<commit_message>
Maksimalkan Sistem Presentasi: prinsip standalone + aturan desain/isi/gambar + deck v3
META: tanamkan prinsip 'setiap sistem self-contained karena akan diunduh jadi repo
standalone' di 00_CARA_KERJA_META.md (dinyatakan pengguna 5 Sep 2026).
MANIFEST: tambah baris prinsip Self-contained/portabel.
SISTEM: dokumen instruksi pertama _sistem/01_ATURAN_DESIGN_ISI_GAMBAR.md (kedalaman
isi, desain, gambar multi-mode M0-M4 + 2 batasan keras, portabilitas, verifikasi).
DECK v3: 14 slide; isi diperdalam (sub-poin, temuan di depan); gambar M3
pola-geometris dipasang PARSIAL sebagai pita kanan (tanpa teks) + DAFTAR_GAMBAR.md.

Co-authored-by: arena-agent <297053741+arena-agent@users.noreply.github.com>
</commit_message>
<xml_diff>
--- a/sistem-presentasi/deck-aktif/presentasi-tesis-fikih-hiasan-wanita/keluaran/presentasi-tesis-fikih-hiasan-wanita.pptx
+++ b/sistem-presentasi/deck-aktif/presentasi-tesis-fikih-hiasan-wanita/keluaran/presentasi-tesis-fikih-hiasan-wanita.pptx
@@ -18,6 +18,7 @@
     <p:sldId id="266" r:id="rId18"/>
     <p:sldId id="267" r:id="rId19"/>
     <p:sldId id="268" r:id="rId20"/>
+    <p:sldId id="269" r:id="rId21"/>
   </p:sldIdLst>
   <p:sldSz cx="12191695" cy="6858000" type="screen4x3"/>
   <p:notesSz cx="6858000" cy="9144000"/>
@@ -514,7 +515,7 @@
           <a:lstStyle/>
           <a:p>
             <a:r>
-              <a:t>Slide pembuka. Nama pembimbing/universitas tidak ada di bahan -&gt; kosong, jangan dikarang.</a:t>
+              <a:t>Pembuka. Pembimbing/universitas kosong (tidak ada di bahan) - jangan dikarang.</a:t>
             </a:r>
           </a:p>
         </p:txBody>
@@ -584,7 +585,7 @@
           <a:lstStyle/>
           <a:p>
             <a:r>
-              <a:t>العلة (hal 66-67). Tabel perbandingan mazhab.</a:t>
+              <a:t>Prosedur hal 89 (Far'2+3+4).</a:t>
             </a:r>
           </a:p>
         </p:txBody>
@@ -654,7 +655,7 @@
           <a:lstStyle/>
           <a:p>
             <a:r>
-              <a:t>Kesimpulan dirangkum dari ملخص hal 6; خاتمة hal 151 = doa.</a:t>
+              <a:t>العلة hal 66-67; tabel perbandingan mazhab.</a:t>
             </a:r>
           </a:p>
         </p:txBody>
@@ -724,7 +725,7 @@
           <a:lstStyle/>
           <a:p>
             <a:r>
-              <a:t>توصيات (hal 152).</a:t>
+              <a:t>Kesimpulan dari ملخص hal 6; خاتمة hal 151 = doa.</a:t>
             </a:r>
           </a:p>
         </p:txBody>
@@ -794,7 +795,77 @@
           <a:lstStyle/>
           <a:p>
             <a:r>
-              <a:t>خاتمة (hal 151) = doa penutup.</a:t>
+              <a:t>توصيات hal 152.</a:t>
+            </a:r>
+          </a:p>
+        </p:txBody>
+      </p:sp>
+      <p:sp>
+        <p:nvSpPr>
+          <p:cNvPr id="4" name="Slide Number Placeholder 3"/>
+          <p:cNvSpPr>
+            <a:spLocks noGrp="1"/>
+          </p:cNvSpPr>
+          <p:nvPr>
+            <p:ph type="sldNum" idx="5" sz="quarter"/>
+          </p:nvPr>
+        </p:nvSpPr>
+        <p:spPr/>
+      </p:sp>
+    </p:spTree>
+  </p:cSld>
+  <p:clrMapOvr>
+    <a:masterClrMapping/>
+  </p:clrMapOvr>
+</p:notes>
+</file>
+
+<file path=ppt/notesSlides/notesSlide14.xml><?xml version="1.0" encoding="utf-8"?>
+<p:notes xmlns:a="http://schemas.openxmlformats.org/drawingml/2006/main" xmlns:p="http://schemas.openxmlformats.org/presentationml/2006/main" xmlns:r="http://schemas.openxmlformats.org/officeDocument/2006/relationships">
+  <p:cSld>
+    <p:spTree>
+      <p:nvGrpSpPr>
+        <p:cNvPr id="1" name=""/>
+        <p:cNvGrpSpPr/>
+        <p:nvPr/>
+      </p:nvGrpSpPr>
+      <p:grpSpPr>
+        <a:xfrm>
+          <a:off x="0" y="0"/>
+          <a:ext cx="0" cy="0"/>
+          <a:chOff x="0" y="0"/>
+          <a:chExt cx="0" cy="0"/>
+        </a:xfrm>
+      </p:grpSpPr>
+      <p:sp>
+        <p:nvSpPr>
+          <p:cNvPr id="2" name="Slide Image Placeholder 1"/>
+          <p:cNvSpPr>
+            <a:spLocks noGrp="1"/>
+          </p:cNvSpPr>
+          <p:nvPr>
+            <p:ph type="sldImg" idx="2"/>
+          </p:nvPr>
+        </p:nvSpPr>
+        <p:spPr/>
+      </p:sp>
+      <p:sp>
+        <p:nvSpPr>
+          <p:cNvPr id="3" name="Notes Placeholder 2"/>
+          <p:cNvSpPr>
+            <a:spLocks noGrp="1"/>
+          </p:cNvSpPr>
+          <p:nvPr>
+            <p:ph type="body" idx="3" sz="quarter"/>
+          </p:nvPr>
+        </p:nvSpPr>
+        <p:spPr/>
+        <p:txBody>
+          <a:bodyPr/>
+          <a:lstStyle/>
+          <a:p>
+            <a:r>
+              <a:t>خاتمة hal 151 = doa penutup.</a:t>
             </a:r>
           </a:p>
         </p:txBody>
@@ -864,7 +935,7 @@
           <a:lstStyle/>
           <a:p>
             <a:r>
-              <a:t>Temuan utama (hal 6): hukum berputar pada tiga illat.</a:t>
+              <a:t>Temuan utama hal 6: tiga illat menjadi poros hukum.</a:t>
             </a:r>
           </a:p>
         </p:txBody>
@@ -934,7 +1005,7 @@
           <a:lstStyle/>
           <a:p>
             <a:r>
-              <a:t>Hal 6: jenis hiasan &amp; ضابط-nya; وصل boleh dengan bukan rambut manusia.</a:t>
+              <a:t>Hal 6: rincian per jenis hiasan dan ضابط-nya.</a:t>
             </a:r>
           </a:p>
         </p:txBody>
@@ -1004,7 +1075,7 @@
           <a:lstStyle/>
           <a:p>
             <a:r>
-              <a:t>Hal 6: operasi boleh bila kebutuhan sah; hiasan memengaruhi pandangan dalam akad nikah.</a:t>
+              <a:t>Hal 6: operasi kecantikan boleh bila kebutuhan sah, tidak mengubah ciptaan.</a:t>
             </a:r>
           </a:p>
         </p:txBody>
@@ -1074,7 +1145,7 @@
           <a:lstStyle/>
           <a:p>
             <a:r>
-              <a:t>Tujuan (hal 21).</a:t>
+              <a:t>Hal 6: hiasan memengaruhi pandangan dalam akad nikah; rincian per mazhab.</a:t>
             </a:r>
           </a:p>
         </p:txBody>
@@ -1144,7 +1215,7 @@
           <a:lstStyle/>
           <a:p>
             <a:r>
-              <a:t>Manfaat (hal 21).</a:t>
+              <a:t>Tujuan hal 21.</a:t>
             </a:r>
           </a:p>
         </p:txBody>
@@ -1214,7 +1285,7 @@
           <a:lstStyle/>
           <a:p>
             <a:r>
-              <a:t>Masalah (hal 21).</a:t>
+              <a:t>Manfaat hal 21.</a:t>
             </a:r>
           </a:p>
         </p:txBody>
@@ -1284,7 +1355,7 @@
           <a:lstStyle/>
           <a:p>
             <a:r>
-              <a:t>Metode (hal 23) + jenis (hal 88) dipadatkan.</a:t>
+              <a:t>Masalah hal 21.</a:t>
             </a:r>
           </a:p>
         </p:txBody>
@@ -1354,7 +1425,7 @@
           <a:lstStyle/>
           <a:p>
             <a:r>
-              <a:t>Prosedur data (hal 89) dipadatkan: Far'2+3+4.</a:t>
+              <a:t>Metode hal 23 + jenis hal 88.</a:t>
             </a:r>
           </a:p>
         </p:txBody>
@@ -4368,49 +4439,30 @@
         <p:nvPr/>
       </p:nvGrpSpPr>
       <p:grpSpPr/>
-      <p:sp>
-        <p:nvSpPr>
-          <p:cNvPr id="2" name="Rectangle 1"/>
-          <p:cNvSpPr/>
-          <p:nvPr/>
-        </p:nvSpPr>
-        <p:spPr>
-          <a:xfrm>
-            <a:off x="11917375" y="0"/>
-            <a:ext cx="274320" cy="6858000"/>
-          </a:xfrm>
-          <a:prstGeom prst="rect">
-            <a:avLst/>
-          </a:prstGeom>
-          <a:solidFill>
-            <a:srgbClr val="0F3D2E"/>
-          </a:solidFill>
-          <a:ln>
-            <a:noFill/>
-          </a:ln>
-        </p:spPr>
-        <p:style>
-          <a:lnRef idx="1">
-            <a:schemeClr val="accent1"/>
-          </a:lnRef>
-          <a:fillRef idx="3">
-            <a:schemeClr val="accent1"/>
-          </a:fillRef>
-          <a:effectRef idx="2">
-            <a:schemeClr val="accent1"/>
-          </a:effectRef>
-          <a:fontRef idx="minor">
-            <a:schemeClr val="lt1"/>
-          </a:fontRef>
-        </p:style>
-        <p:txBody>
-          <a:bodyPr rtlCol="0" anchor="ctr"/>
-          <a:lstStyle/>
-          <a:p>
-            <a:pPr algn="ctr"/>
-          </a:p>
-        </p:txBody>
-      </p:sp>
+      <p:pic>
+        <p:nvPicPr>
+          <p:cNvPr id="2" name="Picture 1" descr="pola-geometris.png"/>
+          <p:cNvPicPr>
+            <a:picLocks noChangeAspect="1"/>
+          </p:cNvPicPr>
+          <p:nvPr/>
+        </p:nvPicPr>
+        <p:blipFill>
+          <a:blip r:embed="rId2"/>
+          <a:stretch>
+            <a:fillRect/>
+          </a:stretch>
+        </p:blipFill>
+        <p:spPr>
+          <a:xfrm>
+            <a:off x="10911535" y="0"/>
+            <a:ext cx="1280160" cy="6858000"/>
+          </a:xfrm>
+          <a:prstGeom prst="rect">
+            <a:avLst/>
+          </a:prstGeom>
+        </p:spPr>
+      </p:pic>
       <p:sp>
         <p:nvSpPr>
           <p:cNvPr id="3" name="Rectangle 2"/>
@@ -4419,7 +4471,7 @@
         </p:nvSpPr>
         <p:spPr>
           <a:xfrm>
-            <a:off x="11862511" y="0"/>
+            <a:off x="10856671" y="0"/>
             <a:ext cx="54864" cy="6858000"/>
           </a:xfrm>
           <a:prstGeom prst="rect">
@@ -4542,8 +4594,8 @@
         </p:nvSpPr>
         <p:spPr>
           <a:xfrm>
-            <a:off x="9448495" y="6400800"/>
-            <a:ext cx="2194560" cy="411480"/>
+            <a:off x="9082735" y="6400800"/>
+            <a:ext cx="2377440" cy="411480"/>
           </a:xfrm>
           <a:prstGeom prst="rect">
             <a:avLst/>
@@ -4580,7 +4632,7 @@
         <p:spPr>
           <a:xfrm>
             <a:off x="1097280" y="1828800"/>
-            <a:ext cx="9997135" cy="2377440"/>
+            <a:ext cx="9265615" cy="2377440"/>
           </a:xfrm>
           <a:prstGeom prst="rect">
             <a:avLst/>
@@ -4602,7 +4654,7 @@
               </a:spcAft>
             </a:pPr>
             <a:r>
-              <a:rPr sz="4000" b="1">
+              <a:rPr sz="3800" b="1">
                 <a:solidFill>
                   <a:srgbClr val="0F3D2E"/>
                 </a:solidFill>
@@ -4645,7 +4697,7 @@
         <p:spPr>
           <a:xfrm>
             <a:off x="914400" y="1554480"/>
-            <a:ext cx="10362895" cy="3108960"/>
+            <a:ext cx="9448495" cy="3108960"/>
           </a:xfrm>
           <a:prstGeom prst="rect">
             <a:avLst/>
@@ -4705,49 +4757,30 @@
         <p:nvPr/>
       </p:nvGrpSpPr>
       <p:grpSpPr/>
-      <p:sp>
-        <p:nvSpPr>
-          <p:cNvPr id="2" name="Rectangle 1"/>
-          <p:cNvSpPr/>
-          <p:nvPr/>
-        </p:nvSpPr>
-        <p:spPr>
-          <a:xfrm>
-            <a:off x="11917375" y="0"/>
-            <a:ext cx="274320" cy="6858000"/>
-          </a:xfrm>
-          <a:prstGeom prst="rect">
-            <a:avLst/>
-          </a:prstGeom>
-          <a:solidFill>
-            <a:srgbClr val="0F3D2E"/>
-          </a:solidFill>
-          <a:ln>
-            <a:noFill/>
-          </a:ln>
-        </p:spPr>
-        <p:style>
-          <a:lnRef idx="1">
-            <a:schemeClr val="accent1"/>
-          </a:lnRef>
-          <a:fillRef idx="3">
-            <a:schemeClr val="accent1"/>
-          </a:fillRef>
-          <a:effectRef idx="2">
-            <a:schemeClr val="accent1"/>
-          </a:effectRef>
-          <a:fontRef idx="minor">
-            <a:schemeClr val="lt1"/>
-          </a:fontRef>
-        </p:style>
-        <p:txBody>
-          <a:bodyPr rtlCol="0" anchor="ctr"/>
-          <a:lstStyle/>
-          <a:p>
-            <a:pPr algn="ctr"/>
-          </a:p>
-        </p:txBody>
-      </p:sp>
+      <p:pic>
+        <p:nvPicPr>
+          <p:cNvPr id="2" name="Picture 1" descr="pola-geometris.png"/>
+          <p:cNvPicPr>
+            <a:picLocks noChangeAspect="1"/>
+          </p:cNvPicPr>
+          <p:nvPr/>
+        </p:nvPicPr>
+        <p:blipFill>
+          <a:blip r:embed="rId2"/>
+          <a:stretch>
+            <a:fillRect/>
+          </a:stretch>
+        </p:blipFill>
+        <p:spPr>
+          <a:xfrm>
+            <a:off x="11368735" y="0"/>
+            <a:ext cx="822960" cy="6858000"/>
+          </a:xfrm>
+          <a:prstGeom prst="rect">
+            <a:avLst/>
+          </a:prstGeom>
+        </p:spPr>
+      </p:pic>
       <p:sp>
         <p:nvSpPr>
           <p:cNvPr id="3" name="Rectangle 2"/>
@@ -4756,7 +4789,7 @@
         </p:nvSpPr>
         <p:spPr>
           <a:xfrm>
-            <a:off x="11862511" y="0"/>
+            <a:off x="11313871" y="0"/>
             <a:ext cx="54864" cy="6858000"/>
           </a:xfrm>
           <a:prstGeom prst="rect">
@@ -4879,8 +4912,391 @@
         </p:nvSpPr>
         <p:spPr>
           <a:xfrm>
-            <a:off x="9448495" y="6400800"/>
-            <a:ext cx="2194560" cy="411480"/>
+            <a:off x="9082735" y="6400800"/>
+            <a:ext cx="2377440" cy="411480"/>
+          </a:xfrm>
+          <a:prstGeom prst="rect">
+            <a:avLst/>
+          </a:prstGeom>
+          <a:noFill/>
+        </p:spPr>
+        <p:txBody>
+          <a:bodyPr wrap="none">
+            <a:spAutoFit/>
+          </a:bodyPr>
+          <a:lstStyle/>
+          <a:p>
+            <a:pPr algn="r"/>
+            <a:r>
+              <a:rPr sz="1400" b="0">
+                <a:solidFill>
+                  <a:srgbClr val="C9A227"/>
+                </a:solidFill>
+                <a:latin typeface="Amiri"/>
+                <a:ea typeface="Amiri"/>
+                <a:cs typeface="Amiri"/>
+              </a:rPr>
+              <a:t>ص٨٩</a:t>
+            </a:r>
+          </a:p>
+        </p:txBody>
+      </p:sp>
+      <p:sp>
+        <p:nvSpPr>
+          <p:cNvPr id="7" name="TextBox 6"/>
+          <p:cNvSpPr txBox="1"/>
+          <p:nvPr/>
+        </p:nvSpPr>
+        <p:spPr>
+          <a:xfrm>
+            <a:off x="640080" y="411480"/>
+            <a:ext cx="10180015" cy="1280160"/>
+          </a:xfrm>
+          <a:prstGeom prst="rect">
+            <a:avLst/>
+          </a:prstGeom>
+          <a:noFill/>
+        </p:spPr>
+        <p:txBody>
+          <a:bodyPr wrap="square">
+            <a:spAutoFit/>
+          </a:bodyPr>
+          <a:lstStyle/>
+          <a:p>
+            <a:pPr algn="r" rtl="1">
+              <a:lnSpc>
+                <a:spcPct val="115000"/>
+              </a:lnSpc>
+              <a:spcAft>
+                <a:spcPts val="600"/>
+              </a:spcAft>
+            </a:pPr>
+            <a:r>
+              <a:rPr sz="3200" b="1">
+                <a:solidFill>
+                  <a:srgbClr val="0F3D2E"/>
+                </a:solidFill>
+                <a:latin typeface="Amiri"/>
+                <a:ea typeface="Amiri"/>
+                <a:cs typeface="Amiri"/>
+              </a:rPr>
+              <a:t>جمعٌ ومعالجةٌ وتحقق: من التتبّع إلى التطبيق الموثّق</a:t>
+            </a:r>
+          </a:p>
+        </p:txBody>
+      </p:sp>
+      <p:sp>
+        <p:nvSpPr>
+          <p:cNvPr id="8" name="Rectangle 7"/>
+          <p:cNvSpPr/>
+          <p:nvPr/>
+        </p:nvSpPr>
+        <p:spPr>
+          <a:xfrm>
+            <a:off x="5461711" y="1645920"/>
+            <a:ext cx="5852160" cy="54864"/>
+          </a:xfrm>
+          <a:prstGeom prst="rect">
+            <a:avLst/>
+          </a:prstGeom>
+          <a:solidFill>
+            <a:srgbClr val="C9A227"/>
+          </a:solidFill>
+          <a:ln>
+            <a:noFill/>
+          </a:ln>
+        </p:spPr>
+        <p:style>
+          <a:lnRef idx="1">
+            <a:schemeClr val="accent1"/>
+          </a:lnRef>
+          <a:fillRef idx="3">
+            <a:schemeClr val="accent1"/>
+          </a:fillRef>
+          <a:effectRef idx="2">
+            <a:schemeClr val="accent1"/>
+          </a:effectRef>
+          <a:fontRef idx="minor">
+            <a:schemeClr val="lt1"/>
+          </a:fontRef>
+        </p:style>
+        <p:txBody>
+          <a:bodyPr rtlCol="0" anchor="ctr"/>
+          <a:lstStyle/>
+          <a:p>
+            <a:pPr algn="ctr"/>
+          </a:p>
+        </p:txBody>
+      </p:sp>
+      <p:sp>
+        <p:nvSpPr>
+          <p:cNvPr id="9" name="TextBox 8"/>
+          <p:cNvSpPr txBox="1"/>
+          <p:nvPr/>
+        </p:nvSpPr>
+        <p:spPr>
+          <a:xfrm>
+            <a:off x="822960" y="1828800"/>
+            <a:ext cx="10088575" cy="4206240"/>
+          </a:xfrm>
+          <a:prstGeom prst="rect">
+            <a:avLst/>
+          </a:prstGeom>
+          <a:noFill/>
+        </p:spPr>
+        <p:txBody>
+          <a:bodyPr wrap="square" anchor="ctr">
+            <a:spAutoFit/>
+          </a:bodyPr>
+          <a:lstStyle/>
+          <a:p>
+            <a:pPr algn="r" rtl="1">
+              <a:lnSpc>
+                <a:spcPct val="115000"/>
+              </a:lnSpc>
+              <a:spcAft>
+                <a:spcPts val="1400"/>
+              </a:spcAft>
+            </a:pPr>
+            <a:r>
+              <a:rPr sz="2400" b="0">
+                <a:solidFill>
+                  <a:srgbClr val="222222"/>
+                </a:solidFill>
+                <a:latin typeface="Amiri"/>
+                <a:ea typeface="Amiri"/>
+                <a:cs typeface="Amiri"/>
+              </a:rPr>
+              <a:t>جمع: تتبّع أقوال المذاهب وجمع النوازل ثم الترتيب والمقارنة</a:t>
+            </a:r>
+          </a:p>
+          <a:p>
+            <a:pPr algn="r" rtl="1">
+              <a:lnSpc>
+                <a:spcPct val="115000"/>
+              </a:lnSpc>
+              <a:spcAft>
+                <a:spcPts val="1400"/>
+              </a:spcAft>
+            </a:pPr>
+            <a:r>
+              <a:rPr sz="2400" b="0">
+                <a:solidFill>
+                  <a:srgbClr val="222222"/>
+                </a:solidFill>
+                <a:latin typeface="Amiri"/>
+                <a:ea typeface="Amiri"/>
+                <a:cs typeface="Amiri"/>
+              </a:rPr>
+              <a:t>معالجة: مقارنة الأقوال وذكر الأدلة ثم التطبيق على النوازل</a:t>
+            </a:r>
+          </a:p>
+          <a:p>
+            <a:pPr algn="r" rtl="1">
+              <a:lnSpc>
+                <a:spcPct val="115000"/>
+              </a:lnSpc>
+              <a:spcAft>
+                <a:spcPts val="1400"/>
+              </a:spcAft>
+            </a:pPr>
+            <a:r>
+              <a:rPr sz="2400" b="0">
+                <a:solidFill>
+                  <a:srgbClr val="222222"/>
+                </a:solidFill>
+                <a:latin typeface="Amiri"/>
+                <a:ea typeface="Amiri"/>
+                <a:cs typeface="Amiri"/>
+              </a:rPr>
+              <a:t>تحقق: عرض المعلومة على عدة مصادر حتى يتفق المعنى</a:t>
+            </a:r>
+          </a:p>
+        </p:txBody>
+      </p:sp>
+    </p:spTree>
+  </p:cSld>
+  <p:clrMapOvr>
+    <a:masterClrMapping/>
+  </p:clrMapOvr>
+</p:sld>
+</file>
+
+<file path=ppt/slides/slide11.xml><?xml version="1.0" encoding="utf-8"?>
+<p:sld xmlns:a="http://schemas.openxmlformats.org/drawingml/2006/main" xmlns:p="http://schemas.openxmlformats.org/presentationml/2006/main" xmlns:r="http://schemas.openxmlformats.org/officeDocument/2006/relationships">
+  <p:cSld>
+    <p:bg>
+      <p:bgPr>
+        <a:solidFill>
+          <a:srgbClr val="F7F3E9"/>
+        </a:solidFill>
+        <a:effectLst/>
+      </p:bgPr>
+    </p:bg>
+    <p:spTree>
+      <p:nvGrpSpPr>
+        <p:cNvPr id="1" name=""/>
+        <p:cNvGrpSpPr/>
+        <p:nvPr/>
+      </p:nvGrpSpPr>
+      <p:grpSpPr/>
+      <p:pic>
+        <p:nvPicPr>
+          <p:cNvPr id="2" name="Picture 1" descr="pola-geometris.png"/>
+          <p:cNvPicPr>
+            <a:picLocks noChangeAspect="1"/>
+          </p:cNvPicPr>
+          <p:nvPr/>
+        </p:nvPicPr>
+        <p:blipFill>
+          <a:blip r:embed="rId2"/>
+          <a:stretch>
+            <a:fillRect/>
+          </a:stretch>
+        </p:blipFill>
+        <p:spPr>
+          <a:xfrm>
+            <a:off x="11368735" y="0"/>
+            <a:ext cx="822960" cy="6858000"/>
+          </a:xfrm>
+          <a:prstGeom prst="rect">
+            <a:avLst/>
+          </a:prstGeom>
+        </p:spPr>
+      </p:pic>
+      <p:sp>
+        <p:nvSpPr>
+          <p:cNvPr id="3" name="Rectangle 2"/>
+          <p:cNvSpPr/>
+          <p:nvPr/>
+        </p:nvSpPr>
+        <p:spPr>
+          <a:xfrm>
+            <a:off x="11313871" y="0"/>
+            <a:ext cx="54864" cy="6858000"/>
+          </a:xfrm>
+          <a:prstGeom prst="rect">
+            <a:avLst/>
+          </a:prstGeom>
+          <a:solidFill>
+            <a:srgbClr val="C9A227"/>
+          </a:solidFill>
+          <a:ln>
+            <a:noFill/>
+          </a:ln>
+        </p:spPr>
+        <p:style>
+          <a:lnRef idx="1">
+            <a:schemeClr val="accent1"/>
+          </a:lnRef>
+          <a:fillRef idx="3">
+            <a:schemeClr val="accent1"/>
+          </a:fillRef>
+          <a:effectRef idx="2">
+            <a:schemeClr val="accent1"/>
+          </a:effectRef>
+          <a:fontRef idx="minor">
+            <a:schemeClr val="lt1"/>
+          </a:fontRef>
+        </p:style>
+        <p:txBody>
+          <a:bodyPr rtlCol="0" anchor="ctr"/>
+          <a:lstStyle/>
+          <a:p>
+            <a:pPr algn="ctr"/>
+          </a:p>
+        </p:txBody>
+      </p:sp>
+      <p:sp>
+        <p:nvSpPr>
+          <p:cNvPr id="4" name="Rectangle 3"/>
+          <p:cNvSpPr/>
+          <p:nvPr/>
+        </p:nvSpPr>
+        <p:spPr>
+          <a:xfrm>
+            <a:off x="0" y="6355080"/>
+            <a:ext cx="12191695" cy="502920"/>
+          </a:xfrm>
+          <a:prstGeom prst="rect">
+            <a:avLst/>
+          </a:prstGeom>
+          <a:solidFill>
+            <a:srgbClr val="0F3D2E"/>
+          </a:solidFill>
+          <a:ln>
+            <a:noFill/>
+          </a:ln>
+        </p:spPr>
+        <p:style>
+          <a:lnRef idx="1">
+            <a:schemeClr val="accent1"/>
+          </a:lnRef>
+          <a:fillRef idx="3">
+            <a:schemeClr val="accent1"/>
+          </a:fillRef>
+          <a:effectRef idx="2">
+            <a:schemeClr val="accent1"/>
+          </a:effectRef>
+          <a:fontRef idx="minor">
+            <a:schemeClr val="lt1"/>
+          </a:fontRef>
+        </p:style>
+        <p:txBody>
+          <a:bodyPr rtlCol="0" anchor="ctr"/>
+          <a:lstStyle/>
+          <a:p>
+            <a:pPr algn="ctr"/>
+          </a:p>
+        </p:txBody>
+      </p:sp>
+      <p:sp>
+        <p:nvSpPr>
+          <p:cNvPr id="5" name="TextBox 4"/>
+          <p:cNvSpPr txBox="1"/>
+          <p:nvPr/>
+        </p:nvSpPr>
+        <p:spPr>
+          <a:xfrm>
+            <a:off x="457200" y="6400800"/>
+            <a:ext cx="1828800" cy="411480"/>
+          </a:xfrm>
+          <a:prstGeom prst="rect">
+            <a:avLst/>
+          </a:prstGeom>
+          <a:noFill/>
+        </p:spPr>
+        <p:txBody>
+          <a:bodyPr wrap="none">
+            <a:spAutoFit/>
+          </a:bodyPr>
+          <a:lstStyle/>
+          <a:p>
+            <a:pPr algn="l"/>
+            <a:r>
+              <a:rPr sz="1600" b="1">
+                <a:solidFill>
+                  <a:srgbClr val="C9A227"/>
+                </a:solidFill>
+                <a:latin typeface="Amiri"/>
+                <a:ea typeface="Amiri"/>
+                <a:cs typeface="Amiri"/>
+              </a:rPr>
+              <a:t>١١</a:t>
+            </a:r>
+          </a:p>
+        </p:txBody>
+      </p:sp>
+      <p:sp>
+        <p:nvSpPr>
+          <p:cNvPr id="6" name="TextBox 5"/>
+          <p:cNvSpPr txBox="1"/>
+          <p:nvPr/>
+        </p:nvSpPr>
+        <p:spPr>
+          <a:xfrm>
+            <a:off x="9082735" y="6400800"/>
+            <a:ext cx="2377440" cy="411480"/>
           </a:xfrm>
           <a:prstGeom prst="rect">
             <a:avLst/>
@@ -4917,7 +5333,7 @@
         <p:spPr>
           <a:xfrm>
             <a:off x="640080" y="411480"/>
-            <a:ext cx="10728655" cy="1188720"/>
+            <a:ext cx="10180015" cy="1280160"/>
           </a:xfrm>
           <a:prstGeom prst="rect">
             <a:avLst/>
@@ -4939,7 +5355,7 @@
               </a:spcAft>
             </a:pPr>
             <a:r>
-              <a:rPr sz="3400" b="1">
+              <a:rPr sz="3200" b="1">
                 <a:solidFill>
                   <a:srgbClr val="0F3D2E"/>
                 </a:solidFill>
@@ -4960,7 +5376,7 @@
         </p:nvSpPr>
         <p:spPr>
           <a:xfrm>
-            <a:off x="6010351" y="1600200"/>
+            <a:off x="5461711" y="1645920"/>
             <a:ext cx="5852160" cy="54864"/>
           </a:xfrm>
           <a:prstGeom prst="rect">
@@ -5005,7 +5421,7 @@
         </p:nvGraphicFramePr>
         <p:xfrm>
           <a:off x="1005840" y="1920240"/>
-          <a:ext cx="9814255" cy="3931920"/>
+          <a:ext cx="9082735" cy="3931920"/>
         </p:xfrm>
         <a:graphic>
           <a:graphicData uri="http://schemas.openxmlformats.org/drawingml/2006/table">
@@ -5014,8 +5430,8 @@
                 <a:tableStyleId>{5C22544A-7EE6-4342-B048-85BDC9FD1C3A}</a:tableStyleId>
               </a:tblPr>
               <a:tblGrid>
-                <a:gridCol w="2926080"/>
-                <a:gridCol w="6888175"/>
+                <a:gridCol w="2743200"/>
+                <a:gridCol w="6339535"/>
               </a:tblGrid>
               <a:tr h="655320">
                 <a:tc>
@@ -5025,7 +5441,7 @@
                     <a:p>
                       <a:pPr algn="r" rtl="1"/>
                       <a:r>
-                        <a:rPr sz="2200" b="1">
+                        <a:rPr sz="2000" b="1">
                           <a:solidFill>
                             <a:srgbClr val="F7F3E9"/>
                           </a:solidFill>
@@ -5050,7 +5466,7 @@
                     <a:p>
                       <a:pPr algn="r" rtl="1"/>
                       <a:r>
-                        <a:rPr sz="2200" b="1">
+                        <a:rPr sz="2000" b="1">
                           <a:solidFill>
                             <a:srgbClr val="F7F3E9"/>
                           </a:solidFill>
@@ -5077,7 +5493,7 @@
                     <a:p>
                       <a:pPr algn="r" rtl="1"/>
                       <a:r>
-                        <a:rPr sz="2000" b="0">
+                        <a:rPr sz="1800" b="0">
                           <a:latin typeface="Amiri"/>
                           <a:ea typeface="Amiri"/>
                           <a:cs typeface="Amiri"/>
@@ -5099,7 +5515,7 @@
                     <a:p>
                       <a:pPr algn="r" rtl="1"/>
                       <a:r>
-                        <a:rPr sz="2000" b="0">
+                        <a:rPr sz="1800" b="0">
                           <a:latin typeface="Amiri"/>
                           <a:ea typeface="Amiri"/>
                           <a:cs typeface="Amiri"/>
@@ -5123,7 +5539,7 @@
                     <a:p>
                       <a:pPr algn="r" rtl="1"/>
                       <a:r>
-                        <a:rPr sz="2000" b="0">
+                        <a:rPr sz="1800" b="0">
                           <a:latin typeface="Amiri"/>
                           <a:ea typeface="Amiri"/>
                           <a:cs typeface="Amiri"/>
@@ -5145,7 +5561,7 @@
                     <a:p>
                       <a:pPr algn="r" rtl="1"/>
                       <a:r>
-                        <a:rPr sz="2000" b="0">
+                        <a:rPr sz="1800" b="0">
                           <a:latin typeface="Amiri"/>
                           <a:ea typeface="Amiri"/>
                           <a:cs typeface="Amiri"/>
@@ -5169,7 +5585,7 @@
                     <a:p>
                       <a:pPr algn="r" rtl="1"/>
                       <a:r>
-                        <a:rPr sz="2000" b="0">
+                        <a:rPr sz="1800" b="0">
                           <a:latin typeface="Amiri"/>
                           <a:ea typeface="Amiri"/>
                           <a:cs typeface="Amiri"/>
@@ -5191,7 +5607,7 @@
                     <a:p>
                       <a:pPr algn="r" rtl="1"/>
                       <a:r>
-                        <a:rPr sz="2000" b="0">
+                        <a:rPr sz="1800" b="0">
                           <a:latin typeface="Amiri"/>
                           <a:ea typeface="Amiri"/>
                           <a:cs typeface="Amiri"/>
@@ -5215,7 +5631,7 @@
                     <a:p>
                       <a:pPr algn="r" rtl="1"/>
                       <a:r>
-                        <a:rPr sz="2000" b="0">
+                        <a:rPr sz="1800" b="0">
                           <a:latin typeface="Amiri"/>
                           <a:ea typeface="Amiri"/>
                           <a:cs typeface="Amiri"/>
@@ -5237,7 +5653,7 @@
                     <a:p>
                       <a:pPr algn="r" rtl="1"/>
                       <a:r>
-                        <a:rPr sz="2000" b="0">
+                        <a:rPr sz="1800" b="0">
                           <a:latin typeface="Amiri"/>
                           <a:ea typeface="Amiri"/>
                           <a:cs typeface="Amiri"/>
@@ -5261,7 +5677,7 @@
                     <a:p>
                       <a:pPr algn="r" rtl="1"/>
                       <a:r>
-                        <a:rPr sz="2000" b="0">
+                        <a:rPr sz="1800" b="0">
                           <a:latin typeface="Amiri"/>
                           <a:ea typeface="Amiri"/>
                           <a:cs typeface="Amiri"/>
@@ -5283,7 +5699,7 @@
                     <a:p>
                       <a:pPr algn="r" rtl="1"/>
                       <a:r>
-                        <a:rPr sz="2000" b="0">
+                        <a:rPr sz="1800" b="0">
                           <a:latin typeface="Amiri"/>
                           <a:ea typeface="Amiri"/>
                           <a:cs typeface="Amiri"/>
@@ -5311,408 +5727,6 @@
 </p:sld>
 </file>
 
-<file path=ppt/slides/slide11.xml><?xml version="1.0" encoding="utf-8"?>
-<p:sld xmlns:a="http://schemas.openxmlformats.org/drawingml/2006/main" xmlns:p="http://schemas.openxmlformats.org/presentationml/2006/main" xmlns:r="http://schemas.openxmlformats.org/officeDocument/2006/relationships">
-  <p:cSld>
-    <p:bg>
-      <p:bgPr>
-        <a:solidFill>
-          <a:srgbClr val="F7F3E9"/>
-        </a:solidFill>
-        <a:effectLst/>
-      </p:bgPr>
-    </p:bg>
-    <p:spTree>
-      <p:nvGrpSpPr>
-        <p:cNvPr id="1" name=""/>
-        <p:cNvGrpSpPr/>
-        <p:nvPr/>
-      </p:nvGrpSpPr>
-      <p:grpSpPr/>
-      <p:sp>
-        <p:nvSpPr>
-          <p:cNvPr id="2" name="Rectangle 1"/>
-          <p:cNvSpPr/>
-          <p:nvPr/>
-        </p:nvSpPr>
-        <p:spPr>
-          <a:xfrm>
-            <a:off x="11917375" y="0"/>
-            <a:ext cx="274320" cy="6858000"/>
-          </a:xfrm>
-          <a:prstGeom prst="rect">
-            <a:avLst/>
-          </a:prstGeom>
-          <a:solidFill>
-            <a:srgbClr val="0F3D2E"/>
-          </a:solidFill>
-          <a:ln>
-            <a:noFill/>
-          </a:ln>
-        </p:spPr>
-        <p:style>
-          <a:lnRef idx="1">
-            <a:schemeClr val="accent1"/>
-          </a:lnRef>
-          <a:fillRef idx="3">
-            <a:schemeClr val="accent1"/>
-          </a:fillRef>
-          <a:effectRef idx="2">
-            <a:schemeClr val="accent1"/>
-          </a:effectRef>
-          <a:fontRef idx="minor">
-            <a:schemeClr val="lt1"/>
-          </a:fontRef>
-        </p:style>
-        <p:txBody>
-          <a:bodyPr rtlCol="0" anchor="ctr"/>
-          <a:lstStyle/>
-          <a:p>
-            <a:pPr algn="ctr"/>
-          </a:p>
-        </p:txBody>
-      </p:sp>
-      <p:sp>
-        <p:nvSpPr>
-          <p:cNvPr id="3" name="Rectangle 2"/>
-          <p:cNvSpPr/>
-          <p:nvPr/>
-        </p:nvSpPr>
-        <p:spPr>
-          <a:xfrm>
-            <a:off x="11862511" y="0"/>
-            <a:ext cx="54864" cy="6858000"/>
-          </a:xfrm>
-          <a:prstGeom prst="rect">
-            <a:avLst/>
-          </a:prstGeom>
-          <a:solidFill>
-            <a:srgbClr val="C9A227"/>
-          </a:solidFill>
-          <a:ln>
-            <a:noFill/>
-          </a:ln>
-        </p:spPr>
-        <p:style>
-          <a:lnRef idx="1">
-            <a:schemeClr val="accent1"/>
-          </a:lnRef>
-          <a:fillRef idx="3">
-            <a:schemeClr val="accent1"/>
-          </a:fillRef>
-          <a:effectRef idx="2">
-            <a:schemeClr val="accent1"/>
-          </a:effectRef>
-          <a:fontRef idx="minor">
-            <a:schemeClr val="lt1"/>
-          </a:fontRef>
-        </p:style>
-        <p:txBody>
-          <a:bodyPr rtlCol="0" anchor="ctr"/>
-          <a:lstStyle/>
-          <a:p>
-            <a:pPr algn="ctr"/>
-          </a:p>
-        </p:txBody>
-      </p:sp>
-      <p:sp>
-        <p:nvSpPr>
-          <p:cNvPr id="4" name="Rectangle 3"/>
-          <p:cNvSpPr/>
-          <p:nvPr/>
-        </p:nvSpPr>
-        <p:spPr>
-          <a:xfrm>
-            <a:off x="0" y="6355080"/>
-            <a:ext cx="12191695" cy="502920"/>
-          </a:xfrm>
-          <a:prstGeom prst="rect">
-            <a:avLst/>
-          </a:prstGeom>
-          <a:solidFill>
-            <a:srgbClr val="0F3D2E"/>
-          </a:solidFill>
-          <a:ln>
-            <a:noFill/>
-          </a:ln>
-        </p:spPr>
-        <p:style>
-          <a:lnRef idx="1">
-            <a:schemeClr val="accent1"/>
-          </a:lnRef>
-          <a:fillRef idx="3">
-            <a:schemeClr val="accent1"/>
-          </a:fillRef>
-          <a:effectRef idx="2">
-            <a:schemeClr val="accent1"/>
-          </a:effectRef>
-          <a:fontRef idx="minor">
-            <a:schemeClr val="lt1"/>
-          </a:fontRef>
-        </p:style>
-        <p:txBody>
-          <a:bodyPr rtlCol="0" anchor="ctr"/>
-          <a:lstStyle/>
-          <a:p>
-            <a:pPr algn="ctr"/>
-          </a:p>
-        </p:txBody>
-      </p:sp>
-      <p:sp>
-        <p:nvSpPr>
-          <p:cNvPr id="5" name="TextBox 4"/>
-          <p:cNvSpPr txBox="1"/>
-          <p:nvPr/>
-        </p:nvSpPr>
-        <p:spPr>
-          <a:xfrm>
-            <a:off x="457200" y="6400800"/>
-            <a:ext cx="1828800" cy="411480"/>
-          </a:xfrm>
-          <a:prstGeom prst="rect">
-            <a:avLst/>
-          </a:prstGeom>
-          <a:noFill/>
-        </p:spPr>
-        <p:txBody>
-          <a:bodyPr wrap="none">
-            <a:spAutoFit/>
-          </a:bodyPr>
-          <a:lstStyle/>
-          <a:p>
-            <a:pPr algn="l"/>
-            <a:r>
-              <a:rPr sz="1600" b="1">
-                <a:solidFill>
-                  <a:srgbClr val="C9A227"/>
-                </a:solidFill>
-                <a:latin typeface="Amiri"/>
-                <a:ea typeface="Amiri"/>
-                <a:cs typeface="Amiri"/>
-              </a:rPr>
-              <a:t>١١</a:t>
-            </a:r>
-          </a:p>
-        </p:txBody>
-      </p:sp>
-      <p:sp>
-        <p:nvSpPr>
-          <p:cNvPr id="6" name="TextBox 5"/>
-          <p:cNvSpPr txBox="1"/>
-          <p:nvPr/>
-        </p:nvSpPr>
-        <p:spPr>
-          <a:xfrm>
-            <a:off x="9448495" y="6400800"/>
-            <a:ext cx="2194560" cy="411480"/>
-          </a:xfrm>
-          <a:prstGeom prst="rect">
-            <a:avLst/>
-          </a:prstGeom>
-          <a:noFill/>
-        </p:spPr>
-        <p:txBody>
-          <a:bodyPr wrap="none">
-            <a:spAutoFit/>
-          </a:bodyPr>
-          <a:lstStyle/>
-          <a:p>
-            <a:pPr algn="r"/>
-            <a:r>
-              <a:rPr sz="1400" b="0">
-                <a:solidFill>
-                  <a:srgbClr val="C9A227"/>
-                </a:solidFill>
-                <a:latin typeface="Amiri"/>
-                <a:ea typeface="Amiri"/>
-                <a:cs typeface="Amiri"/>
-              </a:rPr>
-              <a:t>ص٦</a:t>
-            </a:r>
-          </a:p>
-        </p:txBody>
-      </p:sp>
-      <p:sp>
-        <p:nvSpPr>
-          <p:cNvPr id="7" name="TextBox 6"/>
-          <p:cNvSpPr txBox="1"/>
-          <p:nvPr/>
-        </p:nvSpPr>
-        <p:spPr>
-          <a:xfrm>
-            <a:off x="640080" y="411480"/>
-            <a:ext cx="10728655" cy="1188720"/>
-          </a:xfrm>
-          <a:prstGeom prst="rect">
-            <a:avLst/>
-          </a:prstGeom>
-          <a:noFill/>
-        </p:spPr>
-        <p:txBody>
-          <a:bodyPr wrap="square">
-            <a:spAutoFit/>
-          </a:bodyPr>
-          <a:lstStyle/>
-          <a:p>
-            <a:pPr algn="r" rtl="1">
-              <a:lnSpc>
-                <a:spcPct val="115000"/>
-              </a:lnSpc>
-              <a:spcAft>
-                <a:spcPts val="600"/>
-              </a:spcAft>
-            </a:pPr>
-            <a:r>
-              <a:rPr sz="3400" b="1">
-                <a:solidFill>
-                  <a:srgbClr val="0F3D2E"/>
-                </a:solidFill>
-                <a:latin typeface="Amiri"/>
-                <a:ea typeface="Amiri"/>
-                <a:cs typeface="Amiri"/>
-              </a:rPr>
-              <a:t>الخلاصة: التحريم عند العلل الثلاث، والجواز بضوابط، وللزينة أثر في النكاح</a:t>
-            </a:r>
-          </a:p>
-        </p:txBody>
-      </p:sp>
-      <p:sp>
-        <p:nvSpPr>
-          <p:cNvPr id="8" name="Rectangle 7"/>
-          <p:cNvSpPr/>
-          <p:nvPr/>
-        </p:nvSpPr>
-        <p:spPr>
-          <a:xfrm>
-            <a:off x="6010351" y="1600200"/>
-            <a:ext cx="5852160" cy="54864"/>
-          </a:xfrm>
-          <a:prstGeom prst="rect">
-            <a:avLst/>
-          </a:prstGeom>
-          <a:solidFill>
-            <a:srgbClr val="C9A227"/>
-          </a:solidFill>
-          <a:ln>
-            <a:noFill/>
-          </a:ln>
-        </p:spPr>
-        <p:style>
-          <a:lnRef idx="1">
-            <a:schemeClr val="accent1"/>
-          </a:lnRef>
-          <a:fillRef idx="3">
-            <a:schemeClr val="accent1"/>
-          </a:fillRef>
-          <a:effectRef idx="2">
-            <a:schemeClr val="accent1"/>
-          </a:effectRef>
-          <a:fontRef idx="minor">
-            <a:schemeClr val="lt1"/>
-          </a:fontRef>
-        </p:style>
-        <p:txBody>
-          <a:bodyPr rtlCol="0" anchor="ctr"/>
-          <a:lstStyle/>
-          <a:p>
-            <a:pPr algn="ctr"/>
-          </a:p>
-        </p:txBody>
-      </p:sp>
-      <p:sp>
-        <p:nvSpPr>
-          <p:cNvPr id="9" name="TextBox 8"/>
-          <p:cNvSpPr txBox="1"/>
-          <p:nvPr/>
-        </p:nvSpPr>
-        <p:spPr>
-          <a:xfrm>
-            <a:off x="822960" y="1920240"/>
-            <a:ext cx="10362895" cy="4114800"/>
-          </a:xfrm>
-          <a:prstGeom prst="rect">
-            <a:avLst/>
-          </a:prstGeom>
-          <a:noFill/>
-        </p:spPr>
-        <p:txBody>
-          <a:bodyPr wrap="square" anchor="ctr">
-            <a:spAutoFit/>
-          </a:bodyPr>
-          <a:lstStyle/>
-          <a:p>
-            <a:pPr algn="r" rtl="1">
-              <a:lnSpc>
-                <a:spcPct val="120000"/>
-              </a:lnSpc>
-              <a:spcAft>
-                <a:spcPts val="1800"/>
-              </a:spcAft>
-            </a:pPr>
-            <a:r>
-              <a:rPr sz="2600" b="0">
-                <a:solidFill>
-                  <a:srgbClr val="222222"/>
-                </a:solidFill>
-                <a:latin typeface="Amiri"/>
-                <a:ea typeface="Amiri"/>
-                <a:cs typeface="Amiri"/>
-              </a:rPr>
-              <a:t>التحريم عند تغيير الخلق أو التدليس أو الضرر</a:t>
-            </a:r>
-          </a:p>
-          <a:p>
-            <a:pPr algn="r" rtl="1">
-              <a:lnSpc>
-                <a:spcPct val="120000"/>
-              </a:lnSpc>
-              <a:spcAft>
-                <a:spcPts val="1800"/>
-              </a:spcAft>
-            </a:pPr>
-            <a:r>
-              <a:rPr sz="2600" b="0">
-                <a:solidFill>
-                  <a:srgbClr val="222222"/>
-                </a:solidFill>
-                <a:latin typeface="Amiri"/>
-                <a:ea typeface="Amiri"/>
-                <a:cs typeface="Amiri"/>
-              </a:rPr>
-              <a:t>جواز العمليات والوصل بغير الآدمي بضوابطها</a:t>
-            </a:r>
-          </a:p>
-          <a:p>
-            <a:pPr algn="r" rtl="1">
-              <a:lnSpc>
-                <a:spcPct val="120000"/>
-              </a:lnSpc>
-              <a:spcAft>
-                <a:spcPts val="1800"/>
-              </a:spcAft>
-            </a:pPr>
-            <a:r>
-              <a:rPr sz="2600" b="0">
-                <a:solidFill>
-                  <a:srgbClr val="222222"/>
-                </a:solidFill>
-                <a:latin typeface="Amiri"/>
-                <a:ea typeface="Amiri"/>
-                <a:cs typeface="Amiri"/>
-              </a:rPr>
-              <a:t>ترتيب أثر الزينة على النظر في عقد النكاح</a:t>
-            </a:r>
-          </a:p>
-        </p:txBody>
-      </p:sp>
-    </p:spTree>
-  </p:cSld>
-  <p:clrMapOvr>
-    <a:masterClrMapping/>
-  </p:clrMapOvr>
-</p:sld>
-</file>
-
 <file path=ppt/slides/slide12.xml><?xml version="1.0" encoding="utf-8"?>
 <p:sld xmlns:a="http://schemas.openxmlformats.org/drawingml/2006/main" xmlns:p="http://schemas.openxmlformats.org/presentationml/2006/main" xmlns:r="http://schemas.openxmlformats.org/officeDocument/2006/relationships">
   <p:cSld>
@@ -5731,49 +5745,30 @@
         <p:nvPr/>
       </p:nvGrpSpPr>
       <p:grpSpPr/>
-      <p:sp>
-        <p:nvSpPr>
-          <p:cNvPr id="2" name="Rectangle 1"/>
-          <p:cNvSpPr/>
-          <p:nvPr/>
-        </p:nvSpPr>
-        <p:spPr>
-          <a:xfrm>
-            <a:off x="11917375" y="0"/>
-            <a:ext cx="274320" cy="6858000"/>
-          </a:xfrm>
-          <a:prstGeom prst="rect">
-            <a:avLst/>
-          </a:prstGeom>
-          <a:solidFill>
-            <a:srgbClr val="0F3D2E"/>
-          </a:solidFill>
-          <a:ln>
-            <a:noFill/>
-          </a:ln>
-        </p:spPr>
-        <p:style>
-          <a:lnRef idx="1">
-            <a:schemeClr val="accent1"/>
-          </a:lnRef>
-          <a:fillRef idx="3">
-            <a:schemeClr val="accent1"/>
-          </a:fillRef>
-          <a:effectRef idx="2">
-            <a:schemeClr val="accent1"/>
-          </a:effectRef>
-          <a:fontRef idx="minor">
-            <a:schemeClr val="lt1"/>
-          </a:fontRef>
-        </p:style>
-        <p:txBody>
-          <a:bodyPr rtlCol="0" anchor="ctr"/>
-          <a:lstStyle/>
-          <a:p>
-            <a:pPr algn="ctr"/>
-          </a:p>
-        </p:txBody>
-      </p:sp>
+      <p:pic>
+        <p:nvPicPr>
+          <p:cNvPr id="2" name="Picture 1" descr="pola-geometris.png"/>
+          <p:cNvPicPr>
+            <a:picLocks noChangeAspect="1"/>
+          </p:cNvPicPr>
+          <p:nvPr/>
+        </p:nvPicPr>
+        <p:blipFill>
+          <a:blip r:embed="rId2"/>
+          <a:stretch>
+            <a:fillRect/>
+          </a:stretch>
+        </p:blipFill>
+        <p:spPr>
+          <a:xfrm>
+            <a:off x="11368735" y="0"/>
+            <a:ext cx="822960" cy="6858000"/>
+          </a:xfrm>
+          <a:prstGeom prst="rect">
+            <a:avLst/>
+          </a:prstGeom>
+        </p:spPr>
+      </p:pic>
       <p:sp>
         <p:nvSpPr>
           <p:cNvPr id="3" name="Rectangle 2"/>
@@ -5782,7 +5777,7 @@
         </p:nvSpPr>
         <p:spPr>
           <a:xfrm>
-            <a:off x="11862511" y="0"/>
+            <a:off x="11313871" y="0"/>
             <a:ext cx="54864" cy="6858000"/>
           </a:xfrm>
           <a:prstGeom prst="rect">
@@ -5905,8 +5900,8 @@
         </p:nvSpPr>
         <p:spPr>
           <a:xfrm>
-            <a:off x="9448495" y="6400800"/>
-            <a:ext cx="2194560" cy="411480"/>
+            <a:off x="9082735" y="6400800"/>
+            <a:ext cx="2377440" cy="411480"/>
           </a:xfrm>
           <a:prstGeom prst="rect">
             <a:avLst/>
@@ -5929,7 +5924,7 @@
                 <a:ea typeface="Amiri"/>
                 <a:cs typeface="Amiri"/>
               </a:rPr>
-              <a:t>ص١٥٢</a:t>
+              <a:t>ص٦</a:t>
             </a:r>
           </a:p>
         </p:txBody>
@@ -5943,7 +5938,7 @@
         <p:spPr>
           <a:xfrm>
             <a:off x="640080" y="411480"/>
-            <a:ext cx="10728655" cy="1188720"/>
+            <a:ext cx="10180015" cy="1280160"/>
           </a:xfrm>
           <a:prstGeom prst="rect">
             <a:avLst/>
@@ -5965,7 +5960,7 @@
               </a:spcAft>
             </a:pPr>
             <a:r>
-              <a:rPr sz="3400" b="1">
+              <a:rPr sz="3200" b="1">
                 <a:solidFill>
                   <a:srgbClr val="0F3D2E"/>
                 </a:solidFill>
@@ -5973,7 +5968,7 @@
                 <a:ea typeface="Amiri"/>
                 <a:cs typeface="Amiri"/>
               </a:rPr>
-              <a:t>ثلاث وصايا: للعلماء، للمرأة المسلمة، وللمجامع الفقهية</a:t>
+              <a:t>الخلاصة: التحريم عند العلل الثلاث، والجواز بضوابط، وللزينة أثر في النكاح</a:t>
             </a:r>
           </a:p>
         </p:txBody>
@@ -5986,7 +5981,7 @@
         </p:nvSpPr>
         <p:spPr>
           <a:xfrm>
-            <a:off x="6010351" y="1600200"/>
+            <a:off x="5461711" y="1645920"/>
             <a:ext cx="5852160" cy="54864"/>
           </a:xfrm>
           <a:prstGeom prst="rect">
@@ -6029,8 +6024,8 @@
         </p:nvSpPr>
         <p:spPr>
           <a:xfrm>
-            <a:off x="822960" y="1920240"/>
-            <a:ext cx="10362895" cy="4114800"/>
+            <a:off x="822960" y="1828800"/>
+            <a:ext cx="10088575" cy="4206240"/>
           </a:xfrm>
           <a:prstGeom prst="rect">
             <a:avLst/>
@@ -6045,14 +6040,14 @@
           <a:p>
             <a:pPr algn="r" rtl="1">
               <a:lnSpc>
-                <a:spcPct val="120000"/>
+                <a:spcPct val="115000"/>
               </a:lnSpc>
               <a:spcAft>
-                <a:spcPts val="1800"/>
+                <a:spcPts val="1400"/>
               </a:spcAft>
             </a:pPr>
             <a:r>
-              <a:rPr sz="2600" b="0">
+              <a:rPr sz="2400" b="0">
                 <a:solidFill>
                   <a:srgbClr val="222222"/>
                 </a:solidFill>
@@ -6060,20 +6055,20 @@
                 <a:ea typeface="Amiri"/>
                 <a:cs typeface="Amiri"/>
               </a:rPr>
-              <a:t>للعلماء: دقة البحث وإظهار أحكام النوازل</a:t>
+              <a:t>التحريم عند تغيير الخلق أو التدليس أو الضرر</a:t>
             </a:r>
           </a:p>
           <a:p>
             <a:pPr algn="r" rtl="1">
               <a:lnSpc>
-                <a:spcPct val="120000"/>
+                <a:spcPct val="115000"/>
               </a:lnSpc>
               <a:spcAft>
-                <a:spcPts val="1800"/>
+                <a:spcPts val="1400"/>
               </a:spcAft>
             </a:pPr>
             <a:r>
-              <a:rPr sz="2600" b="0">
+              <a:rPr sz="2400" b="0">
                 <a:solidFill>
                   <a:srgbClr val="222222"/>
                 </a:solidFill>
@@ -6081,20 +6076,20 @@
                 <a:ea typeface="Amiri"/>
                 <a:cs typeface="Amiri"/>
               </a:rPr>
-              <a:t>للمرأة المسلمة: الحذر من المحرم والاكتفاء بالحلال عن علم</a:t>
+              <a:t>جواز العمليات للحاجة، والوصل بغير شعر الآدمي بضوابطها</a:t>
             </a:r>
           </a:p>
           <a:p>
             <a:pPr algn="r" rtl="1">
               <a:lnSpc>
-                <a:spcPct val="120000"/>
+                <a:spcPct val="115000"/>
               </a:lnSpc>
               <a:spcAft>
-                <a:spcPts val="1800"/>
+                <a:spcPts val="1400"/>
               </a:spcAft>
             </a:pPr>
             <a:r>
-              <a:rPr sz="2600" b="0">
+              <a:rPr sz="2400" b="0">
                 <a:solidFill>
                   <a:srgbClr val="222222"/>
                 </a:solidFill>
@@ -6102,7 +6097,7 @@
                 <a:ea typeface="Amiri"/>
                 <a:cs typeface="Amiri"/>
               </a:rPr>
-              <a:t>للمجامع الفقهية: متابعة المستجدات وبيان أحكامها</a:t>
+              <a:t>ترتيب أثر الزينة على النظر في عقد النكاح</a:t>
             </a:r>
           </a:p>
         </p:txBody>
@@ -6133,49 +6128,30 @@
         <p:nvPr/>
       </p:nvGrpSpPr>
       <p:grpSpPr/>
-      <p:sp>
-        <p:nvSpPr>
-          <p:cNvPr id="2" name="Rectangle 1"/>
-          <p:cNvSpPr/>
-          <p:nvPr/>
-        </p:nvSpPr>
-        <p:spPr>
-          <a:xfrm>
-            <a:off x="11917375" y="0"/>
-            <a:ext cx="274320" cy="6858000"/>
-          </a:xfrm>
-          <a:prstGeom prst="rect">
-            <a:avLst/>
-          </a:prstGeom>
-          <a:solidFill>
-            <a:srgbClr val="0F3D2E"/>
-          </a:solidFill>
-          <a:ln>
-            <a:noFill/>
-          </a:ln>
-        </p:spPr>
-        <p:style>
-          <a:lnRef idx="1">
-            <a:schemeClr val="accent1"/>
-          </a:lnRef>
-          <a:fillRef idx="3">
-            <a:schemeClr val="accent1"/>
-          </a:fillRef>
-          <a:effectRef idx="2">
-            <a:schemeClr val="accent1"/>
-          </a:effectRef>
-          <a:fontRef idx="minor">
-            <a:schemeClr val="lt1"/>
-          </a:fontRef>
-        </p:style>
-        <p:txBody>
-          <a:bodyPr rtlCol="0" anchor="ctr"/>
-          <a:lstStyle/>
-          <a:p>
-            <a:pPr algn="ctr"/>
-          </a:p>
-        </p:txBody>
-      </p:sp>
+      <p:pic>
+        <p:nvPicPr>
+          <p:cNvPr id="2" name="Picture 1" descr="pola-geometris.png"/>
+          <p:cNvPicPr>
+            <a:picLocks noChangeAspect="1"/>
+          </p:cNvPicPr>
+          <p:nvPr/>
+        </p:nvPicPr>
+        <p:blipFill>
+          <a:blip r:embed="rId2"/>
+          <a:stretch>
+            <a:fillRect/>
+          </a:stretch>
+        </p:blipFill>
+        <p:spPr>
+          <a:xfrm>
+            <a:off x="11368735" y="0"/>
+            <a:ext cx="822960" cy="6858000"/>
+          </a:xfrm>
+          <a:prstGeom prst="rect">
+            <a:avLst/>
+          </a:prstGeom>
+        </p:spPr>
+      </p:pic>
       <p:sp>
         <p:nvSpPr>
           <p:cNvPr id="3" name="Rectangle 2"/>
@@ -6184,7 +6160,7 @@
         </p:nvSpPr>
         <p:spPr>
           <a:xfrm>
-            <a:off x="11862511" y="0"/>
+            <a:off x="11313871" y="0"/>
             <a:ext cx="54864" cy="6858000"/>
           </a:xfrm>
           <a:prstGeom prst="rect">
@@ -6307,8 +6283,391 @@
         </p:nvSpPr>
         <p:spPr>
           <a:xfrm>
-            <a:off x="9448495" y="6400800"/>
-            <a:ext cx="2194560" cy="411480"/>
+            <a:off x="9082735" y="6400800"/>
+            <a:ext cx="2377440" cy="411480"/>
+          </a:xfrm>
+          <a:prstGeom prst="rect">
+            <a:avLst/>
+          </a:prstGeom>
+          <a:noFill/>
+        </p:spPr>
+        <p:txBody>
+          <a:bodyPr wrap="none">
+            <a:spAutoFit/>
+          </a:bodyPr>
+          <a:lstStyle/>
+          <a:p>
+            <a:pPr algn="r"/>
+            <a:r>
+              <a:rPr sz="1400" b="0">
+                <a:solidFill>
+                  <a:srgbClr val="C9A227"/>
+                </a:solidFill>
+                <a:latin typeface="Amiri"/>
+                <a:ea typeface="Amiri"/>
+                <a:cs typeface="Amiri"/>
+              </a:rPr>
+              <a:t>ص١٥٢</a:t>
+            </a:r>
+          </a:p>
+        </p:txBody>
+      </p:sp>
+      <p:sp>
+        <p:nvSpPr>
+          <p:cNvPr id="7" name="TextBox 6"/>
+          <p:cNvSpPr txBox="1"/>
+          <p:nvPr/>
+        </p:nvSpPr>
+        <p:spPr>
+          <a:xfrm>
+            <a:off x="640080" y="411480"/>
+            <a:ext cx="10180015" cy="1280160"/>
+          </a:xfrm>
+          <a:prstGeom prst="rect">
+            <a:avLst/>
+          </a:prstGeom>
+          <a:noFill/>
+        </p:spPr>
+        <p:txBody>
+          <a:bodyPr wrap="square">
+            <a:spAutoFit/>
+          </a:bodyPr>
+          <a:lstStyle/>
+          <a:p>
+            <a:pPr algn="r" rtl="1">
+              <a:lnSpc>
+                <a:spcPct val="115000"/>
+              </a:lnSpc>
+              <a:spcAft>
+                <a:spcPts val="600"/>
+              </a:spcAft>
+            </a:pPr>
+            <a:r>
+              <a:rPr sz="3200" b="1">
+                <a:solidFill>
+                  <a:srgbClr val="0F3D2E"/>
+                </a:solidFill>
+                <a:latin typeface="Amiri"/>
+                <a:ea typeface="Amiri"/>
+                <a:cs typeface="Amiri"/>
+              </a:rPr>
+              <a:t>ثلاث وصايا: للعلماء، للمرأة المسلمة، وللمجامع الفقهية</a:t>
+            </a:r>
+          </a:p>
+        </p:txBody>
+      </p:sp>
+      <p:sp>
+        <p:nvSpPr>
+          <p:cNvPr id="8" name="Rectangle 7"/>
+          <p:cNvSpPr/>
+          <p:nvPr/>
+        </p:nvSpPr>
+        <p:spPr>
+          <a:xfrm>
+            <a:off x="5461711" y="1645920"/>
+            <a:ext cx="5852160" cy="54864"/>
+          </a:xfrm>
+          <a:prstGeom prst="rect">
+            <a:avLst/>
+          </a:prstGeom>
+          <a:solidFill>
+            <a:srgbClr val="C9A227"/>
+          </a:solidFill>
+          <a:ln>
+            <a:noFill/>
+          </a:ln>
+        </p:spPr>
+        <p:style>
+          <a:lnRef idx="1">
+            <a:schemeClr val="accent1"/>
+          </a:lnRef>
+          <a:fillRef idx="3">
+            <a:schemeClr val="accent1"/>
+          </a:fillRef>
+          <a:effectRef idx="2">
+            <a:schemeClr val="accent1"/>
+          </a:effectRef>
+          <a:fontRef idx="minor">
+            <a:schemeClr val="lt1"/>
+          </a:fontRef>
+        </p:style>
+        <p:txBody>
+          <a:bodyPr rtlCol="0" anchor="ctr"/>
+          <a:lstStyle/>
+          <a:p>
+            <a:pPr algn="ctr"/>
+          </a:p>
+        </p:txBody>
+      </p:sp>
+      <p:sp>
+        <p:nvSpPr>
+          <p:cNvPr id="9" name="TextBox 8"/>
+          <p:cNvSpPr txBox="1"/>
+          <p:nvPr/>
+        </p:nvSpPr>
+        <p:spPr>
+          <a:xfrm>
+            <a:off x="822960" y="1828800"/>
+            <a:ext cx="10088575" cy="4206240"/>
+          </a:xfrm>
+          <a:prstGeom prst="rect">
+            <a:avLst/>
+          </a:prstGeom>
+          <a:noFill/>
+        </p:spPr>
+        <p:txBody>
+          <a:bodyPr wrap="square" anchor="ctr">
+            <a:spAutoFit/>
+          </a:bodyPr>
+          <a:lstStyle/>
+          <a:p>
+            <a:pPr algn="r" rtl="1">
+              <a:lnSpc>
+                <a:spcPct val="115000"/>
+              </a:lnSpc>
+              <a:spcAft>
+                <a:spcPts val="1400"/>
+              </a:spcAft>
+            </a:pPr>
+            <a:r>
+              <a:rPr sz="2400" b="0">
+                <a:solidFill>
+                  <a:srgbClr val="222222"/>
+                </a:solidFill>
+                <a:latin typeface="Amiri"/>
+                <a:ea typeface="Amiri"/>
+                <a:cs typeface="Amiri"/>
+              </a:rPr>
+              <a:t>للعلماء وطلاب العلم: دقة البحث وإظهار أحكام النوازل للمجتمع</a:t>
+            </a:r>
+          </a:p>
+          <a:p>
+            <a:pPr algn="r" rtl="1">
+              <a:lnSpc>
+                <a:spcPct val="115000"/>
+              </a:lnSpc>
+              <a:spcAft>
+                <a:spcPts val="1400"/>
+              </a:spcAft>
+            </a:pPr>
+            <a:r>
+              <a:rPr sz="2400" b="0">
+                <a:solidFill>
+                  <a:srgbClr val="222222"/>
+                </a:solidFill>
+                <a:latin typeface="Amiri"/>
+                <a:ea typeface="Amiri"/>
+                <a:cs typeface="Amiri"/>
+              </a:rPr>
+              <a:t>للمرأة المسلمة: الحذر من الزينة المحرمة والاكتفاء بالحلال عن علم</a:t>
+            </a:r>
+          </a:p>
+          <a:p>
+            <a:pPr algn="r" rtl="1">
+              <a:lnSpc>
+                <a:spcPct val="115000"/>
+              </a:lnSpc>
+              <a:spcAft>
+                <a:spcPts val="1400"/>
+              </a:spcAft>
+            </a:pPr>
+            <a:r>
+              <a:rPr sz="2400" b="0">
+                <a:solidFill>
+                  <a:srgbClr val="222222"/>
+                </a:solidFill>
+                <a:latin typeface="Amiri"/>
+                <a:ea typeface="Amiri"/>
+                <a:cs typeface="Amiri"/>
+              </a:rPr>
+              <a:t>للمجامع الفقهية: متابعة المستجدات في زينة المرأة وبيان أحكامها</a:t>
+            </a:r>
+          </a:p>
+        </p:txBody>
+      </p:sp>
+    </p:spTree>
+  </p:cSld>
+  <p:clrMapOvr>
+    <a:masterClrMapping/>
+  </p:clrMapOvr>
+</p:sld>
+</file>
+
+<file path=ppt/slides/slide14.xml><?xml version="1.0" encoding="utf-8"?>
+<p:sld xmlns:a="http://schemas.openxmlformats.org/drawingml/2006/main" xmlns:p="http://schemas.openxmlformats.org/presentationml/2006/main" xmlns:r="http://schemas.openxmlformats.org/officeDocument/2006/relationships">
+  <p:cSld>
+    <p:bg>
+      <p:bgPr>
+        <a:solidFill>
+          <a:srgbClr val="F7F3E9"/>
+        </a:solidFill>
+        <a:effectLst/>
+      </p:bgPr>
+    </p:bg>
+    <p:spTree>
+      <p:nvGrpSpPr>
+        <p:cNvPr id="1" name=""/>
+        <p:cNvGrpSpPr/>
+        <p:nvPr/>
+      </p:nvGrpSpPr>
+      <p:grpSpPr/>
+      <p:pic>
+        <p:nvPicPr>
+          <p:cNvPr id="2" name="Picture 1" descr="pola-geometris.png"/>
+          <p:cNvPicPr>
+            <a:picLocks noChangeAspect="1"/>
+          </p:cNvPicPr>
+          <p:nvPr/>
+        </p:nvPicPr>
+        <p:blipFill>
+          <a:blip r:embed="rId2"/>
+          <a:stretch>
+            <a:fillRect/>
+          </a:stretch>
+        </p:blipFill>
+        <p:spPr>
+          <a:xfrm>
+            <a:off x="11368735" y="0"/>
+            <a:ext cx="822960" cy="6858000"/>
+          </a:xfrm>
+          <a:prstGeom prst="rect">
+            <a:avLst/>
+          </a:prstGeom>
+        </p:spPr>
+      </p:pic>
+      <p:sp>
+        <p:nvSpPr>
+          <p:cNvPr id="3" name="Rectangle 2"/>
+          <p:cNvSpPr/>
+          <p:nvPr/>
+        </p:nvSpPr>
+        <p:spPr>
+          <a:xfrm>
+            <a:off x="11313871" y="0"/>
+            <a:ext cx="54864" cy="6858000"/>
+          </a:xfrm>
+          <a:prstGeom prst="rect">
+            <a:avLst/>
+          </a:prstGeom>
+          <a:solidFill>
+            <a:srgbClr val="C9A227"/>
+          </a:solidFill>
+          <a:ln>
+            <a:noFill/>
+          </a:ln>
+        </p:spPr>
+        <p:style>
+          <a:lnRef idx="1">
+            <a:schemeClr val="accent1"/>
+          </a:lnRef>
+          <a:fillRef idx="3">
+            <a:schemeClr val="accent1"/>
+          </a:fillRef>
+          <a:effectRef idx="2">
+            <a:schemeClr val="accent1"/>
+          </a:effectRef>
+          <a:fontRef idx="minor">
+            <a:schemeClr val="lt1"/>
+          </a:fontRef>
+        </p:style>
+        <p:txBody>
+          <a:bodyPr rtlCol="0" anchor="ctr"/>
+          <a:lstStyle/>
+          <a:p>
+            <a:pPr algn="ctr"/>
+          </a:p>
+        </p:txBody>
+      </p:sp>
+      <p:sp>
+        <p:nvSpPr>
+          <p:cNvPr id="4" name="Rectangle 3"/>
+          <p:cNvSpPr/>
+          <p:nvPr/>
+        </p:nvSpPr>
+        <p:spPr>
+          <a:xfrm>
+            <a:off x="0" y="6355080"/>
+            <a:ext cx="12191695" cy="502920"/>
+          </a:xfrm>
+          <a:prstGeom prst="rect">
+            <a:avLst/>
+          </a:prstGeom>
+          <a:solidFill>
+            <a:srgbClr val="0F3D2E"/>
+          </a:solidFill>
+          <a:ln>
+            <a:noFill/>
+          </a:ln>
+        </p:spPr>
+        <p:style>
+          <a:lnRef idx="1">
+            <a:schemeClr val="accent1"/>
+          </a:lnRef>
+          <a:fillRef idx="3">
+            <a:schemeClr val="accent1"/>
+          </a:fillRef>
+          <a:effectRef idx="2">
+            <a:schemeClr val="accent1"/>
+          </a:effectRef>
+          <a:fontRef idx="minor">
+            <a:schemeClr val="lt1"/>
+          </a:fontRef>
+        </p:style>
+        <p:txBody>
+          <a:bodyPr rtlCol="0" anchor="ctr"/>
+          <a:lstStyle/>
+          <a:p>
+            <a:pPr algn="ctr"/>
+          </a:p>
+        </p:txBody>
+      </p:sp>
+      <p:sp>
+        <p:nvSpPr>
+          <p:cNvPr id="5" name="TextBox 4"/>
+          <p:cNvSpPr txBox="1"/>
+          <p:nvPr/>
+        </p:nvSpPr>
+        <p:spPr>
+          <a:xfrm>
+            <a:off x="457200" y="6400800"/>
+            <a:ext cx="1828800" cy="411480"/>
+          </a:xfrm>
+          <a:prstGeom prst="rect">
+            <a:avLst/>
+          </a:prstGeom>
+          <a:noFill/>
+        </p:spPr>
+        <p:txBody>
+          <a:bodyPr wrap="none">
+            <a:spAutoFit/>
+          </a:bodyPr>
+          <a:lstStyle/>
+          <a:p>
+            <a:pPr algn="l"/>
+            <a:r>
+              <a:rPr sz="1600" b="1">
+                <a:solidFill>
+                  <a:srgbClr val="C9A227"/>
+                </a:solidFill>
+                <a:latin typeface="Amiri"/>
+                <a:ea typeface="Amiri"/>
+                <a:cs typeface="Amiri"/>
+              </a:rPr>
+              <a:t>١٤</a:t>
+            </a:r>
+          </a:p>
+        </p:txBody>
+      </p:sp>
+      <p:sp>
+        <p:nvSpPr>
+          <p:cNvPr id="6" name="TextBox 5"/>
+          <p:cNvSpPr txBox="1"/>
+          <p:nvPr/>
+        </p:nvSpPr>
+        <p:spPr>
+          <a:xfrm>
+            <a:off x="9082735" y="6400800"/>
+            <a:ext cx="2377440" cy="411480"/>
           </a:xfrm>
           <a:prstGeom prst="rect">
             <a:avLst/>
@@ -6345,7 +6704,7 @@
         <p:spPr>
           <a:xfrm>
             <a:off x="640080" y="411480"/>
-            <a:ext cx="10728655" cy="1188720"/>
+            <a:ext cx="10180015" cy="1280160"/>
           </a:xfrm>
           <a:prstGeom prst="rect">
             <a:avLst/>
@@ -6367,7 +6726,7 @@
               </a:spcAft>
             </a:pPr>
             <a:r>
-              <a:rPr sz="3400" b="1">
+              <a:rPr sz="3200" b="1">
                 <a:solidFill>
                   <a:srgbClr val="0F3D2E"/>
                 </a:solidFill>
@@ -6388,7 +6747,7 @@
         </p:nvSpPr>
         <p:spPr>
           <a:xfrm>
-            <a:off x="6010351" y="1600200"/>
+            <a:off x="5461711" y="1645920"/>
             <a:ext cx="5852160" cy="54864"/>
           </a:xfrm>
           <a:prstGeom prst="rect">
@@ -6431,8 +6790,8 @@
         </p:nvSpPr>
         <p:spPr>
           <a:xfrm>
-            <a:off x="822960" y="1920240"/>
-            <a:ext cx="10362895" cy="4114800"/>
+            <a:off x="822960" y="1828800"/>
+            <a:ext cx="10088575" cy="4206240"/>
           </a:xfrm>
           <a:prstGeom prst="rect">
             <a:avLst/>
@@ -6447,14 +6806,14 @@
           <a:p>
             <a:pPr algn="r" rtl="1">
               <a:lnSpc>
-                <a:spcPct val="120000"/>
+                <a:spcPct val="115000"/>
               </a:lnSpc>
               <a:spcAft>
-                <a:spcPts val="1800"/>
+                <a:spcPts val="1400"/>
               </a:spcAft>
             </a:pPr>
             <a:r>
-              <a:rPr sz="2600" b="0">
+              <a:rPr sz="2400" b="0">
                 <a:solidFill>
                   <a:srgbClr val="222222"/>
                 </a:solidFill>
@@ -6468,14 +6827,14 @@
           <a:p>
             <a:pPr algn="r" rtl="1">
               <a:lnSpc>
-                <a:spcPct val="120000"/>
+                <a:spcPct val="115000"/>
               </a:lnSpc>
               <a:spcAft>
-                <a:spcPts val="1800"/>
+                <a:spcPts val="1400"/>
               </a:spcAft>
             </a:pPr>
             <a:r>
-              <a:rPr sz="2600" b="0">
+              <a:rPr sz="2400" b="0">
                 <a:solidFill>
                   <a:srgbClr val="222222"/>
                 </a:solidFill>
@@ -6514,49 +6873,30 @@
         <p:nvPr/>
       </p:nvGrpSpPr>
       <p:grpSpPr/>
-      <p:sp>
-        <p:nvSpPr>
-          <p:cNvPr id="2" name="Rectangle 1"/>
-          <p:cNvSpPr/>
-          <p:nvPr/>
-        </p:nvSpPr>
-        <p:spPr>
-          <a:xfrm>
-            <a:off x="11917375" y="0"/>
-            <a:ext cx="274320" cy="6858000"/>
-          </a:xfrm>
-          <a:prstGeom prst="rect">
-            <a:avLst/>
-          </a:prstGeom>
-          <a:solidFill>
-            <a:srgbClr val="0F3D2E"/>
-          </a:solidFill>
-          <a:ln>
-            <a:noFill/>
-          </a:ln>
-        </p:spPr>
-        <p:style>
-          <a:lnRef idx="1">
-            <a:schemeClr val="accent1"/>
-          </a:lnRef>
-          <a:fillRef idx="3">
-            <a:schemeClr val="accent1"/>
-          </a:fillRef>
-          <a:effectRef idx="2">
-            <a:schemeClr val="accent1"/>
-          </a:effectRef>
-          <a:fontRef idx="minor">
-            <a:schemeClr val="lt1"/>
-          </a:fontRef>
-        </p:style>
-        <p:txBody>
-          <a:bodyPr rtlCol="0" anchor="ctr"/>
-          <a:lstStyle/>
-          <a:p>
-            <a:pPr algn="ctr"/>
-          </a:p>
-        </p:txBody>
-      </p:sp>
+      <p:pic>
+        <p:nvPicPr>
+          <p:cNvPr id="2" name="Picture 1" descr="pola-geometris.png"/>
+          <p:cNvPicPr>
+            <a:picLocks noChangeAspect="1"/>
+          </p:cNvPicPr>
+          <p:nvPr/>
+        </p:nvPicPr>
+        <p:blipFill>
+          <a:blip r:embed="rId2"/>
+          <a:stretch>
+            <a:fillRect/>
+          </a:stretch>
+        </p:blipFill>
+        <p:spPr>
+          <a:xfrm>
+            <a:off x="11368735" y="0"/>
+            <a:ext cx="822960" cy="6858000"/>
+          </a:xfrm>
+          <a:prstGeom prst="rect">
+            <a:avLst/>
+          </a:prstGeom>
+        </p:spPr>
+      </p:pic>
       <p:sp>
         <p:nvSpPr>
           <p:cNvPr id="3" name="Rectangle 2"/>
@@ -6565,7 +6905,7 @@
         </p:nvSpPr>
         <p:spPr>
           <a:xfrm>
-            <a:off x="11862511" y="0"/>
+            <a:off x="11313871" y="0"/>
             <a:ext cx="54864" cy="6858000"/>
           </a:xfrm>
           <a:prstGeom prst="rect">
@@ -6688,8 +7028,8 @@
         </p:nvSpPr>
         <p:spPr>
           <a:xfrm>
-            <a:off x="9448495" y="6400800"/>
-            <a:ext cx="2194560" cy="411480"/>
+            <a:off x="9082735" y="6400800"/>
+            <a:ext cx="2377440" cy="411480"/>
           </a:xfrm>
           <a:prstGeom prst="rect">
             <a:avLst/>
@@ -6726,7 +7066,7 @@
         <p:spPr>
           <a:xfrm>
             <a:off x="640080" y="411480"/>
-            <a:ext cx="10728655" cy="1188720"/>
+            <a:ext cx="10180015" cy="1280160"/>
           </a:xfrm>
           <a:prstGeom prst="rect">
             <a:avLst/>
@@ -6748,7 +7088,7 @@
               </a:spcAft>
             </a:pPr>
             <a:r>
-              <a:rPr sz="3400" b="1">
+              <a:rPr sz="3200" b="1">
                 <a:solidFill>
                   <a:srgbClr val="0F3D2E"/>
                 </a:solidFill>
@@ -6769,7 +7109,7 @@
         </p:nvSpPr>
         <p:spPr>
           <a:xfrm>
-            <a:off x="6010351" y="1600200"/>
+            <a:off x="5461711" y="1645920"/>
             <a:ext cx="5852160" cy="54864"/>
           </a:xfrm>
           <a:prstGeom prst="rect">
@@ -6812,8 +7152,8 @@
         </p:nvSpPr>
         <p:spPr>
           <a:xfrm>
-            <a:off x="822960" y="1920240"/>
-            <a:ext cx="10362895" cy="4114800"/>
+            <a:off x="822960" y="1828800"/>
+            <a:ext cx="10088575" cy="4206240"/>
           </a:xfrm>
           <a:prstGeom prst="rect">
             <a:avLst/>
@@ -6828,14 +7168,14 @@
           <a:p>
             <a:pPr algn="r" rtl="1">
               <a:lnSpc>
-                <a:spcPct val="120000"/>
+                <a:spcPct val="115000"/>
               </a:lnSpc>
               <a:spcAft>
-                <a:spcPts val="1800"/>
+                <a:spcPts val="1400"/>
               </a:spcAft>
             </a:pPr>
             <a:r>
-              <a:rPr sz="2600" b="0">
+              <a:rPr sz="2400" b="0">
                 <a:solidFill>
                   <a:srgbClr val="222222"/>
                 </a:solidFill>
@@ -6843,20 +7183,20 @@
                 <a:ea typeface="Amiri"/>
                 <a:cs typeface="Amiri"/>
               </a:rPr>
-              <a:t>الأصل: التحريم عند تحقق إحدى العلل الثلاث</a:t>
+              <a:t>الأصل التحريم عند تحقق إحدى العلل الثلاث في وسيلة الزينة</a:t>
             </a:r>
           </a:p>
           <a:p>
             <a:pPr algn="r" rtl="1">
               <a:lnSpc>
-                <a:spcPct val="120000"/>
+                <a:spcPct val="115000"/>
               </a:lnSpc>
               <a:spcAft>
-                <a:spcPts val="1800"/>
+                <a:spcPts val="1400"/>
               </a:spcAft>
             </a:pPr>
             <a:r>
-              <a:rPr sz="2600" b="0">
+              <a:rPr sz="2400" b="0">
                 <a:solidFill>
                   <a:srgbClr val="222222"/>
                 </a:solidFill>
@@ -6868,16 +7208,79 @@
             </a:r>
           </a:p>
           <a:p>
+            <a:pPr algn="r" rtl="1" lvl="1">
+              <a:lnSpc>
+                <a:spcPct val="115000"/>
+              </a:lnSpc>
+              <a:spcAft>
+                <a:spcPts val="800"/>
+              </a:spcAft>
+            </a:pPr>
+            <a:r>
+              <a:rPr sz="2000" b="0">
+                <a:solidFill>
+                  <a:srgbClr val="444444"/>
+                </a:solidFill>
+                <a:latin typeface="Amiri"/>
+                <a:ea typeface="Amiri"/>
+                <a:cs typeface="Amiri"/>
+              </a:rPr>
+              <a:t>تغيير خلق الله: كالنمص والوشم وما يغيّر الخلقة</a:t>
+            </a:r>
+          </a:p>
+          <a:p>
+            <a:pPr algn="r" rtl="1" lvl="1">
+              <a:lnSpc>
+                <a:spcPct val="115000"/>
+              </a:lnSpc>
+              <a:spcAft>
+                <a:spcPts val="800"/>
+              </a:spcAft>
+            </a:pPr>
+            <a:r>
+              <a:rPr sz="2000" b="0">
+                <a:solidFill>
+                  <a:srgbClr val="444444"/>
+                </a:solidFill>
+                <a:latin typeface="Amiri"/>
+                <a:ea typeface="Amiri"/>
+                <a:cs typeface="Amiri"/>
+              </a:rPr>
+              <a:t>التدليس: كإظهار ما ليس حقيقة، ومنه الوصل</a:t>
+            </a:r>
+          </a:p>
+          <a:p>
+            <a:pPr algn="r" rtl="1" lvl="1">
+              <a:lnSpc>
+                <a:spcPct val="115000"/>
+              </a:lnSpc>
+              <a:spcAft>
+                <a:spcPts val="800"/>
+              </a:spcAft>
+            </a:pPr>
+            <a:r>
+              <a:rPr sz="2000" b="0">
+                <a:solidFill>
+                  <a:srgbClr val="444444"/>
+                </a:solidFill>
+                <a:latin typeface="Amiri"/>
+                <a:ea typeface="Amiri"/>
+                <a:cs typeface="Amiri"/>
+              </a:rPr>
+              <a:t>الضرر: كل ما أضرّ بالبدن امتنع</a:t>
+            </a:r>
+          </a:p>
+          <a:p>
             <a:pPr algn="r" rtl="1">
               <a:lnSpc>
-                <a:spcPct val="120000"/>
+                <a:spcPct val="115000"/>
               </a:lnSpc>
               <a:spcAft>
-                <a:spcPts val="1800"/>
+                <a:spcPts val="1400"/>
               </a:spcAft>
             </a:pPr>
             <a:r>
-              <a:rPr sz="2600" b="0">
+              <a:rPr sz="2400" b="0">
                 <a:solidFill>
                   <a:srgbClr val="222222"/>
                 </a:solidFill>
@@ -6916,49 +7319,30 @@
         <p:nvPr/>
       </p:nvGrpSpPr>
       <p:grpSpPr/>
-      <p:sp>
-        <p:nvSpPr>
-          <p:cNvPr id="2" name="Rectangle 1"/>
-          <p:cNvSpPr/>
-          <p:nvPr/>
-        </p:nvSpPr>
-        <p:spPr>
-          <a:xfrm>
-            <a:off x="11917375" y="0"/>
-            <a:ext cx="274320" cy="6858000"/>
-          </a:xfrm>
-          <a:prstGeom prst="rect">
-            <a:avLst/>
-          </a:prstGeom>
-          <a:solidFill>
-            <a:srgbClr val="0F3D2E"/>
-          </a:solidFill>
-          <a:ln>
-            <a:noFill/>
-          </a:ln>
-        </p:spPr>
-        <p:style>
-          <a:lnRef idx="1">
-            <a:schemeClr val="accent1"/>
-          </a:lnRef>
-          <a:fillRef idx="3">
-            <a:schemeClr val="accent1"/>
-          </a:fillRef>
-          <a:effectRef idx="2">
-            <a:schemeClr val="accent1"/>
-          </a:effectRef>
-          <a:fontRef idx="minor">
-            <a:schemeClr val="lt1"/>
-          </a:fontRef>
-        </p:style>
-        <p:txBody>
-          <a:bodyPr rtlCol="0" anchor="ctr"/>
-          <a:lstStyle/>
-          <a:p>
-            <a:pPr algn="ctr"/>
-          </a:p>
-        </p:txBody>
-      </p:sp>
+      <p:pic>
+        <p:nvPicPr>
+          <p:cNvPr id="2" name="Picture 1" descr="pola-geometris.png"/>
+          <p:cNvPicPr>
+            <a:picLocks noChangeAspect="1"/>
+          </p:cNvPicPr>
+          <p:nvPr/>
+        </p:nvPicPr>
+        <p:blipFill>
+          <a:blip r:embed="rId2"/>
+          <a:stretch>
+            <a:fillRect/>
+          </a:stretch>
+        </p:blipFill>
+        <p:spPr>
+          <a:xfrm>
+            <a:off x="11368735" y="0"/>
+            <a:ext cx="822960" cy="6858000"/>
+          </a:xfrm>
+          <a:prstGeom prst="rect">
+            <a:avLst/>
+          </a:prstGeom>
+        </p:spPr>
+      </p:pic>
       <p:sp>
         <p:nvSpPr>
           <p:cNvPr id="3" name="Rectangle 2"/>
@@ -6967,7 +7351,7 @@
         </p:nvSpPr>
         <p:spPr>
           <a:xfrm>
-            <a:off x="11862511" y="0"/>
+            <a:off x="11313871" y="0"/>
             <a:ext cx="54864" cy="6858000"/>
           </a:xfrm>
           <a:prstGeom prst="rect">
@@ -7090,8 +7474,8 @@
         </p:nvSpPr>
         <p:spPr>
           <a:xfrm>
-            <a:off x="9448495" y="6400800"/>
-            <a:ext cx="2194560" cy="411480"/>
+            <a:off x="9082735" y="6400800"/>
+            <a:ext cx="2377440" cy="411480"/>
           </a:xfrm>
           <a:prstGeom prst="rect">
             <a:avLst/>
@@ -7128,7 +7512,7 @@
         <p:spPr>
           <a:xfrm>
             <a:off x="640080" y="411480"/>
-            <a:ext cx="10728655" cy="1188720"/>
+            <a:ext cx="10180015" cy="1280160"/>
           </a:xfrm>
           <a:prstGeom prst="rect">
             <a:avLst/>
@@ -7150,7 +7534,7 @@
               </a:spcAft>
             </a:pPr>
             <a:r>
-              <a:rPr sz="3400" b="1">
+              <a:rPr sz="3200" b="1">
                 <a:solidFill>
                   <a:srgbClr val="0F3D2E"/>
                 </a:solidFill>
@@ -7158,7 +7542,7 @@
                 <a:ea typeface="Amiri"/>
                 <a:cs typeface="Amiri"/>
               </a:rPr>
-              <a:t>النمص والوشم والتشقير ونحوها تمتنع عند قيام التغيير أو التدليس</a:t>
+              <a:t>لكل وسيلة زينة ضابطها: الامتناع عند قيام علة محرِّمة</a:t>
             </a:r>
           </a:p>
         </p:txBody>
@@ -7171,7 +7555,7 @@
         </p:nvSpPr>
         <p:spPr>
           <a:xfrm>
-            <a:off x="6010351" y="1600200"/>
+            <a:off x="5461711" y="1645920"/>
             <a:ext cx="5852160" cy="54864"/>
           </a:xfrm>
           <a:prstGeom prst="rect">
@@ -7214,8 +7598,8 @@
         </p:nvSpPr>
         <p:spPr>
           <a:xfrm>
-            <a:off x="822960" y="1920240"/>
-            <a:ext cx="10362895" cy="4114800"/>
+            <a:off x="822960" y="1828800"/>
+            <a:ext cx="10088575" cy="4206240"/>
           </a:xfrm>
           <a:prstGeom prst="rect">
             <a:avLst/>
@@ -7230,14 +7614,77 @@
           <a:p>
             <a:pPr algn="r" rtl="1">
               <a:lnSpc>
-                <a:spcPct val="120000"/>
+                <a:spcPct val="115000"/>
               </a:lnSpc>
               <a:spcAft>
-                <a:spcPts val="1800"/>
+                <a:spcPts val="1400"/>
               </a:spcAft>
             </a:pPr>
             <a:r>
-              <a:rPr sz="2600" b="0">
+              <a:rPr sz="2400" b="0">
+                <a:solidFill>
+                  <a:srgbClr val="222222"/>
+                </a:solidFill>
+                <a:latin typeface="Amiri"/>
+                <a:ea typeface="Amiri"/>
+                <a:cs typeface="Amiri"/>
+              </a:rPr>
+              <a:t>التشقير والحواجب والنمص: تمتنع عند التغيير</a:t>
+            </a:r>
+          </a:p>
+          <a:p>
+            <a:pPr algn="r" rtl="1">
+              <a:lnSpc>
+                <a:spcPct val="115000"/>
+              </a:lnSpc>
+              <a:spcAft>
+                <a:spcPts val="1400"/>
+              </a:spcAft>
+            </a:pPr>
+            <a:r>
+              <a:rPr sz="2400" b="0">
+                <a:solidFill>
+                  <a:srgbClr val="222222"/>
+                </a:solidFill>
+                <a:latin typeface="Amiri"/>
+                <a:ea typeface="Amiri"/>
+                <a:cs typeface="Amiri"/>
+              </a:rPr>
+              <a:t>الوشم: ممنوع لتغيير الخلقة</a:t>
+            </a:r>
+          </a:p>
+          <a:p>
+            <a:pPr algn="r" rtl="1">
+              <a:lnSpc>
+                <a:spcPct val="115000"/>
+              </a:lnSpc>
+              <a:spcAft>
+                <a:spcPts val="1400"/>
+              </a:spcAft>
+            </a:pPr>
+            <a:r>
+              <a:rPr sz="2400" b="0">
+                <a:solidFill>
+                  <a:srgbClr val="222222"/>
+                </a:solidFill>
+                <a:latin typeface="Amiri"/>
+                <a:ea typeface="Amiri"/>
+                <a:cs typeface="Amiri"/>
+              </a:rPr>
+              <a:t>العدسات والأظافر: تُوزن بضوابط التغيير والتدليس والضرر</a:t>
+            </a:r>
+          </a:p>
+          <a:p>
+            <a:pPr algn="r" rtl="1">
+              <a:lnSpc>
+                <a:spcPct val="115000"/>
+              </a:lnSpc>
+              <a:spcAft>
+                <a:spcPts val="1400"/>
+              </a:spcAft>
+            </a:pPr>
+            <a:r>
+              <a:rPr sz="2400" b="0">
                 <a:solidFill>
                   <a:srgbClr val="222222"/>
                 </a:solidFill>
@@ -7246,27 +7693,6 @@
                 <a:cs typeface="Amiri"/>
               </a:rPr>
               <a:t>الوصل: محرم، ويجوز بغير شعر الآدمي اتفاقًا</a:t>
-            </a:r>
-          </a:p>
-          <a:p>
-            <a:pPr algn="r" rtl="1">
-              <a:lnSpc>
-                <a:spcPct val="120000"/>
-              </a:lnSpc>
-              <a:spcAft>
-                <a:spcPts val="1800"/>
-              </a:spcAft>
-            </a:pPr>
-            <a:r>
-              <a:rPr sz="2600" b="0">
-                <a:solidFill>
-                  <a:srgbClr val="222222"/>
-                </a:solidFill>
-                <a:latin typeface="Amiri"/>
-                <a:ea typeface="Amiri"/>
-                <a:cs typeface="Amiri"/>
-              </a:rPr>
-              <a:t>الضابط: كلما تحققت علة محرِّمة امتنع الفعل</a:t>
             </a:r>
           </a:p>
         </p:txBody>
@@ -7297,49 +7723,30 @@
         <p:nvPr/>
       </p:nvGrpSpPr>
       <p:grpSpPr/>
-      <p:sp>
-        <p:nvSpPr>
-          <p:cNvPr id="2" name="Rectangle 1"/>
-          <p:cNvSpPr/>
-          <p:nvPr/>
-        </p:nvSpPr>
-        <p:spPr>
-          <a:xfrm>
-            <a:off x="11917375" y="0"/>
-            <a:ext cx="274320" cy="6858000"/>
-          </a:xfrm>
-          <a:prstGeom prst="rect">
-            <a:avLst/>
-          </a:prstGeom>
-          <a:solidFill>
-            <a:srgbClr val="0F3D2E"/>
-          </a:solidFill>
-          <a:ln>
-            <a:noFill/>
-          </a:ln>
-        </p:spPr>
-        <p:style>
-          <a:lnRef idx="1">
-            <a:schemeClr val="accent1"/>
-          </a:lnRef>
-          <a:fillRef idx="3">
-            <a:schemeClr val="accent1"/>
-          </a:fillRef>
-          <a:effectRef idx="2">
-            <a:schemeClr val="accent1"/>
-          </a:effectRef>
-          <a:fontRef idx="minor">
-            <a:schemeClr val="lt1"/>
-          </a:fontRef>
-        </p:style>
-        <p:txBody>
-          <a:bodyPr rtlCol="0" anchor="ctr"/>
-          <a:lstStyle/>
-          <a:p>
-            <a:pPr algn="ctr"/>
-          </a:p>
-        </p:txBody>
-      </p:sp>
+      <p:pic>
+        <p:nvPicPr>
+          <p:cNvPr id="2" name="Picture 1" descr="pola-geometris.png"/>
+          <p:cNvPicPr>
+            <a:picLocks noChangeAspect="1"/>
+          </p:cNvPicPr>
+          <p:nvPr/>
+        </p:nvPicPr>
+        <p:blipFill>
+          <a:blip r:embed="rId2"/>
+          <a:stretch>
+            <a:fillRect/>
+          </a:stretch>
+        </p:blipFill>
+        <p:spPr>
+          <a:xfrm>
+            <a:off x="11368735" y="0"/>
+            <a:ext cx="822960" cy="6858000"/>
+          </a:xfrm>
+          <a:prstGeom prst="rect">
+            <a:avLst/>
+          </a:prstGeom>
+        </p:spPr>
+      </p:pic>
       <p:sp>
         <p:nvSpPr>
           <p:cNvPr id="3" name="Rectangle 2"/>
@@ -7348,7 +7755,7 @@
         </p:nvSpPr>
         <p:spPr>
           <a:xfrm>
-            <a:off x="11862511" y="0"/>
+            <a:off x="11313871" y="0"/>
             <a:ext cx="54864" cy="6858000"/>
           </a:xfrm>
           <a:prstGeom prst="rect">
@@ -7471,8 +7878,8 @@
         </p:nvSpPr>
         <p:spPr>
           <a:xfrm>
-            <a:off x="9448495" y="6400800"/>
-            <a:ext cx="2194560" cy="411480"/>
+            <a:off x="9082735" y="6400800"/>
+            <a:ext cx="2377440" cy="411480"/>
           </a:xfrm>
           <a:prstGeom prst="rect">
             <a:avLst/>
@@ -7509,7 +7916,7 @@
         <p:spPr>
           <a:xfrm>
             <a:off x="640080" y="411480"/>
-            <a:ext cx="10728655" cy="1188720"/>
+            <a:ext cx="10180015" cy="1280160"/>
           </a:xfrm>
           <a:prstGeom prst="rect">
             <a:avLst/>
@@ -7531,7 +7938,7 @@
               </a:spcAft>
             </a:pPr>
             <a:r>
-              <a:rPr sz="3400" b="1">
+              <a:rPr sz="3200" b="1">
                 <a:solidFill>
                   <a:srgbClr val="0F3D2E"/>
                 </a:solidFill>
@@ -7539,7 +7946,7 @@
                 <a:ea typeface="Amiri"/>
                 <a:cs typeface="Amiri"/>
               </a:rPr>
-              <a:t>العمليات تجوز بضوابط، وللزينة أثر في النظر داخل عقد النكاح</a:t>
+              <a:t>العمليات الجراحية التجميلية تجوز للحاجة الشرعية دون تغيير الخلق</a:t>
             </a:r>
           </a:p>
         </p:txBody>
@@ -7552,7 +7959,7 @@
         </p:nvSpPr>
         <p:spPr>
           <a:xfrm>
-            <a:off x="6010351" y="1600200"/>
+            <a:off x="5461711" y="1645920"/>
             <a:ext cx="5852160" cy="54864"/>
           </a:xfrm>
           <a:prstGeom prst="rect">
@@ -7595,8 +8002,8 @@
         </p:nvSpPr>
         <p:spPr>
           <a:xfrm>
-            <a:off x="822960" y="1920240"/>
-            <a:ext cx="10362895" cy="4114800"/>
+            <a:off x="822960" y="1828800"/>
+            <a:ext cx="10088575" cy="4206240"/>
           </a:xfrm>
           <a:prstGeom prst="rect">
             <a:avLst/>
@@ -7611,14 +8018,14 @@
           <a:p>
             <a:pPr algn="r" rtl="1">
               <a:lnSpc>
-                <a:spcPct val="120000"/>
+                <a:spcPct val="115000"/>
               </a:lnSpc>
               <a:spcAft>
-                <a:spcPts val="1800"/>
+                <a:spcPts val="1400"/>
               </a:spcAft>
             </a:pPr>
             <a:r>
-              <a:rPr sz="2600" b="0">
+              <a:rPr sz="2400" b="0">
                 <a:solidFill>
                   <a:srgbClr val="222222"/>
                 </a:solidFill>
@@ -7626,20 +8033,20 @@
                 <a:ea typeface="Amiri"/>
                 <a:cs typeface="Amiri"/>
               </a:rPr>
-              <a:t>العمليات الجراحية تجوز للحاجة الشرعية دون تغيير الخلق</a:t>
+              <a:t>الجواز مشروط بالحاجة الشرعية (علاج، إصلاح عيب)</a:t>
             </a:r>
           </a:p>
           <a:p>
             <a:pPr algn="r" rtl="1">
               <a:lnSpc>
-                <a:spcPct val="120000"/>
+                <a:spcPct val="115000"/>
               </a:lnSpc>
               <a:spcAft>
-                <a:spcPts val="1800"/>
+                <a:spcPts val="1400"/>
               </a:spcAft>
             </a:pPr>
             <a:r>
-              <a:rPr sz="2600" b="0">
+              <a:rPr sz="2400" b="0">
                 <a:solidFill>
                   <a:srgbClr val="222222"/>
                 </a:solidFill>
@@ -7647,7 +8054,28 @@
                 <a:ea typeface="Amiri"/>
                 <a:cs typeface="Amiri"/>
               </a:rPr>
-              <a:t>الزينة المؤثرة على النظر تُرتَّب أحكامها في النكاح وفق المذاهب</a:t>
+              <a:t>يمتنع ما كان لمجرد تغيير خلق الله</a:t>
+            </a:r>
+          </a:p>
+          <a:p>
+            <a:pPr algn="r" rtl="1">
+              <a:lnSpc>
+                <a:spcPct val="115000"/>
+              </a:lnSpc>
+              <a:spcAft>
+                <a:spcPts val="1400"/>
+              </a:spcAft>
+            </a:pPr>
+            <a:r>
+              <a:rPr sz="2400" b="0">
+                <a:solidFill>
+                  <a:srgbClr val="222222"/>
+                </a:solidFill>
+                <a:latin typeface="Amiri"/>
+                <a:ea typeface="Amiri"/>
+                <a:cs typeface="Amiri"/>
+              </a:rPr>
+              <a:t>يُراعى انتفاء الضرر</a:t>
             </a:r>
           </a:p>
         </p:txBody>
@@ -7678,49 +8106,30 @@
         <p:nvPr/>
       </p:nvGrpSpPr>
       <p:grpSpPr/>
-      <p:sp>
-        <p:nvSpPr>
-          <p:cNvPr id="2" name="Rectangle 1"/>
-          <p:cNvSpPr/>
-          <p:nvPr/>
-        </p:nvSpPr>
-        <p:spPr>
-          <a:xfrm>
-            <a:off x="11917375" y="0"/>
-            <a:ext cx="274320" cy="6858000"/>
-          </a:xfrm>
-          <a:prstGeom prst="rect">
-            <a:avLst/>
-          </a:prstGeom>
-          <a:solidFill>
-            <a:srgbClr val="0F3D2E"/>
-          </a:solidFill>
-          <a:ln>
-            <a:noFill/>
-          </a:ln>
-        </p:spPr>
-        <p:style>
-          <a:lnRef idx="1">
-            <a:schemeClr val="accent1"/>
-          </a:lnRef>
-          <a:fillRef idx="3">
-            <a:schemeClr val="accent1"/>
-          </a:fillRef>
-          <a:effectRef idx="2">
-            <a:schemeClr val="accent1"/>
-          </a:effectRef>
-          <a:fontRef idx="minor">
-            <a:schemeClr val="lt1"/>
-          </a:fontRef>
-        </p:style>
-        <p:txBody>
-          <a:bodyPr rtlCol="0" anchor="ctr"/>
-          <a:lstStyle/>
-          <a:p>
-            <a:pPr algn="ctr"/>
-          </a:p>
-        </p:txBody>
-      </p:sp>
+      <p:pic>
+        <p:nvPicPr>
+          <p:cNvPr id="2" name="Picture 1" descr="pola-geometris.png"/>
+          <p:cNvPicPr>
+            <a:picLocks noChangeAspect="1"/>
+          </p:cNvPicPr>
+          <p:nvPr/>
+        </p:nvPicPr>
+        <p:blipFill>
+          <a:blip r:embed="rId2"/>
+          <a:stretch>
+            <a:fillRect/>
+          </a:stretch>
+        </p:blipFill>
+        <p:spPr>
+          <a:xfrm>
+            <a:off x="11368735" y="0"/>
+            <a:ext cx="822960" cy="6858000"/>
+          </a:xfrm>
+          <a:prstGeom prst="rect">
+            <a:avLst/>
+          </a:prstGeom>
+        </p:spPr>
+      </p:pic>
       <p:sp>
         <p:nvSpPr>
           <p:cNvPr id="3" name="Rectangle 2"/>
@@ -7729,7 +8138,7 @@
         </p:nvSpPr>
         <p:spPr>
           <a:xfrm>
-            <a:off x="11862511" y="0"/>
+            <a:off x="11313871" y="0"/>
             <a:ext cx="54864" cy="6858000"/>
           </a:xfrm>
           <a:prstGeom prst="rect">
@@ -7852,8 +8261,8 @@
         </p:nvSpPr>
         <p:spPr>
           <a:xfrm>
-            <a:off x="9448495" y="6400800"/>
-            <a:ext cx="2194560" cy="411480"/>
+            <a:off x="9082735" y="6400800"/>
+            <a:ext cx="2377440" cy="411480"/>
           </a:xfrm>
           <a:prstGeom prst="rect">
             <a:avLst/>
@@ -7876,7 +8285,7 @@
                 <a:ea typeface="Amiri"/>
                 <a:cs typeface="Amiri"/>
               </a:rPr>
-              <a:t>ص٢١</a:t>
+              <a:t>ص٦</a:t>
             </a:r>
           </a:p>
         </p:txBody>
@@ -7890,7 +8299,7 @@
         <p:spPr>
           <a:xfrm>
             <a:off x="640080" y="411480"/>
-            <a:ext cx="10728655" cy="1188720"/>
+            <a:ext cx="10180015" cy="1280160"/>
           </a:xfrm>
           <a:prstGeom prst="rect">
             <a:avLst/>
@@ -7912,7 +8321,7 @@
               </a:spcAft>
             </a:pPr>
             <a:r>
-              <a:rPr sz="3400" b="1">
+              <a:rPr sz="3200" b="1">
                 <a:solidFill>
                   <a:srgbClr val="0F3D2E"/>
                 </a:solidFill>
@@ -7920,7 +8329,7 @@
                 <a:ea typeface="Amiri"/>
                 <a:cs typeface="Amiri"/>
               </a:rPr>
-              <a:t>أربعة أهداف: الأدوات، العمليات، البيع، وأثر الزينة على النكاح</a:t>
+              <a:t>للزينة أثر في النظر داخل عقد النكاح، وتُرتَّب أحكامها وفق المذاهب</a:t>
             </a:r>
           </a:p>
         </p:txBody>
@@ -7933,7 +8342,7 @@
         </p:nvSpPr>
         <p:spPr>
           <a:xfrm>
-            <a:off x="6010351" y="1600200"/>
+            <a:off x="5461711" y="1645920"/>
             <a:ext cx="5852160" cy="54864"/>
           </a:xfrm>
           <a:prstGeom prst="rect">
@@ -7976,8 +8385,8 @@
         </p:nvSpPr>
         <p:spPr>
           <a:xfrm>
-            <a:off x="822960" y="1920240"/>
-            <a:ext cx="10362895" cy="4114800"/>
+            <a:off x="822960" y="1828800"/>
+            <a:ext cx="10088575" cy="4206240"/>
           </a:xfrm>
           <a:prstGeom prst="rect">
             <a:avLst/>
@@ -7992,10 +8401,10 @@
           <a:p>
             <a:pPr algn="r" rtl="1">
               <a:lnSpc>
-                <a:spcPct val="120000"/>
+                <a:spcPct val="115000"/>
               </a:lnSpc>
               <a:spcAft>
-                <a:spcPts val="1800"/>
+                <a:spcPts val="1400"/>
               </a:spcAft>
             </a:pPr>
             <a:r>
@@ -8007,16 +8416,16 @@
                 <a:ea typeface="Amiri"/>
                 <a:cs typeface="Amiri"/>
               </a:rPr>
-              <a:t>بيان حكم أدوات التجميل المعاصرة في المذاهب الأربعة</a:t>
+              <a:t>الزينة المؤثرة على النظر تُرتَّب أحكامها في باب النكاح</a:t>
             </a:r>
           </a:p>
           <a:p>
             <a:pPr algn="r" rtl="1">
               <a:lnSpc>
-                <a:spcPct val="120000"/>
+                <a:spcPct val="115000"/>
               </a:lnSpc>
               <a:spcAft>
-                <a:spcPts val="1800"/>
+                <a:spcPts val="1400"/>
               </a:spcAft>
             </a:pPr>
             <a:r>
@@ -8028,49 +8437,7 @@
                 <a:ea typeface="Amiri"/>
                 <a:cs typeface="Amiri"/>
               </a:rPr>
-              <a:t>معرفة حكم عمليات التجميل في المذاهب المعتمدة</a:t>
-            </a:r>
-          </a:p>
-          <a:p>
-            <a:pPr algn="r" rtl="1">
-              <a:lnSpc>
-                <a:spcPct val="120000"/>
-              </a:lnSpc>
-              <a:spcAft>
-                <a:spcPts val="1800"/>
-              </a:spcAft>
-            </a:pPr>
-            <a:r>
-              <a:rPr sz="2400" b="0">
-                <a:solidFill>
-                  <a:srgbClr val="222222"/>
-                </a:solidFill>
-                <a:latin typeface="Amiri"/>
-                <a:ea typeface="Amiri"/>
-                <a:cs typeface="Amiri"/>
-              </a:rPr>
-              <a:t>معرفة حكم بيع أدوات التجميل في المذاهب الأربعة</a:t>
-            </a:r>
-          </a:p>
-          <a:p>
-            <a:pPr algn="r" rtl="1">
-              <a:lnSpc>
-                <a:spcPct val="120000"/>
-              </a:lnSpc>
-              <a:spcAft>
-                <a:spcPts val="1800"/>
-              </a:spcAft>
-            </a:pPr>
-            <a:r>
-              <a:rPr sz="2400" b="0">
-                <a:solidFill>
-                  <a:srgbClr val="222222"/>
-                </a:solidFill>
-                <a:latin typeface="Amiri"/>
-                <a:ea typeface="Amiri"/>
-                <a:cs typeface="Amiri"/>
-              </a:rPr>
-              <a:t>بيان أثر الزينة على عقد النكاح</a:t>
+              <a:t>تفصيل المذاهب (المالكية والشافعية والحنابلة) في أثرها على النظر والخيار</a:t>
             </a:r>
           </a:p>
         </p:txBody>
@@ -8101,49 +8468,30 @@
         <p:nvPr/>
       </p:nvGrpSpPr>
       <p:grpSpPr/>
-      <p:sp>
-        <p:nvSpPr>
-          <p:cNvPr id="2" name="Rectangle 1"/>
-          <p:cNvSpPr/>
-          <p:nvPr/>
-        </p:nvSpPr>
-        <p:spPr>
-          <a:xfrm>
-            <a:off x="11917375" y="0"/>
-            <a:ext cx="274320" cy="6858000"/>
-          </a:xfrm>
-          <a:prstGeom prst="rect">
-            <a:avLst/>
-          </a:prstGeom>
-          <a:solidFill>
-            <a:srgbClr val="0F3D2E"/>
-          </a:solidFill>
-          <a:ln>
-            <a:noFill/>
-          </a:ln>
-        </p:spPr>
-        <p:style>
-          <a:lnRef idx="1">
-            <a:schemeClr val="accent1"/>
-          </a:lnRef>
-          <a:fillRef idx="3">
-            <a:schemeClr val="accent1"/>
-          </a:fillRef>
-          <a:effectRef idx="2">
-            <a:schemeClr val="accent1"/>
-          </a:effectRef>
-          <a:fontRef idx="minor">
-            <a:schemeClr val="lt1"/>
-          </a:fontRef>
-        </p:style>
-        <p:txBody>
-          <a:bodyPr rtlCol="0" anchor="ctr"/>
-          <a:lstStyle/>
-          <a:p>
-            <a:pPr algn="ctr"/>
-          </a:p>
-        </p:txBody>
-      </p:sp>
+      <p:pic>
+        <p:nvPicPr>
+          <p:cNvPr id="2" name="Picture 1" descr="pola-geometris.png"/>
+          <p:cNvPicPr>
+            <a:picLocks noChangeAspect="1"/>
+          </p:cNvPicPr>
+          <p:nvPr/>
+        </p:nvPicPr>
+        <p:blipFill>
+          <a:blip r:embed="rId2"/>
+          <a:stretch>
+            <a:fillRect/>
+          </a:stretch>
+        </p:blipFill>
+        <p:spPr>
+          <a:xfrm>
+            <a:off x="11368735" y="0"/>
+            <a:ext cx="822960" cy="6858000"/>
+          </a:xfrm>
+          <a:prstGeom prst="rect">
+            <a:avLst/>
+          </a:prstGeom>
+        </p:spPr>
+      </p:pic>
       <p:sp>
         <p:nvSpPr>
           <p:cNvPr id="3" name="Rectangle 2"/>
@@ -8152,7 +8500,7 @@
         </p:nvSpPr>
         <p:spPr>
           <a:xfrm>
-            <a:off x="11862511" y="0"/>
+            <a:off x="11313871" y="0"/>
             <a:ext cx="54864" cy="6858000"/>
           </a:xfrm>
           <a:prstGeom prst="rect">
@@ -8275,8 +8623,8 @@
         </p:nvSpPr>
         <p:spPr>
           <a:xfrm>
-            <a:off x="9448495" y="6400800"/>
-            <a:ext cx="2194560" cy="411480"/>
+            <a:off x="9082735" y="6400800"/>
+            <a:ext cx="2377440" cy="411480"/>
           </a:xfrm>
           <a:prstGeom prst="rect">
             <a:avLst/>
@@ -8313,7 +8661,7 @@
         <p:spPr>
           <a:xfrm>
             <a:off x="640080" y="411480"/>
-            <a:ext cx="10728655" cy="1188720"/>
+            <a:ext cx="10180015" cy="1280160"/>
           </a:xfrm>
           <a:prstGeom prst="rect">
             <a:avLst/>
@@ -8335,7 +8683,7 @@
               </a:spcAft>
             </a:pPr>
             <a:r>
-              <a:rPr sz="3400" b="1">
+              <a:rPr sz="3200" b="1">
                 <a:solidFill>
                   <a:srgbClr val="0F3D2E"/>
                 </a:solidFill>
@@ -8343,7 +8691,7 @@
                 <a:ea typeface="Amiri"/>
                 <a:cs typeface="Amiri"/>
               </a:rPr>
-              <a:t>الفوائد توازي الأهداف وتُعمّق إدراك الأحكام</a:t>
+              <a:t>أربعة أهداف: الأدوات، العمليات، البيع، وأثر الزينة على النكاح</a:t>
             </a:r>
           </a:p>
         </p:txBody>
@@ -8356,7 +8704,7 @@
         </p:nvSpPr>
         <p:spPr>
           <a:xfrm>
-            <a:off x="6010351" y="1600200"/>
+            <a:off x="5461711" y="1645920"/>
             <a:ext cx="5852160" cy="54864"/>
           </a:xfrm>
           <a:prstGeom prst="rect">
@@ -8399,8 +8747,8 @@
         </p:nvSpPr>
         <p:spPr>
           <a:xfrm>
-            <a:off x="822960" y="1920240"/>
-            <a:ext cx="10362895" cy="4114800"/>
+            <a:off x="822960" y="1828800"/>
+            <a:ext cx="10088575" cy="4206240"/>
           </a:xfrm>
           <a:prstGeom prst="rect">
             <a:avLst/>
@@ -8415,14 +8763,14 @@
           <a:p>
             <a:pPr algn="r" rtl="1">
               <a:lnSpc>
-                <a:spcPct val="120000"/>
+                <a:spcPct val="115000"/>
               </a:lnSpc>
               <a:spcAft>
-                <a:spcPts val="1800"/>
+                <a:spcPts val="1400"/>
               </a:spcAft>
             </a:pPr>
             <a:r>
-              <a:rPr sz="2400" b="0">
+              <a:rPr sz="2200" b="0">
                 <a:solidFill>
                   <a:srgbClr val="222222"/>
                 </a:solidFill>
@@ -8430,20 +8778,20 @@
                 <a:ea typeface="Amiri"/>
                 <a:cs typeface="Amiri"/>
               </a:rPr>
-              <a:t>معرفة أحكام الزينة المعاصرة في المذاهب الأربعة</a:t>
+              <a:t>بيان حكم أدوات التجميل المعاصرة للمرأة في المذاهب الأربعة</a:t>
             </a:r>
           </a:p>
           <a:p>
             <a:pPr algn="r" rtl="1">
               <a:lnSpc>
-                <a:spcPct val="120000"/>
+                <a:spcPct val="115000"/>
               </a:lnSpc>
               <a:spcAft>
-                <a:spcPts val="1800"/>
+                <a:spcPts val="1400"/>
               </a:spcAft>
             </a:pPr>
             <a:r>
-              <a:rPr sz="2400" b="0">
+              <a:rPr sz="2200" b="0">
                 <a:solidFill>
                   <a:srgbClr val="222222"/>
                 </a:solidFill>
@@ -8451,20 +8799,20 @@
                 <a:ea typeface="Amiri"/>
                 <a:cs typeface="Amiri"/>
               </a:rPr>
-              <a:t>بيان أحكام النوازل المتعلقة بزينة المرأة</a:t>
+              <a:t>معرفة حكم عمليات التجميل في المذاهب المعتمدة</a:t>
             </a:r>
           </a:p>
           <a:p>
             <a:pPr algn="r" rtl="1">
               <a:lnSpc>
-                <a:spcPct val="120000"/>
+                <a:spcPct val="115000"/>
               </a:lnSpc>
               <a:spcAft>
-                <a:spcPts val="1800"/>
+                <a:spcPts val="1400"/>
               </a:spcAft>
             </a:pPr>
             <a:r>
-              <a:rPr sz="2400" b="0">
+              <a:rPr sz="2200" b="0">
                 <a:solidFill>
                   <a:srgbClr val="222222"/>
                 </a:solidFill>
@@ -8472,20 +8820,20 @@
                 <a:ea typeface="Amiri"/>
                 <a:cs typeface="Amiri"/>
               </a:rPr>
-              <a:t>معرفة حكم العمليات وبيع الأدوات الممنوعة</a:t>
+              <a:t>معرفة حكم بيع أدوات التجميل في المذاهب الأربعة</a:t>
             </a:r>
           </a:p>
           <a:p>
             <a:pPr algn="r" rtl="1">
               <a:lnSpc>
-                <a:spcPct val="120000"/>
+                <a:spcPct val="115000"/>
               </a:lnSpc>
               <a:spcAft>
-                <a:spcPts val="1800"/>
+                <a:spcPts val="1400"/>
               </a:spcAft>
             </a:pPr>
             <a:r>
-              <a:rPr sz="2400" b="0">
+              <a:rPr sz="2200" b="0">
                 <a:solidFill>
                   <a:srgbClr val="222222"/>
                 </a:solidFill>
@@ -8493,7 +8841,7 @@
                 <a:ea typeface="Amiri"/>
                 <a:cs typeface="Amiri"/>
               </a:rPr>
-              <a:t>إدراك أثر الزينة على عقد النكاح</a:t>
+              <a:t>بيان الأثر المترتب على الزينة في عقد النكاح</a:t>
             </a:r>
           </a:p>
         </p:txBody>
@@ -8524,49 +8872,30 @@
         <p:nvPr/>
       </p:nvGrpSpPr>
       <p:grpSpPr/>
-      <p:sp>
-        <p:nvSpPr>
-          <p:cNvPr id="2" name="Rectangle 1"/>
-          <p:cNvSpPr/>
-          <p:nvPr/>
-        </p:nvSpPr>
-        <p:spPr>
-          <a:xfrm>
-            <a:off x="11917375" y="0"/>
-            <a:ext cx="274320" cy="6858000"/>
-          </a:xfrm>
-          <a:prstGeom prst="rect">
-            <a:avLst/>
-          </a:prstGeom>
-          <a:solidFill>
-            <a:srgbClr val="0F3D2E"/>
-          </a:solidFill>
-          <a:ln>
-            <a:noFill/>
-          </a:ln>
-        </p:spPr>
-        <p:style>
-          <a:lnRef idx="1">
-            <a:schemeClr val="accent1"/>
-          </a:lnRef>
-          <a:fillRef idx="3">
-            <a:schemeClr val="accent1"/>
-          </a:fillRef>
-          <a:effectRef idx="2">
-            <a:schemeClr val="accent1"/>
-          </a:effectRef>
-          <a:fontRef idx="minor">
-            <a:schemeClr val="lt1"/>
-          </a:fontRef>
-        </p:style>
-        <p:txBody>
-          <a:bodyPr rtlCol="0" anchor="ctr"/>
-          <a:lstStyle/>
-          <a:p>
-            <a:pPr algn="ctr"/>
-          </a:p>
-        </p:txBody>
-      </p:sp>
+      <p:pic>
+        <p:nvPicPr>
+          <p:cNvPr id="2" name="Picture 1" descr="pola-geometris.png"/>
+          <p:cNvPicPr>
+            <a:picLocks noChangeAspect="1"/>
+          </p:cNvPicPr>
+          <p:nvPr/>
+        </p:nvPicPr>
+        <p:blipFill>
+          <a:blip r:embed="rId2"/>
+          <a:stretch>
+            <a:fillRect/>
+          </a:stretch>
+        </p:blipFill>
+        <p:spPr>
+          <a:xfrm>
+            <a:off x="11368735" y="0"/>
+            <a:ext cx="822960" cy="6858000"/>
+          </a:xfrm>
+          <a:prstGeom prst="rect">
+            <a:avLst/>
+          </a:prstGeom>
+        </p:spPr>
+      </p:pic>
       <p:sp>
         <p:nvSpPr>
           <p:cNvPr id="3" name="Rectangle 2"/>
@@ -8575,7 +8904,7 @@
         </p:nvSpPr>
         <p:spPr>
           <a:xfrm>
-            <a:off x="11862511" y="0"/>
+            <a:off x="11313871" y="0"/>
             <a:ext cx="54864" cy="6858000"/>
           </a:xfrm>
           <a:prstGeom prst="rect">
@@ -8698,8 +9027,8 @@
         </p:nvSpPr>
         <p:spPr>
           <a:xfrm>
-            <a:off x="9448495" y="6400800"/>
-            <a:ext cx="2194560" cy="411480"/>
+            <a:off x="9082735" y="6400800"/>
+            <a:ext cx="2377440" cy="411480"/>
           </a:xfrm>
           <a:prstGeom prst="rect">
             <a:avLst/>
@@ -8736,7 +9065,7 @@
         <p:spPr>
           <a:xfrm>
             <a:off x="640080" y="411480"/>
-            <a:ext cx="10728655" cy="1188720"/>
+            <a:ext cx="10180015" cy="1280160"/>
           </a:xfrm>
           <a:prstGeom prst="rect">
             <a:avLst/>
@@ -8758,7 +9087,7 @@
               </a:spcAft>
             </a:pPr>
             <a:r>
-              <a:rPr sz="3400" b="1">
+              <a:rPr sz="3200" b="1">
                 <a:solidFill>
                   <a:srgbClr val="0F3D2E"/>
                 </a:solidFill>
@@ -8766,7 +9095,7 @@
                 <a:ea typeface="Amiri"/>
                 <a:cs typeface="Amiri"/>
               </a:rPr>
-              <a:t>خمس مشكلات استدعت البحث: نوازل، حصر، أزمنة، واردات، تكييف</a:t>
+              <a:t>الفوائد توازي الأهداف وتعمّق إدراك الأحكام والنوازل</a:t>
             </a:r>
           </a:p>
         </p:txBody>
@@ -8779,7 +9108,7 @@
         </p:nvSpPr>
         <p:spPr>
           <a:xfrm>
-            <a:off x="6010351" y="1600200"/>
+            <a:off x="5461711" y="1645920"/>
             <a:ext cx="5852160" cy="54864"/>
           </a:xfrm>
           <a:prstGeom prst="rect">
@@ -8822,8 +9151,8 @@
         </p:nvSpPr>
         <p:spPr>
           <a:xfrm>
-            <a:off x="822960" y="1920240"/>
-            <a:ext cx="10362895" cy="4114800"/>
+            <a:off x="822960" y="1828800"/>
+            <a:ext cx="10088575" cy="4206240"/>
           </a:xfrm>
           <a:prstGeom prst="rect">
             <a:avLst/>
@@ -8838,14 +9167,14 @@
           <a:p>
             <a:pPr algn="r" rtl="1">
               <a:lnSpc>
-                <a:spcPct val="120000"/>
+                <a:spcPct val="115000"/>
               </a:lnSpc>
               <a:spcAft>
-                <a:spcPts val="1800"/>
+                <a:spcPts val="1400"/>
               </a:spcAft>
             </a:pPr>
             <a:r>
-              <a:rPr sz="2400" b="0">
+              <a:rPr sz="2200" b="0">
                 <a:solidFill>
                   <a:srgbClr val="222222"/>
                 </a:solidFill>
@@ -8853,20 +9182,20 @@
                 <a:ea typeface="Amiri"/>
                 <a:cs typeface="Amiri"/>
               </a:rPr>
-              <a:t>نوازل معاصرة لم يفصّلها الفقهاء قديمًا</a:t>
+              <a:t>معرفة أحكام الزينة المعاصرة في المذاهب الأربعة</a:t>
             </a:r>
           </a:p>
           <a:p>
             <a:pPr algn="r" rtl="1">
               <a:lnSpc>
-                <a:spcPct val="120000"/>
+                <a:spcPct val="115000"/>
               </a:lnSpc>
               <a:spcAft>
-                <a:spcPts val="1800"/>
+                <a:spcPts val="1400"/>
               </a:spcAft>
             </a:pPr>
             <a:r>
-              <a:rPr sz="2400" b="0">
+              <a:rPr sz="2200" b="0">
                 <a:solidFill>
                   <a:srgbClr val="222222"/>
                 </a:solidFill>
@@ -8874,20 +9203,20 @@
                 <a:ea typeface="Amiri"/>
                 <a:cs typeface="Amiri"/>
               </a:rPr>
-              <a:t>صعوبة حصر وسائل الزينة لاختلاط العادات</a:t>
+              <a:t>بيان أحكام النوازل المتعلقة بزينة المرأة</a:t>
             </a:r>
           </a:p>
           <a:p>
             <a:pPr algn="r" rtl="1">
               <a:lnSpc>
-                <a:spcPct val="120000"/>
+                <a:spcPct val="115000"/>
               </a:lnSpc>
               <a:spcAft>
-                <a:spcPts val="1800"/>
+                <a:spcPts val="1400"/>
               </a:spcAft>
             </a:pPr>
             <a:r>
-              <a:rPr sz="2400" b="0">
+              <a:rPr sz="2200" b="0">
                 <a:solidFill>
                   <a:srgbClr val="222222"/>
                 </a:solidFill>
@@ -8895,20 +9224,20 @@
                 <a:ea typeface="Amiri"/>
                 <a:cs typeface="Amiri"/>
               </a:rPr>
-              <a:t>اختلاف الأزمنة يستدعي نظر القواعد والضوابط</a:t>
+              <a:t>معرفة حكم عمليات التجميل وبيع الأدوات الممنوعة</a:t>
             </a:r>
           </a:p>
           <a:p>
             <a:pPr algn="r" rtl="1">
               <a:lnSpc>
-                <a:spcPct val="120000"/>
+                <a:spcPct val="115000"/>
               </a:lnSpc>
               <a:spcAft>
-                <a:spcPts val="1800"/>
+                <a:spcPts val="1400"/>
               </a:spcAft>
             </a:pPr>
             <a:r>
-              <a:rPr sz="2400" b="0">
+              <a:rPr sz="2200" b="0">
                 <a:solidFill>
                   <a:srgbClr val="222222"/>
                 </a:solidFill>
@@ -8916,7 +9245,7 @@
                 <a:ea typeface="Amiri"/>
                 <a:cs typeface="Amiri"/>
               </a:rPr>
-              <a:t>ورود أدوات من الغرب دون نظر شرعي واختلاف التكييف</a:t>
+              <a:t>إدراك أثر الزينة على عقد النكاح</a:t>
             </a:r>
           </a:p>
         </p:txBody>
@@ -8947,49 +9276,30 @@
         <p:nvPr/>
       </p:nvGrpSpPr>
       <p:grpSpPr/>
-      <p:sp>
-        <p:nvSpPr>
-          <p:cNvPr id="2" name="Rectangle 1"/>
-          <p:cNvSpPr/>
-          <p:nvPr/>
-        </p:nvSpPr>
-        <p:spPr>
-          <a:xfrm>
-            <a:off x="11917375" y="0"/>
-            <a:ext cx="274320" cy="6858000"/>
-          </a:xfrm>
-          <a:prstGeom prst="rect">
-            <a:avLst/>
-          </a:prstGeom>
-          <a:solidFill>
-            <a:srgbClr val="0F3D2E"/>
-          </a:solidFill>
-          <a:ln>
-            <a:noFill/>
-          </a:ln>
-        </p:spPr>
-        <p:style>
-          <a:lnRef idx="1">
-            <a:schemeClr val="accent1"/>
-          </a:lnRef>
-          <a:fillRef idx="3">
-            <a:schemeClr val="accent1"/>
-          </a:fillRef>
-          <a:effectRef idx="2">
-            <a:schemeClr val="accent1"/>
-          </a:effectRef>
-          <a:fontRef idx="minor">
-            <a:schemeClr val="lt1"/>
-          </a:fontRef>
-        </p:style>
-        <p:txBody>
-          <a:bodyPr rtlCol="0" anchor="ctr"/>
-          <a:lstStyle/>
-          <a:p>
-            <a:pPr algn="ctr"/>
-          </a:p>
-        </p:txBody>
-      </p:sp>
+      <p:pic>
+        <p:nvPicPr>
+          <p:cNvPr id="2" name="Picture 1" descr="pola-geometris.png"/>
+          <p:cNvPicPr>
+            <a:picLocks noChangeAspect="1"/>
+          </p:cNvPicPr>
+          <p:nvPr/>
+        </p:nvPicPr>
+        <p:blipFill>
+          <a:blip r:embed="rId2"/>
+          <a:stretch>
+            <a:fillRect/>
+          </a:stretch>
+        </p:blipFill>
+        <p:spPr>
+          <a:xfrm>
+            <a:off x="11368735" y="0"/>
+            <a:ext cx="822960" cy="6858000"/>
+          </a:xfrm>
+          <a:prstGeom prst="rect">
+            <a:avLst/>
+          </a:prstGeom>
+        </p:spPr>
+      </p:pic>
       <p:sp>
         <p:nvSpPr>
           <p:cNvPr id="3" name="Rectangle 2"/>
@@ -8998,7 +9308,7 @@
         </p:nvSpPr>
         <p:spPr>
           <a:xfrm>
-            <a:off x="11862511" y="0"/>
+            <a:off x="11313871" y="0"/>
             <a:ext cx="54864" cy="6858000"/>
           </a:xfrm>
           <a:prstGeom prst="rect">
@@ -9121,8 +9431,8 @@
         </p:nvSpPr>
         <p:spPr>
           <a:xfrm>
-            <a:off x="9448495" y="6400800"/>
-            <a:ext cx="2194560" cy="411480"/>
+            <a:off x="9082735" y="6400800"/>
+            <a:ext cx="2377440" cy="411480"/>
           </a:xfrm>
           <a:prstGeom prst="rect">
             <a:avLst/>
@@ -9145,7 +9455,7 @@
                 <a:ea typeface="Amiri"/>
                 <a:cs typeface="Amiri"/>
               </a:rPr>
-              <a:t>ص٢٣·٨٨</a:t>
+              <a:t>ص٢١</a:t>
             </a:r>
           </a:p>
         </p:txBody>
@@ -9159,7 +9469,7 @@
         <p:spPr>
           <a:xfrm>
             <a:off x="640080" y="411480"/>
-            <a:ext cx="10728655" cy="1188720"/>
+            <a:ext cx="10180015" cy="1280160"/>
           </a:xfrm>
           <a:prstGeom prst="rect">
             <a:avLst/>
@@ -9181,7 +9491,7 @@
               </a:spcAft>
             </a:pPr>
             <a:r>
-              <a:rPr sz="3400" b="1">
+              <a:rPr sz="3200" b="1">
                 <a:solidFill>
                   <a:srgbClr val="0F3D2E"/>
                 </a:solidFill>
@@ -9189,7 +9499,7 @@
                 <a:ea typeface="Amiri"/>
                 <a:cs typeface="Amiri"/>
               </a:rPr>
-              <a:t>بحث فقهي مقارن بثلاثة مناهج: وصفي، استقرائي، استنباطي</a:t>
+              <a:t>خمس مشكلات استدعت البحث: نوازل، حصر، أزمنة، واردات، تكييف</a:t>
             </a:r>
           </a:p>
         </p:txBody>
@@ -9202,7 +9512,7 @@
         </p:nvSpPr>
         <p:spPr>
           <a:xfrm>
-            <a:off x="6010351" y="1600200"/>
+            <a:off x="5461711" y="1645920"/>
             <a:ext cx="5852160" cy="54864"/>
           </a:xfrm>
           <a:prstGeom prst="rect">
@@ -9245,8 +9555,8 @@
         </p:nvSpPr>
         <p:spPr>
           <a:xfrm>
-            <a:off x="822960" y="1920240"/>
-            <a:ext cx="10362895" cy="4114800"/>
+            <a:off x="822960" y="1828800"/>
+            <a:ext cx="10088575" cy="4206240"/>
           </a:xfrm>
           <a:prstGeom prst="rect">
             <a:avLst/>
@@ -9261,14 +9571,14 @@
           <a:p>
             <a:pPr algn="r" rtl="1">
               <a:lnSpc>
-                <a:spcPct val="120000"/>
+                <a:spcPct val="115000"/>
               </a:lnSpc>
               <a:spcAft>
-                <a:spcPts val="1800"/>
+                <a:spcPts val="1400"/>
               </a:spcAft>
             </a:pPr>
             <a:r>
-              <a:rPr sz="2600" b="0">
+              <a:rPr sz="2200" b="0">
                 <a:solidFill>
                   <a:srgbClr val="222222"/>
                 </a:solidFill>
@@ -9276,20 +9586,20 @@
                 <a:ea typeface="Amiri"/>
                 <a:cs typeface="Amiri"/>
               </a:rPr>
-              <a:t>وصفي مقارن: تتبّع أقوال المذاهب ومقارنتها</a:t>
+              <a:t>نوازل معاصرة لم يفصّلها الفقهاء قديمًا</a:t>
             </a:r>
           </a:p>
           <a:p>
             <a:pPr algn="r" rtl="1">
               <a:lnSpc>
-                <a:spcPct val="120000"/>
+                <a:spcPct val="115000"/>
               </a:lnSpc>
               <a:spcAft>
-                <a:spcPts val="1800"/>
+                <a:spcPts val="1400"/>
               </a:spcAft>
             </a:pPr>
             <a:r>
-              <a:rPr sz="2600" b="0">
+              <a:rPr sz="2200" b="0">
                 <a:solidFill>
                   <a:srgbClr val="222222"/>
                 </a:solidFill>
@@ -9297,20 +9607,20 @@
                 <a:ea typeface="Amiri"/>
                 <a:cs typeface="Amiri"/>
               </a:rPr>
-              <a:t>استقرائي: استقراء النوازل والدراسات المعاصرة</a:t>
+              <a:t>صعوبة حصر وسائل الزينة لاختلاط العادات</a:t>
             </a:r>
           </a:p>
           <a:p>
             <a:pPr algn="r" rtl="1">
               <a:lnSpc>
-                <a:spcPct val="120000"/>
+                <a:spcPct val="115000"/>
               </a:lnSpc>
               <a:spcAft>
-                <a:spcPts val="1800"/>
+                <a:spcPts val="1400"/>
               </a:spcAft>
             </a:pPr>
             <a:r>
-              <a:rPr sz="2600" b="0">
+              <a:rPr sz="2200" b="0">
                 <a:solidFill>
                   <a:srgbClr val="222222"/>
                 </a:solidFill>
@@ -9318,7 +9628,49 @@
                 <a:ea typeface="Amiri"/>
                 <a:cs typeface="Amiri"/>
               </a:rPr>
-              <a:t>استنباطي: استنباط الحكم من النصوص والقواعد</a:t>
+              <a:t>اختلاف الأزمنة يستدعي نظر القواعد والضوابط</a:t>
+            </a:r>
+          </a:p>
+          <a:p>
+            <a:pPr algn="r" rtl="1">
+              <a:lnSpc>
+                <a:spcPct val="115000"/>
+              </a:lnSpc>
+              <a:spcAft>
+                <a:spcPts val="1400"/>
+              </a:spcAft>
+            </a:pPr>
+            <a:r>
+              <a:rPr sz="2200" b="0">
+                <a:solidFill>
+                  <a:srgbClr val="222222"/>
+                </a:solidFill>
+                <a:latin typeface="Amiri"/>
+                <a:ea typeface="Amiri"/>
+                <a:cs typeface="Amiri"/>
+              </a:rPr>
+              <a:t>ورود أدوات من الغرب دون نظر شرعي</a:t>
+            </a:r>
+          </a:p>
+          <a:p>
+            <a:pPr algn="r" rtl="1">
+              <a:lnSpc>
+                <a:spcPct val="115000"/>
+              </a:lnSpc>
+              <a:spcAft>
+                <a:spcPts val="1400"/>
+              </a:spcAft>
+            </a:pPr>
+            <a:r>
+              <a:rPr sz="2200" b="0">
+                <a:solidFill>
+                  <a:srgbClr val="222222"/>
+                </a:solidFill>
+                <a:latin typeface="Amiri"/>
+                <a:ea typeface="Amiri"/>
+                <a:cs typeface="Amiri"/>
+              </a:rPr>
+              <a:t>اختلاف التكييف الفقهي لوسائل الزينة</a:t>
             </a:r>
           </a:p>
         </p:txBody>
@@ -9349,49 +9701,30 @@
         <p:nvPr/>
       </p:nvGrpSpPr>
       <p:grpSpPr/>
-      <p:sp>
-        <p:nvSpPr>
-          <p:cNvPr id="2" name="Rectangle 1"/>
-          <p:cNvSpPr/>
-          <p:nvPr/>
-        </p:nvSpPr>
-        <p:spPr>
-          <a:xfrm>
-            <a:off x="11917375" y="0"/>
-            <a:ext cx="274320" cy="6858000"/>
-          </a:xfrm>
-          <a:prstGeom prst="rect">
-            <a:avLst/>
-          </a:prstGeom>
-          <a:solidFill>
-            <a:srgbClr val="0F3D2E"/>
-          </a:solidFill>
-          <a:ln>
-            <a:noFill/>
-          </a:ln>
-        </p:spPr>
-        <p:style>
-          <a:lnRef idx="1">
-            <a:schemeClr val="accent1"/>
-          </a:lnRef>
-          <a:fillRef idx="3">
-            <a:schemeClr val="accent1"/>
-          </a:fillRef>
-          <a:effectRef idx="2">
-            <a:schemeClr val="accent1"/>
-          </a:effectRef>
-          <a:fontRef idx="minor">
-            <a:schemeClr val="lt1"/>
-          </a:fontRef>
-        </p:style>
-        <p:txBody>
-          <a:bodyPr rtlCol="0" anchor="ctr"/>
-          <a:lstStyle/>
-          <a:p>
-            <a:pPr algn="ctr"/>
-          </a:p>
-        </p:txBody>
-      </p:sp>
+      <p:pic>
+        <p:nvPicPr>
+          <p:cNvPr id="2" name="Picture 1" descr="pola-geometris.png"/>
+          <p:cNvPicPr>
+            <a:picLocks noChangeAspect="1"/>
+          </p:cNvPicPr>
+          <p:nvPr/>
+        </p:nvPicPr>
+        <p:blipFill>
+          <a:blip r:embed="rId2"/>
+          <a:stretch>
+            <a:fillRect/>
+          </a:stretch>
+        </p:blipFill>
+        <p:spPr>
+          <a:xfrm>
+            <a:off x="11368735" y="0"/>
+            <a:ext cx="822960" cy="6858000"/>
+          </a:xfrm>
+          <a:prstGeom prst="rect">
+            <a:avLst/>
+          </a:prstGeom>
+        </p:spPr>
+      </p:pic>
       <p:sp>
         <p:nvSpPr>
           <p:cNvPr id="3" name="Rectangle 2"/>
@@ -9400,7 +9733,7 @@
         </p:nvSpPr>
         <p:spPr>
           <a:xfrm>
-            <a:off x="11862511" y="0"/>
+            <a:off x="11313871" y="0"/>
             <a:ext cx="54864" cy="6858000"/>
           </a:xfrm>
           <a:prstGeom prst="rect">
@@ -9523,8 +9856,8 @@
         </p:nvSpPr>
         <p:spPr>
           <a:xfrm>
-            <a:off x="9448495" y="6400800"/>
-            <a:ext cx="2194560" cy="411480"/>
+            <a:off x="9082735" y="6400800"/>
+            <a:ext cx="2377440" cy="411480"/>
           </a:xfrm>
           <a:prstGeom prst="rect">
             <a:avLst/>
@@ -9547,7 +9880,7 @@
                 <a:ea typeface="Amiri"/>
                 <a:cs typeface="Amiri"/>
               </a:rPr>
-              <a:t>ص٨٩</a:t>
+              <a:t>ص٢٣·٨٨</a:t>
             </a:r>
           </a:p>
         </p:txBody>
@@ -9561,7 +9894,7 @@
         <p:spPr>
           <a:xfrm>
             <a:off x="640080" y="411480"/>
-            <a:ext cx="10728655" cy="1188720"/>
+            <a:ext cx="10180015" cy="1280160"/>
           </a:xfrm>
           <a:prstGeom prst="rect">
             <a:avLst/>
@@ -9583,7 +9916,7 @@
               </a:spcAft>
             </a:pPr>
             <a:r>
-              <a:rPr sz="3400" b="1">
+              <a:rPr sz="3200" b="1">
                 <a:solidFill>
                   <a:srgbClr val="0F3D2E"/>
                 </a:solidFill>
@@ -9591,7 +9924,7 @@
                 <a:ea typeface="Amiri"/>
                 <a:cs typeface="Amiri"/>
               </a:rPr>
-              <a:t>جمعٌ ومعالجةٌ وتحقق: من التتبّع إلى التطبيق الموثّق</a:t>
+              <a:t>بحث فقهي مقارن بثلاثة مناهج متكاملة</a:t>
             </a:r>
           </a:p>
         </p:txBody>
@@ -9604,7 +9937,7 @@
         </p:nvSpPr>
         <p:spPr>
           <a:xfrm>
-            <a:off x="6010351" y="1600200"/>
+            <a:off x="5461711" y="1645920"/>
             <a:ext cx="5852160" cy="54864"/>
           </a:xfrm>
           <a:prstGeom prst="rect">
@@ -9647,8 +9980,8 @@
         </p:nvSpPr>
         <p:spPr>
           <a:xfrm>
-            <a:off x="822960" y="1920240"/>
-            <a:ext cx="10362895" cy="4114800"/>
+            <a:off x="822960" y="1828800"/>
+            <a:ext cx="10088575" cy="4206240"/>
           </a:xfrm>
           <a:prstGeom prst="rect">
             <a:avLst/>
@@ -9663,14 +9996,14 @@
           <a:p>
             <a:pPr algn="r" rtl="1">
               <a:lnSpc>
-                <a:spcPct val="120000"/>
+                <a:spcPct val="115000"/>
               </a:lnSpc>
               <a:spcAft>
-                <a:spcPts val="1800"/>
+                <a:spcPts val="1400"/>
               </a:spcAft>
             </a:pPr>
             <a:r>
-              <a:rPr sz="2600" b="0">
+              <a:rPr sz="2400" b="0">
                 <a:solidFill>
                   <a:srgbClr val="222222"/>
                 </a:solidFill>
@@ -9678,20 +10011,20 @@
                 <a:ea typeface="Amiri"/>
                 <a:cs typeface="Amiri"/>
               </a:rPr>
-              <a:t>جمع: تتبّع أقوال المذاهب وجمع النوازل وترتيبها</a:t>
+              <a:t>وصفي مقارن: تتبّع أقوال المذاهب من كتبها المعتمدة ومقارنتها</a:t>
             </a:r>
           </a:p>
           <a:p>
             <a:pPr algn="r" rtl="1">
               <a:lnSpc>
-                <a:spcPct val="120000"/>
+                <a:spcPct val="115000"/>
               </a:lnSpc>
               <a:spcAft>
-                <a:spcPts val="1800"/>
+                <a:spcPts val="1400"/>
               </a:spcAft>
             </a:pPr>
             <a:r>
-              <a:rPr sz="2600" b="0">
+              <a:rPr sz="2400" b="0">
                 <a:solidFill>
                   <a:srgbClr val="222222"/>
                 </a:solidFill>
@@ -9699,20 +10032,20 @@
                 <a:ea typeface="Amiri"/>
                 <a:cs typeface="Amiri"/>
               </a:rPr>
-              <a:t>معالجة: مقارنة الأقوال وذكر الأدلة ثم التطبيق</a:t>
+              <a:t>استقرائي: استقراء النوازل والدراسات المعاصرة</a:t>
             </a:r>
           </a:p>
           <a:p>
             <a:pPr algn="r" rtl="1">
               <a:lnSpc>
-                <a:spcPct val="120000"/>
+                <a:spcPct val="115000"/>
               </a:lnSpc>
               <a:spcAft>
-                <a:spcPts val="1800"/>
+                <a:spcPts val="1400"/>
               </a:spcAft>
             </a:pPr>
             <a:r>
-              <a:rPr sz="2600" b="0">
+              <a:rPr sz="2400" b="0">
                 <a:solidFill>
                   <a:srgbClr val="222222"/>
                 </a:solidFill>
@@ -9720,7 +10053,7 @@
                 <a:ea typeface="Amiri"/>
                 <a:cs typeface="Amiri"/>
               </a:rPr>
-              <a:t>تحقق: عرض المعلومة على عدة مصادر حتى يتفق المعنى</a:t>
+              <a:t>استنباطي: استنباط الحكم من النصوص والقواعد والضوابط</a:t>
             </a:r>
           </a:p>
         </p:txBody>

</xml_diff>

<commit_message>
v4 + pengetahuan desain: perbaiki gepeng/bidi, mode paragraf, mandat riset
- _sistem/02_KNOWLEDGE_DESIGN_VISUAL.md: sintesis riset desain visual (5 sumber) +
  aturan aspect-ratio, bidi/tanda-baca Arab, mode bullet-vs-paragraf, checklist
  multi-skill, MANDAT riset visual. 01 merujuk 02.
- build_deck_v4.py: pita gambar di-CROP ber-aspek sama (tidak gepeng); hapus
  kurung ASCII/em-dash/+ dari teks Arab; slide naratif (S2,S12) pakai PARAGRAF.
- Verifikasi: crop_right=0.933 (aspek cocok), 0 karakter bidi bermasalah, 14 slide.

Co-authored-by: arena-agent <297053741+arena-agent@users.noreply.github.com>
</commit_message>
<xml_diff>
--- a/sistem-presentasi/deck-aktif/presentasi-tesis-fikih-hiasan-wanita/keluaran/presentasi-tesis-fikih-hiasan-wanita.pptx
+++ b/sistem-presentasi/deck-aktif/presentasi-tesis-fikih-hiasan-wanita/keluaran/presentasi-tesis-fikih-hiasan-wanita.pptx
@@ -515,7 +515,7 @@
           <a:lstStyle/>
           <a:p>
             <a:r>
-              <a:t>Pembuka. Pembimbing/universitas kosong (tidak ada di bahan) - jangan dikarang.</a:t>
+              <a:t>Pembuka. Pembimbing/universitas kosong - jangan dikarang.</a:t>
             </a:r>
           </a:p>
         </p:txBody>
@@ -585,7 +585,7 @@
           <a:lstStyle/>
           <a:p>
             <a:r>
-              <a:t>Prosedur hal 89 (Far'2+3+4).</a:t>
+              <a:t>Prosedur hal 89.</a:t>
             </a:r>
           </a:p>
         </p:txBody>
@@ -655,7 +655,7 @@
           <a:lstStyle/>
           <a:p>
             <a:r>
-              <a:t>العلة hal 66-67; tabel perbandingan mazhab.</a:t>
+              <a:t>العلة hal 66-67.</a:t>
             </a:r>
           </a:p>
         </p:txBody>
@@ -725,7 +725,7 @@
           <a:lstStyle/>
           <a:p>
             <a:r>
-              <a:t>Kesimpulan dari ملخص hal 6; خاتمة hal 151 = doa.</a:t>
+              <a:t>Kesimpulan sebagai PARAGRAF; خاتمة hal 151 = doa.</a:t>
             </a:r>
           </a:p>
         </p:txBody>
@@ -865,7 +865,7 @@
           <a:lstStyle/>
           <a:p>
             <a:r>
-              <a:t>خاتمة hal 151 = doa penutup.</a:t>
+              <a:t>خاتمة hal 151.</a:t>
             </a:r>
           </a:p>
         </p:txBody>
@@ -935,7 +935,7 @@
           <a:lstStyle/>
           <a:p>
             <a:r>
-              <a:t>Temuan utama hal 6: tiga illat menjadi poros hukum.</a:t>
+              <a:t>Temuan utama hal 6 disajikan sebagai PARAGRAF ringkas (mode naratif).</a:t>
             </a:r>
           </a:p>
         </p:txBody>
@@ -1005,7 +1005,7 @@
           <a:lstStyle/>
           <a:p>
             <a:r>
-              <a:t>Hal 6: rincian per jenis hiasan dan ضابط-nya.</a:t>
+              <a:t>Hal 6: rincian per jenis.</a:t>
             </a:r>
           </a:p>
         </p:txBody>
@@ -1075,7 +1075,7 @@
           <a:lstStyle/>
           <a:p>
             <a:r>
-              <a:t>Hal 6: operasi kecantikan boleh bila kebutuhan sah, tidak mengubah ciptaan.</a:t>
+              <a:t>Hal 6.</a:t>
             </a:r>
           </a:p>
         </p:txBody>
@@ -1145,7 +1145,7 @@
           <a:lstStyle/>
           <a:p>
             <a:r>
-              <a:t>Hal 6: hiasan memengaruhi pandangan dalam akad nikah; rincian per mazhab.</a:t>
+              <a:t>Hal 6.</a:t>
             </a:r>
           </a:p>
         </p:txBody>
@@ -4449,6 +4449,7 @@
         </p:nvPicPr>
         <p:blipFill>
           <a:blip r:embed="rId2"/>
+          <a:srcRect r="89581"/>
           <a:stretch>
             <a:fillRect/>
           </a:stretch>
@@ -4767,6 +4768,7 @@
         </p:nvPicPr>
         <p:blipFill>
           <a:blip r:embed="rId2"/>
+          <a:srcRect r="93302"/>
           <a:stretch>
             <a:fillRect/>
           </a:stretch>
@@ -5150,6 +5152,7 @@
         </p:nvPicPr>
         <p:blipFill>
           <a:blip r:embed="rId2"/>
+          <a:srcRect r="93302"/>
           <a:stretch>
             <a:fillRect/>
           </a:stretch>
@@ -5363,7 +5366,7 @@
                 <a:ea typeface="Amiri"/>
                 <a:cs typeface="Amiri"/>
               </a:rPr>
-              <a:t>اتفقوا على الجواز بغير شعر الآدمي، واختلفوا في العلة — والراجح التدليس</a:t>
+              <a:t>اتفقوا على الجواز بغير شعر الآدمي واختلفوا في العلة، والراجح التدليس</a:t>
             </a:r>
           </a:p>
         </p:txBody>
@@ -5566,7 +5569,7 @@
                           <a:ea typeface="Amiri"/>
                           <a:cs typeface="Amiri"/>
                         </a:rPr>
-                        <a:t>مركّبة: تغيير خلق الله + التدليس</a:t>
+                        <a:t>مركّبة: تغيير خلق الله والتدليس</a:t>
                       </a:r>
                     </a:p>
                   </a:txBody>
@@ -5612,7 +5615,7 @@
                           <a:ea typeface="Amiri"/>
                           <a:cs typeface="Amiri"/>
                         </a:rPr>
-                        <a:t>مركّبة: الكرامة + تحريم استعمال النجس</a:t>
+                        <a:t>مركّبة: الكرامة وتحريم استعمال النجس</a:t>
                       </a:r>
                     </a:p>
                   </a:txBody>
@@ -5704,7 +5707,7 @@
                           <a:ea typeface="Amiri"/>
                           <a:cs typeface="Amiri"/>
                         </a:rPr>
-                        <a:t>الزور والتدليس (حديث المرأة)</a:t>
+                        <a:t>الزور والتدليس؛ لحديث المرأة</a:t>
                       </a:r>
                     </a:p>
                   </a:txBody>
@@ -5755,6 +5758,7 @@
         </p:nvPicPr>
         <p:blipFill>
           <a:blip r:embed="rId2"/>
+          <a:srcRect r="93302"/>
           <a:stretch>
             <a:fillRect/>
           </a:stretch>
@@ -6024,8 +6028,8 @@
         </p:nvSpPr>
         <p:spPr>
           <a:xfrm>
-            <a:off x="822960" y="1828800"/>
-            <a:ext cx="10088575" cy="4206240"/>
+            <a:off x="822960" y="1920240"/>
+            <a:ext cx="10088575" cy="4023360"/>
           </a:xfrm>
           <a:prstGeom prst="rect">
             <a:avLst/>
@@ -6040,10 +6044,10 @@
           <a:p>
             <a:pPr algn="r" rtl="1">
               <a:lnSpc>
-                <a:spcPct val="115000"/>
+                <a:spcPct val="140000"/>
               </a:lnSpc>
               <a:spcAft>
-                <a:spcPts val="1400"/>
+                <a:spcPts val="0"/>
               </a:spcAft>
             </a:pPr>
             <a:r>
@@ -6055,49 +6059,7 @@
                 <a:ea typeface="Amiri"/>
                 <a:cs typeface="Amiri"/>
               </a:rPr>
-              <a:t>التحريم عند تغيير الخلق أو التدليس أو الضرر</a:t>
-            </a:r>
-          </a:p>
-          <a:p>
-            <a:pPr algn="r" rtl="1">
-              <a:lnSpc>
-                <a:spcPct val="115000"/>
-              </a:lnSpc>
-              <a:spcAft>
-                <a:spcPts val="1400"/>
-              </a:spcAft>
-            </a:pPr>
-            <a:r>
-              <a:rPr sz="2400" b="0">
-                <a:solidFill>
-                  <a:srgbClr val="222222"/>
-                </a:solidFill>
-                <a:latin typeface="Amiri"/>
-                <a:ea typeface="Amiri"/>
-                <a:cs typeface="Amiri"/>
-              </a:rPr>
-              <a:t>جواز العمليات للحاجة، والوصل بغير شعر الآدمي بضوابطها</a:t>
-            </a:r>
-          </a:p>
-          <a:p>
-            <a:pPr algn="r" rtl="1">
-              <a:lnSpc>
-                <a:spcPct val="115000"/>
-              </a:lnSpc>
-              <a:spcAft>
-                <a:spcPts val="1400"/>
-              </a:spcAft>
-            </a:pPr>
-            <a:r>
-              <a:rPr sz="2400" b="0">
-                <a:solidFill>
-                  <a:srgbClr val="222222"/>
-                </a:solidFill>
-                <a:latin typeface="Amiri"/>
-                <a:ea typeface="Amiri"/>
-                <a:cs typeface="Amiri"/>
-              </a:rPr>
-              <a:t>ترتيب أثر الزينة على النظر في عقد النكاح</a:t>
+              <a:t>خلاصة البحث أن التحريم يدور مع علله الثلاث وجودًا وعدمًا، وأن العمليات تجوز للحاجة والوصل يجوز بغير شعر الآدمي بضوابطهما، وأن للزينة أثرًا يُرتَّب على النظر في عقد النكاح وفق المذاهب.</a:t>
             </a:r>
           </a:p>
         </p:txBody>
@@ -6138,6 +6100,7 @@
         </p:nvPicPr>
         <p:blipFill>
           <a:blip r:embed="rId2"/>
+          <a:srcRect r="93302"/>
           <a:stretch>
             <a:fillRect/>
           </a:stretch>
@@ -6521,6 +6484,7 @@
         </p:nvPicPr>
         <p:blipFill>
           <a:blip r:embed="rId2"/>
+          <a:srcRect r="93302"/>
           <a:stretch>
             <a:fillRect/>
           </a:stretch>
@@ -6883,6 +6847,7 @@
         </p:nvPicPr>
         <p:blipFill>
           <a:blip r:embed="rId2"/>
+          <a:srcRect r="93302"/>
           <a:stretch>
             <a:fillRect/>
           </a:stretch>
@@ -7152,8 +7117,8 @@
         </p:nvSpPr>
         <p:spPr>
           <a:xfrm>
-            <a:off x="822960" y="1828800"/>
-            <a:ext cx="10088575" cy="4206240"/>
+            <a:off x="822960" y="1920240"/>
+            <a:ext cx="10088575" cy="4023360"/>
           </a:xfrm>
           <a:prstGeom prst="rect">
             <a:avLst/>
@@ -7168,10 +7133,10 @@
           <a:p>
             <a:pPr algn="r" rtl="1">
               <a:lnSpc>
-                <a:spcPct val="115000"/>
+                <a:spcPct val="140000"/>
               </a:lnSpc>
               <a:spcAft>
-                <a:spcPts val="1400"/>
+                <a:spcPts val="0"/>
               </a:spcAft>
             </a:pPr>
             <a:r>
@@ -7183,112 +7148,7 @@
                 <a:ea typeface="Amiri"/>
                 <a:cs typeface="Amiri"/>
               </a:rPr>
-              <a:t>الأصل التحريم عند تحقق إحدى العلل الثلاث في وسيلة الزينة</a:t>
-            </a:r>
-          </a:p>
-          <a:p>
-            <a:pPr algn="r" rtl="1">
-              <a:lnSpc>
-                <a:spcPct val="115000"/>
-              </a:lnSpc>
-              <a:spcAft>
-                <a:spcPts val="1400"/>
-              </a:spcAft>
-            </a:pPr>
-            <a:r>
-              <a:rPr sz="2400" b="0">
-                <a:solidFill>
-                  <a:srgbClr val="222222"/>
-                </a:solidFill>
-                <a:latin typeface="Amiri"/>
-                <a:ea typeface="Amiri"/>
-                <a:cs typeface="Amiri"/>
-              </a:rPr>
-              <a:t>الجواز مشروط بانتفاء التغيير والتدليس والضرر</a:t>
-            </a:r>
-          </a:p>
-          <a:p>
-            <a:pPr algn="r" rtl="1" lvl="1">
-              <a:lnSpc>
-                <a:spcPct val="115000"/>
-              </a:lnSpc>
-              <a:spcAft>
-                <a:spcPts val="800"/>
-              </a:spcAft>
-            </a:pPr>
-            <a:r>
-              <a:rPr sz="2000" b="0">
-                <a:solidFill>
-                  <a:srgbClr val="444444"/>
-                </a:solidFill>
-                <a:latin typeface="Amiri"/>
-                <a:ea typeface="Amiri"/>
-                <a:cs typeface="Amiri"/>
-              </a:rPr>
-              <a:t>تغيير خلق الله: كالنمص والوشم وما يغيّر الخلقة</a:t>
-            </a:r>
-          </a:p>
-          <a:p>
-            <a:pPr algn="r" rtl="1" lvl="1">
-              <a:lnSpc>
-                <a:spcPct val="115000"/>
-              </a:lnSpc>
-              <a:spcAft>
-                <a:spcPts val="800"/>
-              </a:spcAft>
-            </a:pPr>
-            <a:r>
-              <a:rPr sz="2000" b="0">
-                <a:solidFill>
-                  <a:srgbClr val="444444"/>
-                </a:solidFill>
-                <a:latin typeface="Amiri"/>
-                <a:ea typeface="Amiri"/>
-                <a:cs typeface="Amiri"/>
-              </a:rPr>
-              <a:t>التدليس: كإظهار ما ليس حقيقة، ومنه الوصل</a:t>
-            </a:r>
-          </a:p>
-          <a:p>
-            <a:pPr algn="r" rtl="1" lvl="1">
-              <a:lnSpc>
-                <a:spcPct val="115000"/>
-              </a:lnSpc>
-              <a:spcAft>
-                <a:spcPts val="800"/>
-              </a:spcAft>
-            </a:pPr>
-            <a:r>
-              <a:rPr sz="2000" b="0">
-                <a:solidFill>
-                  <a:srgbClr val="444444"/>
-                </a:solidFill>
-                <a:latin typeface="Amiri"/>
-                <a:ea typeface="Amiri"/>
-                <a:cs typeface="Amiri"/>
-              </a:rPr>
-              <a:t>الضرر: كل ما أضرّ بالبدن امتنع</a:t>
-            </a:r>
-          </a:p>
-          <a:p>
-            <a:pPr algn="r" rtl="1">
-              <a:lnSpc>
-                <a:spcPct val="115000"/>
-              </a:lnSpc>
-              <a:spcAft>
-                <a:spcPts val="1400"/>
-              </a:spcAft>
-            </a:pPr>
-            <a:r>
-              <a:rPr sz="2400" b="0">
-                <a:solidFill>
-                  <a:srgbClr val="222222"/>
-                </a:solidFill>
-                <a:latin typeface="Amiri"/>
-                <a:ea typeface="Amiri"/>
-                <a:cs typeface="Amiri"/>
-              </a:rPr>
-              <a:t>المنهج: وصفي مقارن، استقرائي، استنباطي</a:t>
+              <a:t>تُوزن وسائل الزينة المعاصرة بثلاث علل: تغيير خلق الله، والتدليس، والضرر؛ فمتى تحققت إحداها امتنع الفعل، ومتى انتفت جاز. ومن هنا يُفهم حكم النمص والوشم والتشقير والوصل والعدسات، ويبقى المنهج وصفيًا مقارنًا استقرائيًا استنباطيًا.</a:t>
             </a:r>
           </a:p>
         </p:txBody>
@@ -7329,6 +7189,7 @@
         </p:nvPicPr>
         <p:blipFill>
           <a:blip r:embed="rId2"/>
+          <a:srcRect r="93302"/>
           <a:stretch>
             <a:fillRect/>
           </a:stretch>
@@ -7733,6 +7594,7 @@
         </p:nvPicPr>
         <p:blipFill>
           <a:blip r:embed="rId2"/>
+          <a:srcRect r="93302"/>
           <a:stretch>
             <a:fillRect/>
           </a:stretch>
@@ -8033,7 +7895,7 @@
                 <a:ea typeface="Amiri"/>
                 <a:cs typeface="Amiri"/>
               </a:rPr>
-              <a:t>الجواز مشروط بالحاجة الشرعية (علاج، إصلاح عيب)</a:t>
+              <a:t>الجواز مشروط بالحاجة الشرعية كالعلاج وإصلاح العيب</a:t>
             </a:r>
           </a:p>
           <a:p>
@@ -8116,6 +7978,7 @@
         </p:nvPicPr>
         <p:blipFill>
           <a:blip r:embed="rId2"/>
+          <a:srcRect r="93302"/>
           <a:stretch>
             <a:fillRect/>
           </a:stretch>
@@ -8437,7 +8300,7 @@
                 <a:ea typeface="Amiri"/>
                 <a:cs typeface="Amiri"/>
               </a:rPr>
-              <a:t>تفصيل المذاهب (المالكية والشافعية والحنابلة) في أثرها على النظر والخيار</a:t>
+              <a:t>تفصيل المذاهب في أثرها على النظر والخيار</a:t>
             </a:r>
           </a:p>
         </p:txBody>
@@ -8478,6 +8341,7 @@
         </p:nvPicPr>
         <p:blipFill>
           <a:blip r:embed="rId2"/>
+          <a:srcRect r="93302"/>
           <a:stretch>
             <a:fillRect/>
           </a:stretch>
@@ -8882,6 +8746,7 @@
         </p:nvPicPr>
         <p:blipFill>
           <a:blip r:embed="rId2"/>
+          <a:srcRect r="93302"/>
           <a:stretch>
             <a:fillRect/>
           </a:stretch>
@@ -9286,6 +9151,7 @@
         </p:nvPicPr>
         <p:blipFill>
           <a:blip r:embed="rId2"/>
+          <a:srcRect r="93302"/>
           <a:stretch>
             <a:fillRect/>
           </a:stretch>
@@ -9711,6 +9577,7 @@
         </p:nvPicPr>
         <p:blipFill>
           <a:blip r:embed="rId2"/>
+          <a:srcRect r="93302"/>
           <a:stretch>
             <a:fillRect/>
           </a:stretch>

</xml_diff>

<commit_message>
v5: sanitizer harakat + layout kaya (dashboard rounded) + akumulasi riset
- 02: F2 akumulasi pengetahuan (riset didokumentasikan, distil, kontradiksi diputuskan;
  diterima dgn penyaring); G aturan bahasa/harakat (strip tashkeel, utamakan verbatim,
  tinjauan penutur asli utk deck berisiko); H library layout kaya (dashboard/KPI,
  multi-kolom, gambar+teks, alur, rounded).
- build_deck_v5.py: sanitizer tashkeel otomatis; slide metode jadi DASHBOARD 3 kartu
  ROUNDED_RECTANGLE (multi-objek); aspect-band & bebas-kurung dipertahankan.
- Verifikasi: 0 tashkeel, 3 kartu roundRect di S9, 14 slide.

Co-authored-by: arena-agent <297053741+arena-agent@users.noreply.github.com>
</commit_message>
<xml_diff>
--- a/sistem-presentasi/deck-aktif/presentasi-tesis-fikih-hiasan-wanita/keluaran/presentasi-tesis-fikih-hiasan-wanita.pptx
+++ b/sistem-presentasi/deck-aktif/presentasi-tesis-fikih-hiasan-wanita/keluaran/presentasi-tesis-fikih-hiasan-wanita.pptx
@@ -725,7 +725,7 @@
           <a:lstStyle/>
           <a:p>
             <a:r>
-              <a:t>Kesimpulan sebagai PARAGRAF; خاتمة hal 151 = doa.</a:t>
+              <a:t>Kesimpulan paragraf.</a:t>
             </a:r>
           </a:p>
         </p:txBody>
@@ -935,7 +935,7 @@
           <a:lstStyle/>
           <a:p>
             <a:r>
-              <a:t>Temuan utama hal 6 disajikan sebagai PARAGRAF ringkas (mode naratif).</a:t>
+              <a:t>Temuan utama hal 6 sebagai paragraf; harakat di-strip sanitizer.</a:t>
             </a:r>
           </a:p>
         </p:txBody>
@@ -1005,7 +1005,7 @@
           <a:lstStyle/>
           <a:p>
             <a:r>
-              <a:t>Hal 6: rincian per jenis.</a:t>
+              <a:t>Hal 6.</a:t>
             </a:r>
           </a:p>
         </p:txBody>
@@ -1425,7 +1425,7 @@
           <a:lstStyle/>
           <a:p>
             <a:r>
-              <a:t>Metode hal 23 + jenis hal 88.</a:t>
+              <a:t>Metode hal 23 sebagai dashboard 3 kartu rounded (multi-objek).</a:t>
             </a:r>
           </a:p>
         </p:txBody>
@@ -4691,7 +4691,7 @@
       </p:sp>
       <p:sp>
         <p:nvSpPr>
-          <p:cNvPr id="8" name="Rectangle 7"/>
+          <p:cNvPr id="8" name="Rounded Rectangle 7"/>
           <p:cNvSpPr/>
           <p:nvPr/>
         </p:nvSpPr>
@@ -4700,8 +4700,10 @@
             <a:off x="914400" y="1554480"/>
             <a:ext cx="9448495" cy="3108960"/>
           </a:xfrm>
-          <a:prstGeom prst="rect">
-            <a:avLst/>
+          <a:prstGeom prst="roundRect">
+            <a:avLst>
+              <a:gd name="adj" fmla="val 4000"/>
+            </a:avLst>
           </a:prstGeom>
           <a:noFill/>
           <a:ln w="25400">
@@ -4982,7 +4984,7 @@
                 <a:ea typeface="Amiri"/>
                 <a:cs typeface="Amiri"/>
               </a:rPr>
-              <a:t>جمعٌ ومعالجةٌ وتحقق: من التتبّع إلى التطبيق الموثّق</a:t>
+              <a:t>جمع ومعالجة وتحقق: من التتبع إلى التطبيق الموثق</a:t>
             </a:r>
           </a:p>
         </p:txBody>
@@ -5069,7 +5071,7 @@
                 <a:ea typeface="Amiri"/>
                 <a:cs typeface="Amiri"/>
               </a:rPr>
-              <a:t>جمع: تتبّع أقوال المذاهب وجمع النوازل ثم الترتيب والمقارنة</a:t>
+              <a:t>جمع: تتبع أقوال المذاهب وجمع النوازل ثم الترتيب والمقارنة</a:t>
             </a:r>
           </a:p>
           <a:p>
@@ -5569,7 +5571,7 @@
                           <a:ea typeface="Amiri"/>
                           <a:cs typeface="Amiri"/>
                         </a:rPr>
-                        <a:t>مركّبة: تغيير خلق الله والتدليس</a:t>
+                        <a:t>مركبة: تغيير خلق الله والتدليس</a:t>
                       </a:r>
                     </a:p>
                   </a:txBody>
@@ -5615,7 +5617,7 @@
                           <a:ea typeface="Amiri"/>
                           <a:cs typeface="Amiri"/>
                         </a:rPr>
-                        <a:t>مركّبة: الكرامة وتحريم استعمال النجس</a:t>
+                        <a:t>مركبة: الكرامة وتحريم استعمال النجس</a:t>
                       </a:r>
                     </a:p>
                   </a:txBody>
@@ -6059,7 +6061,7 @@
                 <a:ea typeface="Amiri"/>
                 <a:cs typeface="Amiri"/>
               </a:rPr>
-              <a:t>خلاصة البحث أن التحريم يدور مع علله الثلاث وجودًا وعدمًا، وأن العمليات تجوز للحاجة والوصل يجوز بغير شعر الآدمي بضوابطهما، وأن للزينة أثرًا يُرتَّب على النظر في عقد النكاح وفق المذاهب.</a:t>
+              <a:t>خلاصة البحث أن التحريم يدور مع علله الثلاث وجودا وعدما، وأن العمليات تجوز للحاجة والوصل يجوز بغير شعر الآدمي بضوابطهما، وأن للزينة أثرا يرتب على النظر في عقد النكاح وفق المذاهب.</a:t>
             </a:r>
           </a:p>
         </p:txBody>
@@ -6698,7 +6700,7 @@
                 <a:ea typeface="Amiri"/>
                 <a:cs typeface="Amiri"/>
               </a:rPr>
-              <a:t>الحمد لله؛ جهد بشري يقبل الخطأ، وسُئل الله القبول والنفع</a:t>
+              <a:t>الحمد لله؛ جهد بشري يقبل الخطأ، وسئل الله القبول والنفع</a:t>
             </a:r>
           </a:p>
         </p:txBody>
@@ -7148,7 +7150,7 @@
                 <a:ea typeface="Amiri"/>
                 <a:cs typeface="Amiri"/>
               </a:rPr>
-              <a:t>تُوزن وسائل الزينة المعاصرة بثلاث علل: تغيير خلق الله، والتدليس، والضرر؛ فمتى تحققت إحداها امتنع الفعل، ومتى انتفت جاز. ومن هنا يُفهم حكم النمص والوشم والتشقير والوصل والعدسات، ويبقى المنهج وصفيًا مقارنًا استقرائيًا استنباطيًا.</a:t>
+              <a:t>توزن وسائل الزينة المعاصرة بثلاث علل: تغيير خلق الله، والتدليس، والضرر؛ فمتى تحققت إحداها امتنع الفعل، ومتى انتفت جاز. ومن هنا يفهم حكم النمص والوشم والتشقير والوصل والعدسات، والمنهج وصفي مقارن استقرائي استنباطي.</a:t>
             </a:r>
           </a:p>
         </p:txBody>
@@ -7403,7 +7405,7 @@
                 <a:ea typeface="Amiri"/>
                 <a:cs typeface="Amiri"/>
               </a:rPr>
-              <a:t>لكل وسيلة زينة ضابطها: الامتناع عند قيام علة محرِّمة</a:t>
+              <a:t>لكل وسيلة زينة ضابطها: الامتناع عند قيام علة محرمة</a:t>
             </a:r>
           </a:p>
         </p:txBody>
@@ -7532,7 +7534,7 @@
                 <a:ea typeface="Amiri"/>
                 <a:cs typeface="Amiri"/>
               </a:rPr>
-              <a:t>العدسات والأظافر: تُوزن بضوابط التغيير والتدليس والضرر</a:t>
+              <a:t>العدسات والأظافر: توزن بضوابط التغيير والتدليس والضرر</a:t>
             </a:r>
           </a:p>
           <a:p>
@@ -7553,7 +7555,7 @@
                 <a:ea typeface="Amiri"/>
                 <a:cs typeface="Amiri"/>
               </a:rPr>
-              <a:t>الوصل: محرم، ويجوز بغير شعر الآدمي اتفاقًا</a:t>
+              <a:t>الوصل: محرم، ويجوز بغير شعر الآدمي اتفاقا</a:t>
             </a:r>
           </a:p>
         </p:txBody>
@@ -7937,7 +7939,7 @@
                 <a:ea typeface="Amiri"/>
                 <a:cs typeface="Amiri"/>
               </a:rPr>
-              <a:t>يُراعى انتفاء الضرر</a:t>
+              <a:t>يراعى انتفاء الضرر</a:t>
             </a:r>
           </a:p>
         </p:txBody>
@@ -8192,7 +8194,7 @@
                 <a:ea typeface="Amiri"/>
                 <a:cs typeface="Amiri"/>
               </a:rPr>
-              <a:t>للزينة أثر في النظر داخل عقد النكاح، وتُرتَّب أحكامها وفق المذاهب</a:t>
+              <a:t>للزينة أثر في النظر داخل عقد النكاح، وترتب أحكامها وفق المذاهب</a:t>
             </a:r>
           </a:p>
         </p:txBody>
@@ -8279,7 +8281,7 @@
                 <a:ea typeface="Amiri"/>
                 <a:cs typeface="Amiri"/>
               </a:rPr>
-              <a:t>الزينة المؤثرة على النظر تُرتَّب أحكامها في باب النكاح</a:t>
+              <a:t>الزينة المؤثرة على النظر ترتب أحكامها في باب النكاح</a:t>
             </a:r>
           </a:p>
           <a:p>
@@ -8960,7 +8962,7 @@
                 <a:ea typeface="Amiri"/>
                 <a:cs typeface="Amiri"/>
               </a:rPr>
-              <a:t>الفوائد توازي الأهداف وتعمّق إدراك الأحكام والنوازل</a:t>
+              <a:t>الفوائد توازي الأهداف وتعمق إدراك الأحكام والنوازل</a:t>
             </a:r>
           </a:p>
         </p:txBody>
@@ -9452,7 +9454,7 @@
                 <a:ea typeface="Amiri"/>
                 <a:cs typeface="Amiri"/>
               </a:rPr>
-              <a:t>نوازل معاصرة لم يفصّلها الفقهاء قديمًا</a:t>
+              <a:t>نوازل معاصرة لم يفصلها الفقهاء قديما</a:t>
             </a:r>
           </a:p>
           <a:p>
@@ -9841,24 +9843,45 @@
       </p:sp>
       <p:sp>
         <p:nvSpPr>
-          <p:cNvPr id="9" name="TextBox 8"/>
-          <p:cNvSpPr txBox="1"/>
-          <p:nvPr/>
-        </p:nvSpPr>
-        <p:spPr>
-          <a:xfrm>
-            <a:off x="822960" y="1828800"/>
-            <a:ext cx="10088575" cy="4206240"/>
-          </a:xfrm>
-          <a:prstGeom prst="rect">
-            <a:avLst/>
-          </a:prstGeom>
-          <a:noFill/>
-        </p:spPr>
-        <p:txBody>
-          <a:bodyPr wrap="square" anchor="ctr">
-            <a:spAutoFit/>
-          </a:bodyPr>
+          <p:cNvPr id="9" name="Rounded Rectangle 8"/>
+          <p:cNvSpPr/>
+          <p:nvPr/>
+        </p:nvSpPr>
+        <p:spPr>
+          <a:xfrm>
+            <a:off x="7731556" y="2194560"/>
+            <a:ext cx="3179978" cy="3108960"/>
+          </a:xfrm>
+          <a:prstGeom prst="roundRect">
+            <a:avLst>
+              <a:gd name="adj" fmla="val 6000"/>
+            </a:avLst>
+          </a:prstGeom>
+          <a:solidFill>
+            <a:srgbClr val="FFFFFF"/>
+          </a:solidFill>
+          <a:ln w="19050">
+            <a:solidFill>
+              <a:srgbClr val="C9A227"/>
+            </a:solidFill>
+          </a:ln>
+        </p:spPr>
+        <p:style>
+          <a:lnRef idx="1">
+            <a:schemeClr val="accent1"/>
+          </a:lnRef>
+          <a:fillRef idx="3">
+            <a:schemeClr val="accent1"/>
+          </a:fillRef>
+          <a:effectRef idx="2">
+            <a:schemeClr val="accent1"/>
+          </a:effectRef>
+          <a:fontRef idx="minor">
+            <a:schemeClr val="lt1"/>
+          </a:fontRef>
+        </p:style>
+        <p:txBody>
+          <a:bodyPr rtlCol="0" anchor="ctr" wrap="square" lIns="182880" rIns="182880"/>
           <a:lstStyle/>
           <a:p>
             <a:pPr algn="r" rtl="1">
@@ -9866,11 +9889,32 @@
                 <a:spcPct val="115000"/>
               </a:lnSpc>
               <a:spcAft>
-                <a:spcPts val="1400"/>
+                <a:spcPts val="1000"/>
               </a:spcAft>
             </a:pPr>
             <a:r>
-              <a:rPr sz="2400" b="0">
+              <a:rPr sz="2400" b="1">
+                <a:solidFill>
+                  <a:srgbClr val="0F3D2E"/>
+                </a:solidFill>
+                <a:latin typeface="Amiri"/>
+                <a:ea typeface="Amiri"/>
+                <a:cs typeface="Amiri"/>
+              </a:rPr>
+              <a:t>وصفي مقارن</a:t>
+            </a:r>
+          </a:p>
+          <a:p>
+            <a:pPr algn="r" rtl="1">
+              <a:lnSpc>
+                <a:spcPct val="120000"/>
+              </a:lnSpc>
+              <a:spcAft>
+                <a:spcPts val="0"/>
+              </a:spcAft>
+            </a:pPr>
+            <a:r>
+              <a:rPr sz="1600" b="0">
                 <a:solidFill>
                   <a:srgbClr val="222222"/>
                 </a:solidFill>
@@ -9878,20 +9922,85 @@
                 <a:ea typeface="Amiri"/>
                 <a:cs typeface="Amiri"/>
               </a:rPr>
-              <a:t>وصفي مقارن: تتبّع أقوال المذاهب من كتبها المعتمدة ومقارنتها</a:t>
-            </a:r>
-          </a:p>
+              <a:t>تتبع أقوال المذاهب من كتبها المعتمدة ومقارنتها</a:t>
+            </a:r>
+          </a:p>
+        </p:txBody>
+      </p:sp>
+      <p:sp>
+        <p:nvSpPr>
+          <p:cNvPr id="10" name="Rounded Rectangle 9"/>
+          <p:cNvSpPr/>
+          <p:nvPr/>
+        </p:nvSpPr>
+        <p:spPr>
+          <a:xfrm>
+            <a:off x="4277258" y="2194560"/>
+            <a:ext cx="3179978" cy="3108960"/>
+          </a:xfrm>
+          <a:prstGeom prst="roundRect">
+            <a:avLst>
+              <a:gd name="adj" fmla="val 6000"/>
+            </a:avLst>
+          </a:prstGeom>
+          <a:solidFill>
+            <a:srgbClr val="FFFFFF"/>
+          </a:solidFill>
+          <a:ln w="19050">
+            <a:solidFill>
+              <a:srgbClr val="C9A227"/>
+            </a:solidFill>
+          </a:ln>
+        </p:spPr>
+        <p:style>
+          <a:lnRef idx="1">
+            <a:schemeClr val="accent1"/>
+          </a:lnRef>
+          <a:fillRef idx="3">
+            <a:schemeClr val="accent1"/>
+          </a:fillRef>
+          <a:effectRef idx="2">
+            <a:schemeClr val="accent1"/>
+          </a:effectRef>
+          <a:fontRef idx="minor">
+            <a:schemeClr val="lt1"/>
+          </a:fontRef>
+        </p:style>
+        <p:txBody>
+          <a:bodyPr rtlCol="0" anchor="ctr" wrap="square" lIns="182880" rIns="182880"/>
+          <a:lstStyle/>
           <a:p>
             <a:pPr algn="r" rtl="1">
               <a:lnSpc>
                 <a:spcPct val="115000"/>
               </a:lnSpc>
               <a:spcAft>
-                <a:spcPts val="1400"/>
+                <a:spcPts val="1000"/>
               </a:spcAft>
             </a:pPr>
             <a:r>
-              <a:rPr sz="2400" b="0">
+              <a:rPr sz="2400" b="1">
+                <a:solidFill>
+                  <a:srgbClr val="0F3D2E"/>
+                </a:solidFill>
+                <a:latin typeface="Amiri"/>
+                <a:ea typeface="Amiri"/>
+                <a:cs typeface="Amiri"/>
+              </a:rPr>
+              <a:t>استقرائي</a:t>
+            </a:r>
+          </a:p>
+          <a:p>
+            <a:pPr algn="r" rtl="1">
+              <a:lnSpc>
+                <a:spcPct val="120000"/>
+              </a:lnSpc>
+              <a:spcAft>
+                <a:spcPts val="0"/>
+              </a:spcAft>
+            </a:pPr>
+            <a:r>
+              <a:rPr sz="1600" b="0">
                 <a:solidFill>
                   <a:srgbClr val="222222"/>
                 </a:solidFill>
@@ -9899,20 +10008,85 @@
                 <a:ea typeface="Amiri"/>
                 <a:cs typeface="Amiri"/>
               </a:rPr>
-              <a:t>استقرائي: استقراء النوازل والدراسات المعاصرة</a:t>
-            </a:r>
-          </a:p>
+              <a:t>استقراء النوازل والدراسات المعاصرة</a:t>
+            </a:r>
+          </a:p>
+        </p:txBody>
+      </p:sp>
+      <p:sp>
+        <p:nvSpPr>
+          <p:cNvPr id="11" name="Rounded Rectangle 10"/>
+          <p:cNvSpPr/>
+          <p:nvPr/>
+        </p:nvSpPr>
+        <p:spPr>
+          <a:xfrm>
+            <a:off x="822959" y="2194560"/>
+            <a:ext cx="3179978" cy="3108960"/>
+          </a:xfrm>
+          <a:prstGeom prst="roundRect">
+            <a:avLst>
+              <a:gd name="adj" fmla="val 6000"/>
+            </a:avLst>
+          </a:prstGeom>
+          <a:solidFill>
+            <a:srgbClr val="FFFFFF"/>
+          </a:solidFill>
+          <a:ln w="19050">
+            <a:solidFill>
+              <a:srgbClr val="C9A227"/>
+            </a:solidFill>
+          </a:ln>
+        </p:spPr>
+        <p:style>
+          <a:lnRef idx="1">
+            <a:schemeClr val="accent1"/>
+          </a:lnRef>
+          <a:fillRef idx="3">
+            <a:schemeClr val="accent1"/>
+          </a:fillRef>
+          <a:effectRef idx="2">
+            <a:schemeClr val="accent1"/>
+          </a:effectRef>
+          <a:fontRef idx="minor">
+            <a:schemeClr val="lt1"/>
+          </a:fontRef>
+        </p:style>
+        <p:txBody>
+          <a:bodyPr rtlCol="0" anchor="ctr" wrap="square" lIns="182880" rIns="182880"/>
+          <a:lstStyle/>
           <a:p>
             <a:pPr algn="r" rtl="1">
               <a:lnSpc>
                 <a:spcPct val="115000"/>
               </a:lnSpc>
               <a:spcAft>
-                <a:spcPts val="1400"/>
+                <a:spcPts val="1000"/>
               </a:spcAft>
             </a:pPr>
             <a:r>
-              <a:rPr sz="2400" b="0">
+              <a:rPr sz="2400" b="1">
+                <a:solidFill>
+                  <a:srgbClr val="0F3D2E"/>
+                </a:solidFill>
+                <a:latin typeface="Amiri"/>
+                <a:ea typeface="Amiri"/>
+                <a:cs typeface="Amiri"/>
+              </a:rPr>
+              <a:t>استنباطي</a:t>
+            </a:r>
+          </a:p>
+          <a:p>
+            <a:pPr algn="r" rtl="1">
+              <a:lnSpc>
+                <a:spcPct val="120000"/>
+              </a:lnSpc>
+              <a:spcAft>
+                <a:spcPts val="0"/>
+              </a:spcAft>
+            </a:pPr>
+            <a:r>
+              <a:rPr sz="1600" b="0">
                 <a:solidFill>
                   <a:srgbClr val="222222"/>
                 </a:solidFill>
@@ -9920,7 +10094,7 @@
                 <a:ea typeface="Amiri"/>
                 <a:cs typeface="Amiri"/>
               </a:rPr>
-              <a:t>استنباطي: استنباط الحكم من النصوص والقواعد والضوابط</a:t>
+              <a:t>استنباط الحكم من النصوص والقواعد والضوابط</a:t>
             </a:r>
           </a:p>
         </p:txBody>

</xml_diff>

<commit_message>
Perbaiki kompetensi bahasa Arab (bukan soal harakat): idiom benar + aturan G diperkuat
Koreksi isi: 'سُئل الله القبول'->'نسأل الله القبول'; 'تُرتَّب أحكامها'->'تترتب على ...
أحكام'; 'توزن'->'تُقاس'; 'تدور على'->'تدور حول'. Aturan 02.G di-reframe: inti masalah
kompetensi, bukan harakat; minimalkan karangan bebas (utamakan verbatim), tinjauan
penutur asli = gerbang WAJIB sebelum G3 utk bahasa non-default, agent tak boleh
sertifikasi bahasanya sendiri.

Co-authored-by: arena-agent <297053741+arena-agent@users.noreply.github.com>
</commit_message>
<xml_diff>
--- a/sistem-presentasi/deck-aktif/presentasi-tesis-fikih-hiasan-wanita/keluaran/presentasi-tesis-fikih-hiasan-wanita.pptx
+++ b/sistem-presentasi/deck-aktif/presentasi-tesis-fikih-hiasan-wanita/keluaran/presentasi-tesis-fikih-hiasan-wanita.pptx
@@ -6061,7 +6061,7 @@
                 <a:ea typeface="Amiri"/>
                 <a:cs typeface="Amiri"/>
               </a:rPr>
-              <a:t>خلاصة البحث أن التحريم يدور مع علله الثلاث وجودا وعدما، وأن العمليات تجوز للحاجة والوصل يجوز بغير شعر الآدمي بضوابطهما، وأن للزينة أثرا يرتب على النظر في عقد النكاح وفق المذاهب.</a:t>
+              <a:t>خلاصة البحث أن التحريم يدور مع علله الثلاث وجودا وعدما، وأن العمليات تجوز للحاجة والوصل يجوز بغير شعر الآدمي بضوابطهما، وأن للزينة أثرا في النظر تترتب عليه أحكام في عقد النكاح وفق المذاهب.</a:t>
             </a:r>
           </a:p>
         </p:txBody>
@@ -6700,7 +6700,7 @@
                 <a:ea typeface="Amiri"/>
                 <a:cs typeface="Amiri"/>
               </a:rPr>
-              <a:t>الحمد لله؛ جهد بشري يقبل الخطأ، وسئل الله القبول والنفع</a:t>
+              <a:t>الحمد لله؛ جهد بشري يقبل الخطأ، ونسأل الله القبول والنفع</a:t>
             </a:r>
           </a:p>
         </p:txBody>
@@ -6808,7 +6808,7 @@
                 <a:ea typeface="Amiri"/>
                 <a:cs typeface="Amiri"/>
               </a:rPr>
-              <a:t>سؤال الله القبول والنفع به</a:t>
+              <a:t>نسأل الله القبول والنفع به</a:t>
             </a:r>
           </a:p>
         </p:txBody>
@@ -7063,7 +7063,7 @@
                 <a:ea typeface="Amiri"/>
                 <a:cs typeface="Amiri"/>
               </a:rPr>
-              <a:t>تدور أحكام الزينة المعاصرة على ثلاث علل: تغيير خلق الله، التدليس، والضرر</a:t>
+              <a:t>تدور أحكام الزينة المعاصرة حول ثلاث علل: تغيير خلق الله، والتدليس، والضرر</a:t>
             </a:r>
           </a:p>
         </p:txBody>
@@ -7150,7 +7150,7 @@
                 <a:ea typeface="Amiri"/>
                 <a:cs typeface="Amiri"/>
               </a:rPr>
-              <a:t>توزن وسائل الزينة المعاصرة بثلاث علل: تغيير خلق الله، والتدليس، والضرر؛ فمتى تحققت إحداها امتنع الفعل، ومتى انتفت جاز. ومن هنا يفهم حكم النمص والوشم والتشقير والوصل والعدسات، والمنهج وصفي مقارن استقرائي استنباطي.</a:t>
+              <a:t>تقاس وسائل الزينة المعاصرة بثلاث علل: تغيير خلق الله، والتدليس، والضرر؛ فمتى تحققت إحداها امتنع الفعل، ومتى انتفت جاز. ومن هنا يعلم حكم النمص والوشم والتشقير والوصل والعدسات، والمنهج وصفي مقارن استقرائي استنباطي.</a:t>
             </a:r>
           </a:p>
         </p:txBody>
@@ -7534,7 +7534,7 @@
                 <a:ea typeface="Amiri"/>
                 <a:cs typeface="Amiri"/>
               </a:rPr>
-              <a:t>العدسات والأظافر: توزن بضوابط التغيير والتدليس والضرر</a:t>
+              <a:t>العدسات والأظافر: تقاس بضوابط التغيير والتدليس والضرر</a:t>
             </a:r>
           </a:p>
           <a:p>
@@ -8194,7 +8194,7 @@
                 <a:ea typeface="Amiri"/>
                 <a:cs typeface="Amiri"/>
               </a:rPr>
-              <a:t>للزينة أثر في النظر داخل عقد النكاح، وترتب أحكامها وفق المذاهب</a:t>
+              <a:t>للزينة أثر في النظر داخل عقد النكاح، وتترتب عليه أحكام وفق المذاهب</a:t>
             </a:r>
           </a:p>
         </p:txBody>
@@ -8281,7 +8281,7 @@
                 <a:ea typeface="Amiri"/>
                 <a:cs typeface="Amiri"/>
               </a:rPr>
-              <a:t>الزينة المؤثرة على النظر ترتب أحكامها في باب النكاح</a:t>
+              <a:t>تترتب على الزينة المؤثرة على النظر أحكام في باب النكاح</a:t>
             </a:r>
           </a:p>
           <a:p>

</xml_diff>

<commit_message>
v7: isi slide diperpanjang sesuai tesis (hal 6/23/88/89 via visi); QA exit 0
Co-authored-by: arena-agent <297053741+arena-agent@users.noreply.github.com>
</commit_message>
<xml_diff>
--- a/sistem-presentasi/deck-aktif/presentasi-tesis-fikih-hiasan-wanita/keluaran/presentasi-tesis-fikih-hiasan-wanita.pptx
+++ b/sistem-presentasi/deck-aktif/presentasi-tesis-fikih-hiasan-wanita/keluaran/presentasi-tesis-fikih-hiasan-wanita.pptx
@@ -585,7 +585,7 @@
           <a:lstStyle/>
           <a:p>
             <a:r>
-              <a:t>جمع hal 89 (Far'2).</a:t>
+              <a:t>جمع hal 89 diperpanjang.</a:t>
             </a:r>
           </a:p>
         </p:txBody>
@@ -655,7 +655,7 @@
           <a:lstStyle/>
           <a:p>
             <a:r>
-              <a:t>معالجة hal 89 (Far'3).</a:t>
+              <a:t>معالجة hal 89 diperpanjang.</a:t>
             </a:r>
           </a:p>
         </p:txBody>
@@ -725,7 +725,7 @@
           <a:lstStyle/>
           <a:p>
             <a:r>
-              <a:t>تحقق hal 89 (Far'4).</a:t>
+              <a:t>تحقق hal 89 diperpanjang.</a:t>
             </a:r>
           </a:p>
         </p:txBody>
@@ -935,7 +935,7 @@
           <a:lstStyle/>
           <a:p>
             <a:r>
-              <a:t>ملخص hal 6, satu slide sesuai permintaan pemilik.</a:t>
+              <a:t>ملخص hal 6 diperpanjang sesuai isi tesis.</a:t>
             </a:r>
           </a:p>
         </p:txBody>
@@ -1215,7 +1215,7 @@
           <a:lstStyle/>
           <a:p>
             <a:r>
-              <a:t>منهج hal 23.</a:t>
+              <a:t>منهج hal 23 diperpanjang.</a:t>
             </a:r>
           </a:p>
         </p:txBody>
@@ -1425,7 +1425,7 @@
           <a:lstStyle/>
           <a:p>
             <a:r>
-              <a:t>جنس ونوع hal 88 (Bab3 Far'1).</a:t>
+              <a:t>جنس ونوع hal 88 diperpanjang.</a:t>
             </a:r>
           </a:p>
         </p:txBody>
@@ -5050,7 +5050,7 @@
               </a:spcAft>
             </a:pPr>
             <a:r>
-              <a:rPr sz="2400" b="0">
+              <a:rPr sz="2000" b="0">
                 <a:solidFill>
                   <a:srgbClr val="222222"/>
                 </a:solidFill>
@@ -5058,7 +5058,7 @@
                 <a:ea typeface="Amiri"/>
                 <a:cs typeface="Amiri"/>
               </a:rPr>
-              <a:t>تتبع أقوال المذاهب في كتب الفقه المعتمدة</a:t>
+              <a:t>تتبع آراء الفقهاء في المذاهب الأربعة واستقراؤها والاطلاع على المسائل المتعلقة بالزينة</a:t>
             </a:r>
           </a:p>
           <a:p>
@@ -5071,7 +5071,7 @@
               </a:spcAft>
             </a:pPr>
             <a:r>
-              <a:rPr sz="2400" b="0">
+              <a:rPr sz="2000" b="0">
                 <a:solidFill>
                   <a:srgbClr val="222222"/>
                 </a:solidFill>
@@ -5079,7 +5079,7 @@
                 <a:ea typeface="Amiri"/>
                 <a:cs typeface="Amiri"/>
               </a:rPr>
-              <a:t>جمع النوازل والدراسات المعاصرة</a:t>
+              <a:t>تتبع محال ذكرها في أبواب كثيرة: اللباس، النفقات، العيدين، الجمعة، الجنائز، ستر العورة، ووصل الشعر وغيره</a:t>
             </a:r>
           </a:p>
           <a:p>
@@ -5092,7 +5092,7 @@
               </a:spcAft>
             </a:pPr>
             <a:r>
-              <a:rPr sz="2400" b="0">
+              <a:rPr sz="2000" b="0">
                 <a:solidFill>
                   <a:srgbClr val="222222"/>
                 </a:solidFill>
@@ -5100,7 +5100,7 @@
                 <a:ea typeface="Amiri"/>
                 <a:cs typeface="Amiri"/>
               </a:rPr>
-              <a:t>ترتيب المعلومات ومقارنتها</a:t>
+              <a:t>الاطلاع على البحوث والدراسات وكتب الفتاوى، ثم ترتيب المعلومات وإلحاق المسائل المعاصرة بأحكامها، مرجحا قولا على قول</a:t>
             </a:r>
           </a:p>
         </p:txBody>
@@ -5434,7 +5434,7 @@
               </a:spcAft>
             </a:pPr>
             <a:r>
-              <a:rPr sz="2400" b="0">
+              <a:rPr sz="2000" b="0">
                 <a:solidFill>
                   <a:srgbClr val="222222"/>
                 </a:solidFill>
@@ -5442,7 +5442,7 @@
                 <a:ea typeface="Amiri"/>
                 <a:cs typeface="Amiri"/>
               </a:rPr>
-              <a:t>مقارنة أقوال الفقهاء وذكر أدلتهم</a:t>
+              <a:t>بعد الاطلاع على كتب الفقه والفتاوى والتفسير والحديث وشروحه ومعاجم اللغة، والمقارنة بين آراء المذاهب</a:t>
             </a:r>
           </a:p>
           <a:p>
@@ -5455,7 +5455,7 @@
               </a:spcAft>
             </a:pPr>
             <a:r>
-              <a:rPr sz="2400" b="0">
+              <a:rPr sz="2000" b="0">
                 <a:solidFill>
                   <a:srgbClr val="222222"/>
                 </a:solidFill>
@@ -5463,7 +5463,28 @@
                 <a:ea typeface="Amiri"/>
                 <a:cs typeface="Amiri"/>
               </a:rPr>
-              <a:t>تطبيق النصوص المعتمدة على النوازل المعاصرة</a:t>
+              <a:t>ذكر الأدلة ومناقشتها مع ترجيح الراجح، وإلحاق المسائل المعاصرة بأصولها المنصوص عليها</a:t>
+            </a:r>
+          </a:p>
+          <a:p>
+            <a:pPr algn="r" rtl="1">
+              <a:lnSpc>
+                <a:spcPct val="115000"/>
+              </a:lnSpc>
+              <a:spcAft>
+                <a:spcPts val="1400"/>
+              </a:spcAft>
+            </a:pPr>
+            <a:r>
+              <a:rPr sz="2000" b="0">
+                <a:solidFill>
+                  <a:srgbClr val="222222"/>
+                </a:solidFill>
+                <a:latin typeface="Amiri"/>
+                <a:ea typeface="Amiri"/>
+                <a:cs typeface="Amiri"/>
+              </a:rPr>
+              <a:t>الاعتماد على نصوص الفقهاء في كتبهم المعتمدة: فقهية أو حديثية أو تفسيرية أو فتاوى</a:t>
             </a:r>
           </a:p>
         </p:txBody>
@@ -5805,7 +5826,7 @@
                 <a:ea typeface="Amiri"/>
                 <a:cs typeface="Amiri"/>
               </a:rPr>
-              <a:t>عرض المعلومة على عدة مصادر مختلفة</a:t>
+              <a:t>تحقق الباحث من المعلومات المأخوذة بعرضها على عدة كتب ومصادر مختلفة</a:t>
             </a:r>
           </a:p>
           <a:p>
@@ -5826,7 +5847,7 @@
                 <a:ea typeface="Amiri"/>
                 <a:cs typeface="Amiri"/>
               </a:rPr>
-              <a:t>اعتمادها عند اتفاق المعنى وإن اختلفت الألفاظ</a:t>
+              <a:t>اعتمادها عند التوصل إلى الاتفاق في المعنى وإن اختلفت الألفاظ</a:t>
             </a:r>
           </a:p>
         </p:txBody>
@@ -6905,8 +6926,8 @@
         </p:nvSpPr>
         <p:spPr>
           <a:xfrm>
-            <a:off x="822960" y="1920240"/>
-            <a:ext cx="10088575" cy="4023360"/>
+            <a:off x="822960" y="1828800"/>
+            <a:ext cx="10088575" cy="4206240"/>
           </a:xfrm>
           <a:prstGeom prst="rect">
             <a:avLst/>
@@ -6921,14 +6942,14 @@
           <a:p>
             <a:pPr algn="r" rtl="1">
               <a:lnSpc>
-                <a:spcPct val="140000"/>
+                <a:spcPct val="115000"/>
               </a:lnSpc>
               <a:spcAft>
-                <a:spcPts val="0"/>
+                <a:spcPts val="1400"/>
               </a:spcAft>
             </a:pPr>
             <a:r>
-              <a:rPr sz="2400" b="0">
+              <a:rPr sz="1900" b="0">
                 <a:solidFill>
                   <a:srgbClr val="222222"/>
                 </a:solidFill>
@@ -6936,7 +6957,112 @@
                 <a:ea typeface="Amiri"/>
                 <a:cs typeface="Amiri"/>
               </a:rPr>
-              <a:t>يبين البحث أحكام النوازل الفقهية المعاصرة المتعلقة بزينة المرأة - من التشقير إلى الوصل والعمليات - في المذاهب الأربعة، بمنهج وصفي مقارن استقرائي استنباطي؛ فالأصل التحريم عند تغيير خلق الله أو التدليس أو الضرر، والجواز بضوابطها، وللزينة أثر في عقد النكاح.</a:t>
+              <a:t>يتناول البحث النوازل المتعلقة بزينة المرأة: التشقير، الأظافر، الحواجب، عدسات العين، النمص، الوشم، الوصل، الباروكة، العمليات الجراحية، مساحيق الوجه وغيرها</a:t>
+            </a:r>
+          </a:p>
+          <a:p>
+            <a:pPr algn="r" rtl="1">
+              <a:lnSpc>
+                <a:spcPct val="115000"/>
+              </a:lnSpc>
+              <a:spcAft>
+                <a:spcPts val="1400"/>
+              </a:spcAft>
+            </a:pPr>
+            <a:r>
+              <a:rPr sz="1900" b="0">
+                <a:solidFill>
+                  <a:srgbClr val="222222"/>
+                </a:solidFill>
+                <a:latin typeface="Amiri"/>
+                <a:ea typeface="Amiri"/>
+                <a:cs typeface="Amiri"/>
+              </a:rPr>
+              <a:t>المنهج: وصفي مقارن، استقرائي، استنباطي</a:t>
+            </a:r>
+          </a:p>
+          <a:p>
+            <a:pPr algn="r" rtl="1">
+              <a:lnSpc>
+                <a:spcPct val="115000"/>
+              </a:lnSpc>
+              <a:spcAft>
+                <a:spcPts val="1400"/>
+              </a:spcAft>
+            </a:pPr>
+            <a:r>
+              <a:rPr sz="1900" b="0">
+                <a:solidFill>
+                  <a:srgbClr val="222222"/>
+                </a:solidFill>
+                <a:latin typeface="Amiri"/>
+                <a:ea typeface="Amiri"/>
+                <a:cs typeface="Amiri"/>
+              </a:rPr>
+              <a:t>الأصل التحريم عند تغيير خلق الله أو التغرير أو التدليس أو الضرر، أو نص الشارع</a:t>
+            </a:r>
+          </a:p>
+          <a:p>
+            <a:pPr algn="r" rtl="1">
+              <a:lnSpc>
+                <a:spcPct val="115000"/>
+              </a:lnSpc>
+              <a:spcAft>
+                <a:spcPts val="1400"/>
+              </a:spcAft>
+            </a:pPr>
+            <a:r>
+              <a:rPr sz="1900" b="0">
+                <a:solidFill>
+                  <a:srgbClr val="222222"/>
+                </a:solidFill>
+                <a:latin typeface="Amiri"/>
+                <a:ea typeface="Amiri"/>
+                <a:cs typeface="Amiri"/>
+              </a:rPr>
+              <a:t>التشقير إن لم يزل الشعر فليس كالنمص؛ والوشم والعدسات والأظافر تجوز للحاجة لا للتغرير</a:t>
+            </a:r>
+          </a:p>
+          <a:p>
+            <a:pPr algn="r" rtl="1">
+              <a:lnSpc>
+                <a:spcPct val="115000"/>
+              </a:lnSpc>
+              <a:spcAft>
+                <a:spcPts val="1400"/>
+              </a:spcAft>
+            </a:pPr>
+            <a:r>
+              <a:rPr sz="1900" b="0">
+                <a:solidFill>
+                  <a:srgbClr val="222222"/>
+                </a:solidFill>
+                <a:latin typeface="Amiri"/>
+                <a:ea typeface="Amiri"/>
+                <a:cs typeface="Amiri"/>
+              </a:rPr>
+              <a:t>الوصل ليس منه إن كان لحاجة ويحرم للتغرير؛ وتحمير الوجه يحرم على الخلية عند الشافعية</a:t>
+            </a:r>
+          </a:p>
+          <a:p>
+            <a:pPr algn="r" rtl="1">
+              <a:lnSpc>
+                <a:spcPct val="115000"/>
+              </a:lnSpc>
+              <a:spcAft>
+                <a:spcPts val="1400"/>
+              </a:spcAft>
+            </a:pPr>
+            <a:r>
+              <a:rPr sz="1900" b="0">
+                <a:solidFill>
+                  <a:srgbClr val="222222"/>
+                </a:solidFill>
+                <a:latin typeface="Amiri"/>
+                <a:ea typeface="Amiri"/>
+                <a:cs typeface="Amiri"/>
+              </a:rPr>
+              <a:t>العمليات تجوز للحاجة دون تغيير الخلق؛ وللزينة أثر في خيار النكاح</a:t>
             </a:r>
           </a:p>
         </p:txBody>
@@ -8527,7 +8653,7 @@
               </a:spcAft>
             </a:pPr>
             <a:r>
-              <a:rPr sz="2400" b="0">
+              <a:rPr sz="2000" b="0">
                 <a:solidFill>
                   <a:srgbClr val="222222"/>
                 </a:solidFill>
@@ -8535,7 +8661,7 @@
                 <a:ea typeface="Amiri"/>
                 <a:cs typeface="Amiri"/>
               </a:rPr>
-              <a:t>وصفي مقارن: تتبع أقوال المذاهب من كتبها المعتمدة ومقارنتها</a:t>
+              <a:t>وصفي مقارن: تتبع آراء الفقهاء في المذاهب الأربعة من كتبهم المعتمدة، مع الرجوع للمؤلفات الحديثة وكلام المعاصرين؛ فيصف النوازل ويشخصها ويقيسها على المنصوص لاستخراج حكمها</a:t>
             </a:r>
           </a:p>
           <a:p>
@@ -8548,7 +8674,7 @@
               </a:spcAft>
             </a:pPr>
             <a:r>
-              <a:rPr sz="2400" b="0">
+              <a:rPr sz="2000" b="0">
                 <a:solidFill>
                   <a:srgbClr val="222222"/>
                 </a:solidFill>
@@ -8556,7 +8682,7 @@
                 <a:ea typeface="Amiri"/>
                 <a:cs typeface="Amiri"/>
               </a:rPr>
-              <a:t>استقرائي: استقراء النوازل والدراسات المعاصرة</a:t>
+              <a:t>استقرائي: استقراء أحكام زينة المرأة الفقهية والطبية من كتب المذاهب القديمة والحديثة</a:t>
             </a:r>
           </a:p>
           <a:p>
@@ -8569,7 +8695,7 @@
               </a:spcAft>
             </a:pPr>
             <a:r>
-              <a:rPr sz="2400" b="0">
+              <a:rPr sz="2000" b="0">
                 <a:solidFill>
                   <a:srgbClr val="222222"/>
                 </a:solidFill>
@@ -8577,7 +8703,7 @@
                 <a:ea typeface="Amiri"/>
                 <a:cs typeface="Amiri"/>
               </a:rPr>
-              <a:t>استنباطي: استنباط الحكم من النصوص والقواعد والضوابط</a:t>
+              <a:t>استنباطي: استنباط الأحكام المتعلقة بزينة المرأة في المذاهب الأربعة</a:t>
             </a:r>
           </a:p>
         </p:txBody>
@@ -9901,7 +10027,7 @@
               </a:spcAft>
             </a:pPr>
             <a:r>
-              <a:rPr sz="2400" b="0">
+              <a:rPr sz="2000" b="0">
                 <a:solidFill>
                   <a:srgbClr val="222222"/>
                 </a:solidFill>
@@ -9909,7 +10035,7 @@
                 <a:ea typeface="Amiri"/>
                 <a:cs typeface="Amiri"/>
               </a:rPr>
-              <a:t>جنس البحث: فقهي مقارن بين المذاهب الأربعة</a:t>
+              <a:t>جنس البحث: فقهي مقارن؛ يتتبع آراء الفقهاء ويشخص النوازل ويقيسها على المسائل المنصوص عليها</a:t>
             </a:r>
           </a:p>
           <a:p>
@@ -9922,7 +10048,7 @@
               </a:spcAft>
             </a:pPr>
             <a:r>
-              <a:rPr sz="2400" b="0">
+              <a:rPr sz="2000" b="0">
                 <a:solidFill>
                   <a:srgbClr val="222222"/>
                 </a:solidFill>
@@ -9930,7 +10056,28 @@
                 <a:ea typeface="Amiri"/>
                 <a:cs typeface="Amiri"/>
               </a:rPr>
-              <a:t>نوعه: استقراء النوازل ثم استنباط الحكم من النصوص والقواعد</a:t>
+              <a:t>نوعه: استقرائي لاستخراج قواعد عامة تساعد على فهم النوازل؛ ثم استنباطي لتنزيل الأحكام على المسائل المعاصرة</a:t>
+            </a:r>
+          </a:p>
+          <a:p>
+            <a:pPr algn="r" rtl="1">
+              <a:lnSpc>
+                <a:spcPct val="115000"/>
+              </a:lnSpc>
+              <a:spcAft>
+                <a:spcPts val="1400"/>
+              </a:spcAft>
+            </a:pPr>
+            <a:r>
+              <a:rPr sz="2000" b="0">
+                <a:solidFill>
+                  <a:srgbClr val="222222"/>
+                </a:solidFill>
+                <a:latin typeface="Amiri"/>
+                <a:ea typeface="Amiri"/>
+                <a:cs typeface="Amiri"/>
+              </a:rPr>
+              <a:t>اختيرت المناهج لمناسبتها الموضوع، وللاطلاع على كتب الفقه والحديث والتفسير ومعاجم اللغة والدراسات المعاصرة</a:t>
             </a:r>
           </a:p>
         </p:txBody>

</xml_diff>